<commit_message>
Rename the migrated corpus from 'Commit' to 'dimut and Verint'
The corpus being copied to S3 is the imaging (dimut) and Verint call-recording
data, not something called 'Commit' as carried over from the source deck.
Renamed across all seven references: slide 2 card title and footnote, slide 6
tier card and footnote, slide 8 benefit, slide 9 timeline, slide 10
recommendation, plus the cover title and slide 6 headline.

Grew the slide 6 tier card to fit the longer term. Re-verified: 0 text
overflows, 78 adjacent bidi embedding pairs with 0 ordering violations.

Co-Authored-By: Claude Opus 5 <noreply@anthropic.com>
Claude-Session: https://claude.ai/code/session_01MZnQ3bUVeTyJdPFvjg3J88
</commit_message>
<xml_diff>
--- a/presentations/ecs-to-s3/Harel_ECS_to_S3_CIO.pptx
+++ b/presentations/ecs-to-s3/Harel_ECS_to_S3_CIO.pptx
@@ -3440,7 +3440,7 @@
                 <a:ea typeface="Calibri" pitchFamily="34" charset="-122"/>
                 <a:cs typeface="Calibri" pitchFamily="34" charset="-120"/>
               </a:rPr>
-              <a:t>‫העתקת מסמכי דימות ושיחות לענן‬</a:t>
+              <a:t>‫העתקת מסמכי דימות ו-‪Verint‬ לענן‬</a:t>
             </a:r>
             <a:endParaRPr lang="he-IL" sz="4000" dirty="0"/>
           </a:p>
@@ -4260,7 +4260,7 @@
                 <a:ea typeface="Calibri" pitchFamily="34" charset="-122"/>
                 <a:cs typeface="Calibri" pitchFamily="34" charset="-120"/>
               </a:rPr>
-              <a:t>‫אישור עקרוני להעתקת מסמכי ‪Commit‬ ל-‪AWS S3‬‬</a:t>
+              <a:t>‫אישור עקרוני להעתקת מסמכי דימות ו-‪Verint‬ ל-‪AWS S3‬‬</a:t>
             </a:r>
             <a:endParaRPr lang="he-IL" sz="1450" dirty="0"/>
           </a:p>
@@ -5298,7 +5298,7 @@
                 <a:ea typeface="Calibri" pitchFamily="34" charset="-122"/>
                 <a:cs typeface="Calibri" pitchFamily="34" charset="-120"/>
               </a:rPr>
-              <a:t>‫העתקת מסמכי ‪Commit‬ ל-‪AWS S3‬‬</a:t>
+              <a:t>‫העתקת מסמכי דימות ו-‪Verint‬ ל-‪AWS S3‬‬</a:t>
             </a:r>
             <a:endParaRPr lang="he-IL" sz="1650" dirty="0"/>
           </a:p>
@@ -5765,7 +5765,7 @@
                 <a:ea typeface="Calibri" pitchFamily="34" charset="-122"/>
                 <a:cs typeface="Calibri" pitchFamily="34" charset="-120"/>
               </a:rPr>
-              <a:t>‫אין צורך באישור תקציב סופי לרכש בישיבה זו. הנתון החסר להחלטה מלאה הוא גודל קורפוס ה-‪Commit‬ — כמה ‪TB‬ באמת יפונו.‬</a:t>
+              <a:t>‫אין צורך באישור תקציב סופי לרכש בישיבה זו. הנתון החסר להחלטה מלאה הוא גודל קורפוס הדימות ו-‪Verint‬ — כמה ‪TB‬ באמת יפונו.‬</a:t>
             </a:r>
             <a:endParaRPr lang="he-IL" sz="1150" dirty="0"/>
           </a:p>
@@ -8733,7 +8733,7 @@
                 <a:ea typeface="Calibri" pitchFamily="34" charset="-122"/>
                 <a:cs typeface="Calibri" pitchFamily="34" charset="-120"/>
               </a:rPr>
-              <a:t>‫השוואנו מול ‪S3 Standard‬ — אבל דימות ושיחות הם דאטה ארכיוני‬</a:t>
+              <a:t>‫השוואנו מול ‪S3 Standard‬ — אבל דימות ו-‪Verint‬ הם דאטה ארכיוני‬</a:t>
             </a:r>
             <a:endParaRPr lang="he-IL" sz="2500" dirty="0"/>
           </a:p>
@@ -9426,12 +9426,12 @@
         </p:nvSpPr>
         <p:spPr>
           <a:xfrm>
-            <a:off x="822960" y="2286000"/>
-            <a:ext cx="5212080" cy="1207008"/>
+            <a:off x="822960" y="2231136"/>
+            <a:ext cx="5212080" cy="1389888"/>
           </a:xfrm>
           <a:prstGeom prst="roundRect">
             <a:avLst>
-              <a:gd name="adj" fmla="val 3030"/>
+              <a:gd name="adj" fmla="val 2632"/>
             </a:avLst>
           </a:prstGeom>
           <a:solidFill>
@@ -9453,7 +9453,7 @@
         </p:nvSpPr>
         <p:spPr>
           <a:xfrm>
-            <a:off x="5532120" y="2578608"/>
+            <a:off x="5532120" y="2523744"/>
             <a:ext cx="118872" cy="118872"/>
           </a:xfrm>
           <a:prstGeom prst="rect">
@@ -9478,7 +9478,7 @@
         </p:nvSpPr>
         <p:spPr>
           <a:xfrm>
-            <a:off x="1133856" y="2523744"/>
+            <a:off x="1133856" y="2468880"/>
             <a:ext cx="4261104" cy="274320"/>
           </a:xfrm>
           <a:prstGeom prst="rect">
@@ -9520,8 +9520,8 @@
         </p:nvSpPr>
         <p:spPr>
           <a:xfrm>
-            <a:off x="1133856" y="2871216"/>
-            <a:ext cx="4590288" cy="365760"/>
+            <a:off x="1133856" y="2816352"/>
+            <a:ext cx="4590288" cy="548640"/>
           </a:xfrm>
           <a:prstGeom prst="rect">
             <a:avLst/>
@@ -9548,7 +9548,7 @@
                 <a:ea typeface="Calibri" pitchFamily="34" charset="-122"/>
                 <a:cs typeface="Calibri" pitchFamily="34" charset="-120"/>
               </a:rPr>
-              <a:t>‫מסמכי ‪Commit‬ נכתבים פעם אחת ונקראים לעיתים נדירות. ב-‪Glacier Instant Retrieval‬, בזמן אחזור של מילישניות, העלות יורדת לכ-‪$25K‬ — פי ‪4.6‬ זול מ-‪On-Prem‬, ולא יקר ממנו ב-‪30%‬.‬</a:t>
+              <a:t>‫מסמכי דימות ו-‪Verint‬ נכתבים פעם אחת ונקראים לעיתים נדירות. ב-‪Glacier Instant Retrieval‬, בזמן אחזור של מילישניות, העלות יורדת לכ-‪$25K‬ — פי ‪4.6‬ זול מ-‪On-Prem‬, ולא יקר ממנו ב-‪30%‬.‬</a:t>
             </a:r>
             <a:endParaRPr lang="he-IL" sz="1200" dirty="0"/>
           </a:p>
@@ -9562,7 +9562,7 @@
         </p:nvSpPr>
         <p:spPr>
           <a:xfrm>
-            <a:off x="822960" y="3712464"/>
+            <a:off x="822960" y="3785616"/>
             <a:ext cx="5212080" cy="1463040"/>
           </a:xfrm>
           <a:prstGeom prst="roundRect">
@@ -9589,7 +9589,7 @@
         </p:nvSpPr>
         <p:spPr>
           <a:xfrm>
-            <a:off x="5532120" y="4005072"/>
+            <a:off x="5532120" y="4078224"/>
             <a:ext cx="118872" cy="118872"/>
           </a:xfrm>
           <a:prstGeom prst="rect">
@@ -9614,7 +9614,7 @@
         </p:nvSpPr>
         <p:spPr>
           <a:xfrm>
-            <a:off x="1133856" y="3950208"/>
+            <a:off x="1133856" y="4023360"/>
             <a:ext cx="4261104" cy="274320"/>
           </a:xfrm>
           <a:prstGeom prst="rect">
@@ -9656,7 +9656,7 @@
         </p:nvSpPr>
         <p:spPr>
           <a:xfrm>
-            <a:off x="1133856" y="4297680"/>
+            <a:off x="1133856" y="4370832"/>
             <a:ext cx="4590288" cy="621792"/>
           </a:xfrm>
           <a:prstGeom prst="rect">
@@ -9776,7 +9776,7 @@
                 <a:ea typeface="Calibri" pitchFamily="34" charset="-122"/>
                 <a:cs typeface="Calibri" pitchFamily="34" charset="-120"/>
               </a:rPr>
-              <a:t>‫הנתון שחסר להכרעה: פילוח גודל-אובייקט ותדירות אחזור של קורפוס ה-‪Commit‬. הוא שקובע איזו שכבה נכונה, והוא אינו קיים היום. המחירים הם מחירון רשימה, ללא הנחות נפח או התחייבות.‬</a:t>
+              <a:t>‫הנתון שחסר להכרעה: פילוח גודל-אובייקט ותדירות אחזור של קורפוס הדימות ו-‪Verint‬. הוא שקובע איזו שכבה נכונה, והוא אינו קיים היום. המחירים הם מחירון רשימה, ללא הנחות נפח או התחייבות.‬</a:t>
             </a:r>
             <a:endParaRPr lang="he-IL" sz="1150" dirty="0"/>
           </a:p>
@@ -11504,7 +11504,7 @@
                 <a:ea typeface="Calibri" pitchFamily="34" charset="-122"/>
                 <a:cs typeface="Calibri" pitchFamily="34" charset="-120"/>
               </a:rPr>
-              <a:t>‫העתקת קורפוס ה-‪Commit‬ מפנה שטח ב-‪ECS‬ תוך שבועות. זו האפשרות היחידה שמשפיעה על הניצולת לפני דצמבר ‪2026‬.‬</a:t>
+              <a:t>‫העתקת קורפוס הדימות ו-‪Verint‬ מפנה שטח ב-‪ECS‬ תוך שבועות. זו האפשרות היחידה שמשפיעה על הניצולת לפני דצמבר ‪2026‬.‬</a:t>
             </a:r>
             <a:endParaRPr lang="he-IL" sz="1150" dirty="0"/>
           </a:p>
@@ -12598,7 +12598,7 @@
                 <a:ea typeface="Calibri" pitchFamily="34" charset="-122"/>
                 <a:cs typeface="Calibri" pitchFamily="34" charset="-120"/>
               </a:rPr>
-              <a:t>‫פילוח קורפוס ה-‪Commit‬‬</a:t>
+              <a:t>‫פילוח קורפוס הדימות ו-‪Verint‬‬</a:t>
             </a:r>
             <a:endParaRPr lang="he-IL" sz="1150" dirty="0"/>
           </a:p>

</xml_diff>

<commit_message>
Slide 5: drop the AWS S3 Standard option, keep S3 + API
The cost comparison now prices On-Prem against S3 + API only. Chart is down to
two bars, the per-TB rail reads $1,450-1,650, and the Dell advantage is
restated as 20%-30% (115.8/145 and 115.8/165) instead of the 16%-30% that was
computed across the wider $138K-165K range spanning both AWS options.

Slide 6's headline no longer claims the comparison was made against S3
Standard; it now says the pricing was done at the hot tier. The tier ladder
still lists S3 Standard, since that is the point of the slide.

Verified: 0 text overflows, 70 adjacent bidi embedding pairs with 0 ordering
violations, schema passes.

Co-Authored-By: Claude Opus 5 <noreply@anthropic.com>
Claude-Session: https://claude.ai/code/session_01MZnQ3bUVeTyJdPFvjg3J88
</commit_message>
<xml_diff>
--- a/presentations/ecs-to-s3/Harel_ECS_to_S3_CIO.pptx
+++ b/presentations/ecs-to-s3/Harel_ECS_to_S3_CIO.pptx
@@ -1268,30 +1268,16 @@
               <a:effectLst/>
             </c:spPr>
           </c:dPt>
-          <c:dPt>
-            <c:idx val="2"/>
-            <c:invertIfNegative val="0"/>
-            <c:bubble3D val="0"/>
-            <c:spPr>
-              <a:solidFill>
-                <a:srgbClr val="B07CFF"/>
-              </a:solidFill>
-              <a:effectLst/>
-            </c:spPr>
-          </c:dPt>
           <c:cat>
             <c:multiLvlStrRef>
-              <c:f>Sheet1!$A$2:$A$4</c:f>
+              <c:f>Sheet1!$A$2:$A$3</c:f>
               <c:multiLvlStrCache>
-                <c:ptCount val="3"/>
+                <c:ptCount val="2"/>
                 <c:lvl>
                   <c:pt idx="0">
                     <c:v>Dell ECS On-Prem</c:v>
                   </c:pt>
                   <c:pt idx="1">
-                    <c:v>AWS S3 Standard</c:v>
-                  </c:pt>
-                  <c:pt idx="2">
                     <c:v>AWS S3 + API</c:v>
                   </c:pt>
                 </c:lvl>
@@ -1300,17 +1286,14 @@
           </c:cat>
           <c:val>
             <c:numRef>
-              <c:f>Sheet1!$B$2:$B$4</c:f>
+              <c:f>Sheet1!$B$2:$B$3</c:f>
               <c:numCache>
                 <c:formatCode>General</c:formatCode>
-                <c:ptCount val="3"/>
+                <c:ptCount val="2"/>
                 <c:pt idx="0">
                   <c:v>115.8</c:v>
                 </c:pt>
                 <c:pt idx="1">
-                  <c:v>146.5</c:v>
-                </c:pt>
-                <c:pt idx="2">
                   <c:v>155</c:v>
                 </c:pt>
               </c:numCache>
@@ -1341,7 +1324,7 @@
           <c:showBubbleSize val="0"/>
           <c:showLeaderLines val="0"/>
         </c:dLbls>
-        <c:gapWidth val="120"/>
+        <c:gapWidth val="240"/>
         <c:overlap val="0"/>
         <c:axId val="2094734554"/>
         <c:axId val="2094734552"/>
@@ -8241,7 +8224,7 @@
               <a:buNone/>
             </a:pPr>
             <a:r>
-              <a:rPr lang="he-IL" altLang="en-US" sz="2400" b="1" dirty="0">
+              <a:rPr lang="he-IL" altLang="en-US" sz="2500" b="1" dirty="0">
                 <a:solidFill>
                   <a:srgbClr val="F4F7FB"/>
                 </a:solidFill>
@@ -8249,9 +8232,9 @@
                 <a:ea typeface="Calibri" pitchFamily="34" charset="-122"/>
                 <a:cs typeface="Calibri" pitchFamily="34" charset="-120"/>
               </a:rPr>
-              <a:t>‫‪100 TB‬ ל-‪5‬ שנים: ‪$116K‬ ב-‪On-Prem‬ מול ‪$138K–165K‬ ב-‪AWS S3 Standard‬‬</a:t>
-            </a:r>
-            <a:endParaRPr lang="he-IL" sz="2400" dirty="0"/>
+              <a:t>‫‪100 TB‬ ל-‪5‬ שנים: ‪$116K‬ ב-‪On-Prem‬ מול ‪$145K–165K‬ ב-‪AWS S3 + API‬‬</a:t>
+            </a:r>
+            <a:endParaRPr lang="he-IL" sz="2500" dirty="0"/>
           </a:p>
         </p:txBody>
       </p:sp>
@@ -8550,7 +8533,7 @@
                 <a:ea typeface="Calibri" pitchFamily="34" charset="-122"/>
                 <a:cs typeface="Calibri" pitchFamily="34" charset="-120"/>
               </a:rPr>
-              <a:t>$1,380–1,650</a:t>
+              <a:t>$1,450–1,650</a:t>
             </a:r>
             <a:endParaRPr lang="en-US" sz="2600" dirty="0"/>
           </a:p>
@@ -8592,7 +8575,7 @@
                 <a:ea typeface="Calibri" pitchFamily="34" charset="-122"/>
                 <a:cs typeface="Calibri" pitchFamily="34" charset="-120"/>
               </a:rPr>
-              <a:t>‫לכל ‪TB · AWS S3 Standard‬‬</a:t>
+              <a:t>‫לכל ‪TB · AWS S3 + API‬‬</a:t>
             </a:r>
             <a:endParaRPr lang="he-IL" sz="1050" dirty="0"/>
           </a:p>
@@ -8634,7 +8617,7 @@
                 <a:ea typeface="Calibri" pitchFamily="34" charset="-122"/>
                 <a:cs typeface="Calibri" pitchFamily="34" charset="-120"/>
               </a:rPr>
-              <a:t>‫עמידות מובנית, ללא כפל אחסון מצידנו‬</a:t>
+              <a:t>‫אחסון ופעילות שוטפת, ללא כפל אחסון מצידנו‬</a:t>
             </a:r>
             <a:endParaRPr lang="he-IL" sz="1100" dirty="0"/>
           </a:p>
@@ -8701,7 +8684,7 @@
                 <a:ea typeface="Calibri" pitchFamily="34" charset="-122"/>
                 <a:cs typeface="Calibri" pitchFamily="34" charset="-120"/>
               </a:rPr>
-              <a:t>16%–30%</a:t>
+              <a:t>20%–30%</a:t>
             </a:r>
             <a:endParaRPr lang="en-US" sz="2600" dirty="0"/>
           </a:p>
@@ -8785,7 +8768,7 @@
                 <a:ea typeface="Calibri" pitchFamily="34" charset="-122"/>
                 <a:cs typeface="Calibri" pitchFamily="34" charset="-120"/>
               </a:rPr>
-              <a:t>‫מול ‪S3 Standard‬ בלבד — ראו השקף הבא‬</a:t>
+              <a:t>‫בשכבה החמה בלבד — ראו השקף הבא‬</a:t>
             </a:r>
             <a:endParaRPr lang="he-IL" sz="1100" dirty="0"/>
           </a:p>
@@ -8985,7 +8968,7 @@
               <a:buNone/>
             </a:pPr>
             <a:r>
-              <a:rPr lang="he-IL" altLang="en-US" sz="2500" b="1" dirty="0">
+              <a:rPr lang="he-IL" altLang="en-US" sz="2600" b="1" dirty="0">
                 <a:solidFill>
                   <a:srgbClr val="F4F7FB"/>
                 </a:solidFill>
@@ -8993,9 +8976,9 @@
                 <a:ea typeface="Calibri" pitchFamily="34" charset="-122"/>
                 <a:cs typeface="Calibri" pitchFamily="34" charset="-120"/>
               </a:rPr>
-              <a:t>‫השוואנו מול ‪S3 Standard‬ — אבל דימות ו-‪Verint‬ הם דאטה ארכיוני‬</a:t>
-            </a:r>
-            <a:endParaRPr lang="he-IL" sz="2500" dirty="0"/>
+              <a:t>‫תמחרנו לפי שכבה חמה — אבל דימות ו-‪Verint‬ הם דאטה ארכיוני‬</a:t>
+            </a:r>
+            <a:endParaRPr lang="he-IL" sz="2600" dirty="0"/>
           </a:p>
         </p:txBody>
       </p:sp>

</xml_diff>

<commit_message>
Strip capacity data from the cover slide
The cover now carries only the title block: organisation eyebrow, headline,
accent rule and a one-line subtitle saying what the deck decides. The three
KPI tiles (75% utilisation, December 80% crossing, October PO deadline) are
gone from slide 1 — those numbers belong to slides 2-4, which is where the
argument is actually made.

Also adds src/qa.js, the overflow + bidi-ordering check that was previously
run ad hoc, so it is reproducible.

Co-Authored-By: Claude Opus 5 <noreply@anthropic.com>
Claude-Session: https://claude.ai/code/session_01MZnQ3bUVeTyJdPFvjg3J88
</commit_message>
<xml_diff>
--- a/presentations/ecs-to-s3/Harel_ECS_to_S3_CIO.pptx
+++ b/presentations/ecs-to-s3/Harel_ECS_to_S3_CIO.pptx
@@ -3095,7 +3095,7 @@
         </p:nvSpPr>
         <p:spPr>
           <a:xfrm>
-            <a:off x="822960" y="1481328"/>
+            <a:off x="822960" y="2212848"/>
             <a:ext cx="10545775" cy="274320"/>
           </a:xfrm>
           <a:prstGeom prst="rect">
@@ -3123,7 +3123,7 @@
                 <a:ea typeface="Calibri" pitchFamily="34" charset="-122"/>
                 <a:cs typeface="Calibri" pitchFamily="34" charset="-120"/>
               </a:rPr>
-              <a:t>‫הראל · תשתיות ‪IT‬ · ניהול קיבולת אחסון‬</a:t>
+              <a:t>‫הראל · תשתיות ‪IT‬‬</a:t>
             </a:r>
             <a:endParaRPr lang="he-IL" sz="1200" dirty="0"/>
           </a:p>
@@ -3137,8 +3137,8 @@
         </p:nvSpPr>
         <p:spPr>
           <a:xfrm>
-            <a:off x="822960" y="1828800"/>
-            <a:ext cx="10545775" cy="868680"/>
+            <a:off x="822960" y="2578608"/>
+            <a:ext cx="10545775" cy="914400"/>
           </a:xfrm>
           <a:prstGeom prst="rect">
             <a:avLst/>
@@ -3173,68 +3173,24 @@
       </p:sp>
       <p:sp>
         <p:nvSpPr>
-          <p:cNvPr id="7" name="Text 5"/>
-          <p:cNvSpPr/>
-          <p:nvPr/>
-        </p:nvSpPr>
-        <p:spPr>
-          <a:xfrm>
-            <a:off x="822960" y="2743200"/>
-            <a:ext cx="10545775" cy="384048"/>
-          </a:xfrm>
-          <a:prstGeom prst="rect">
-            <a:avLst/>
-          </a:prstGeom>
-          <a:noFill/>
-          <a:ln/>
-        </p:spPr>
-        <p:txBody>
-          <a:bodyPr wrap="square" lIns="0" tIns="0" rIns="0" bIns="0" rtlCol="0" anchor="ctr"/>
-          <a:lstStyle/>
-          <a:p>
-            <a:pPr rtl="1" algn="r" indent="0" marL="0">
-              <a:lnSpc>
-                <a:spcPct val="100000"/>
-              </a:lnSpc>
-              <a:buNone/>
-            </a:pPr>
-            <a:r>
-              <a:rPr lang="he-IL" altLang="en-US" sz="1500" dirty="0">
-                <a:solidFill>
-                  <a:srgbClr val="91A0B7"/>
-                </a:solidFill>
-                <a:latin typeface="Calibri" pitchFamily="34" charset="0"/>
-                <a:ea typeface="Calibri" pitchFamily="34" charset="-122"/>
-                <a:cs typeface="Calibri" pitchFamily="34" charset="-120"/>
-              </a:rPr>
-              <a:t>‫מ-‪ECS On-Prem‬ ל-‪AWS S3‬ · מצגת לקבלת החלטה · אוגוסט ‪2026‬‬</a:t>
-            </a:r>
-            <a:endParaRPr lang="he-IL" sz="1500" dirty="0"/>
-          </a:p>
-        </p:txBody>
-      </p:sp>
-      <p:sp>
-        <p:nvSpPr>
-          <p:cNvPr id="8" name="Shape 6"/>
-          <p:cNvSpPr/>
-          <p:nvPr/>
-        </p:nvSpPr>
-        <p:spPr>
-          <a:xfrm>
-            <a:off x="8109509" y="3950208"/>
-            <a:ext cx="3259226" cy="1170432"/>
-          </a:xfrm>
-          <a:prstGeom prst="roundRect">
-            <a:avLst>
-              <a:gd name="adj" fmla="val 3906"/>
-            </a:avLst>
+          <p:cNvPr id="7" name="Shape 5"/>
+          <p:cNvSpPr/>
+          <p:nvPr/>
+        </p:nvSpPr>
+        <p:spPr>
+          <a:xfrm>
+            <a:off x="8991295" y="3602736"/>
+            <a:ext cx="2377440" cy="27432"/>
+          </a:xfrm>
+          <a:prstGeom prst="rect">
+            <a:avLst/>
           </a:prstGeom>
           <a:solidFill>
-            <a:srgbClr val="182133"/>
+            <a:srgbClr val="3DD9EB"/>
           </a:solidFill>
           <a:ln w="12700">
             <a:solidFill>
-              <a:srgbClr val="23304A"/>
+              <a:srgbClr val="3DD9EB"/>
             </a:solidFill>
             <a:prstDash val="solid"/>
           </a:ln>
@@ -3242,14 +3198,14 @@
       </p:sp>
       <p:sp>
         <p:nvSpPr>
-          <p:cNvPr id="9" name="Text 7"/>
-          <p:cNvSpPr/>
-          <p:nvPr/>
-        </p:nvSpPr>
-        <p:spPr>
-          <a:xfrm>
-            <a:off x="8365541" y="4078224"/>
-            <a:ext cx="2747162" cy="219456"/>
+          <p:cNvPr id="8" name="Text 6"/>
+          <p:cNvSpPr/>
+          <p:nvPr/>
+        </p:nvSpPr>
+        <p:spPr>
+          <a:xfrm>
+            <a:off x="822960" y="3767328"/>
+            <a:ext cx="10545775" cy="384048"/>
           </a:xfrm>
           <a:prstGeom prst="rect">
             <a:avLst/>
@@ -3268,7 +3224,7 @@
               <a:buNone/>
             </a:pPr>
             <a:r>
-              <a:rPr lang="he-IL" altLang="en-US" sz="1050" b="1" spc="80" kern="0" dirty="0">
+              <a:rPr lang="he-IL" altLang="en-US" sz="1600" dirty="0">
                 <a:solidFill>
                   <a:srgbClr val="91A0B7"/>
                 </a:solidFill>
@@ -3276,405 +3232,15 @@
                 <a:ea typeface="Calibri" pitchFamily="34" charset="-122"/>
                 <a:cs typeface="Calibri" pitchFamily="34" charset="-120"/>
               </a:rPr>
-              <a:t>‫ניצולת האחסון היום‬</a:t>
-            </a:r>
-            <a:endParaRPr lang="he-IL" sz="1050" dirty="0"/>
-          </a:p>
-        </p:txBody>
-      </p:sp>
-      <p:sp>
-        <p:nvSpPr>
-          <p:cNvPr id="10" name="Text 8"/>
-          <p:cNvSpPr/>
-          <p:nvPr/>
-        </p:nvSpPr>
-        <p:spPr>
-          <a:xfrm>
-            <a:off x="8365541" y="4315968"/>
-            <a:ext cx="2747162" cy="420624"/>
-          </a:xfrm>
-          <a:prstGeom prst="rect">
-            <a:avLst/>
-          </a:prstGeom>
-          <a:noFill/>
-          <a:ln/>
-        </p:spPr>
-        <p:txBody>
-          <a:bodyPr wrap="square" lIns="0" tIns="0" rIns="0" bIns="0" rtlCol="0" anchor="ctr"/>
-          <a:lstStyle/>
-          <a:p>
-            <a:pPr rtl="1" algn="r" indent="0" marL="0">
-              <a:lnSpc>
-                <a:spcPct val="100000"/>
-              </a:lnSpc>
-              <a:buNone/>
-            </a:pPr>
-            <a:r>
-              <a:rPr lang="he-IL" altLang="en-US" sz="2600" b="1" dirty="0">
-                <a:solidFill>
-                  <a:srgbClr val="FF9F43"/>
-                </a:solidFill>
-                <a:latin typeface="Calibri" pitchFamily="34" charset="0"/>
-                <a:ea typeface="Calibri" pitchFamily="34" charset="-122"/>
-                <a:cs typeface="Calibri" pitchFamily="34" charset="-120"/>
-              </a:rPr>
-              <a:t>‫‪75%‬‬</a:t>
-            </a:r>
-            <a:endParaRPr lang="he-IL" sz="2600" dirty="0"/>
-          </a:p>
-        </p:txBody>
-      </p:sp>
-      <p:sp>
-        <p:nvSpPr>
-          <p:cNvPr id="11" name="Text 9"/>
-          <p:cNvSpPr/>
-          <p:nvPr/>
-        </p:nvSpPr>
-        <p:spPr>
-          <a:xfrm>
-            <a:off x="8365541" y="4745736"/>
-            <a:ext cx="2747162" cy="256032"/>
-          </a:xfrm>
-          <a:prstGeom prst="rect">
-            <a:avLst/>
-          </a:prstGeom>
-          <a:noFill/>
-          <a:ln/>
-        </p:spPr>
-        <p:txBody>
-          <a:bodyPr wrap="square" lIns="0" tIns="0" rIns="0" bIns="0" rtlCol="0" anchor="ctr"/>
-          <a:lstStyle/>
-          <a:p>
-            <a:pPr rtl="1" algn="r" indent="0" marL="0">
-              <a:lnSpc>
-                <a:spcPct val="100000"/>
-              </a:lnSpc>
-              <a:buNone/>
-            </a:pPr>
-            <a:r>
-              <a:rPr lang="he-IL" altLang="en-US" sz="1100" dirty="0">
-                <a:solidFill>
-                  <a:srgbClr val="5E6E85"/>
-                </a:solidFill>
-                <a:latin typeface="Calibri" pitchFamily="34" charset="0"/>
-                <a:ea typeface="Calibri" pitchFamily="34" charset="-122"/>
-                <a:cs typeface="Calibri" pitchFamily="34" charset="-120"/>
-              </a:rPr>
-              <a:t>‫‪687 TB‬ מתוך ‪916 TB‬‬</a:t>
-            </a:r>
-            <a:endParaRPr lang="he-IL" sz="1100" dirty="0"/>
-          </a:p>
-        </p:txBody>
-      </p:sp>
-      <p:sp>
-        <p:nvSpPr>
-          <p:cNvPr id="12" name="Shape 10"/>
-          <p:cNvSpPr/>
-          <p:nvPr/>
-        </p:nvSpPr>
-        <p:spPr>
-          <a:xfrm>
-            <a:off x="4466234" y="3950208"/>
-            <a:ext cx="3259226" cy="1170432"/>
-          </a:xfrm>
-          <a:prstGeom prst="roundRect">
-            <a:avLst>
-              <a:gd name="adj" fmla="val 3906"/>
-            </a:avLst>
-          </a:prstGeom>
-          <a:solidFill>
-            <a:srgbClr val="182133"/>
-          </a:solidFill>
-          <a:ln w="12700">
-            <a:solidFill>
-              <a:srgbClr val="23304A"/>
-            </a:solidFill>
-            <a:prstDash val="solid"/>
-          </a:ln>
-        </p:spPr>
-      </p:sp>
-      <p:sp>
-        <p:nvSpPr>
-          <p:cNvPr id="13" name="Text 11"/>
-          <p:cNvSpPr/>
-          <p:nvPr/>
-        </p:nvSpPr>
-        <p:spPr>
-          <a:xfrm>
-            <a:off x="4722266" y="4078224"/>
-            <a:ext cx="2747162" cy="219456"/>
-          </a:xfrm>
-          <a:prstGeom prst="rect">
-            <a:avLst/>
-          </a:prstGeom>
-          <a:noFill/>
-          <a:ln/>
-        </p:spPr>
-        <p:txBody>
-          <a:bodyPr wrap="square" lIns="0" tIns="0" rIns="0" bIns="0" rtlCol="0" anchor="ctr"/>
-          <a:lstStyle/>
-          <a:p>
-            <a:pPr rtl="1" algn="r" indent="0" marL="0">
-              <a:lnSpc>
-                <a:spcPct val="100000"/>
-              </a:lnSpc>
-              <a:buNone/>
-            </a:pPr>
-            <a:r>
-              <a:rPr lang="he-IL" altLang="en-US" sz="1050" b="1" spc="80" kern="0" dirty="0">
-                <a:solidFill>
-                  <a:srgbClr val="91A0B7"/>
-                </a:solidFill>
-                <a:latin typeface="Calibri" pitchFamily="34" charset="0"/>
-                <a:ea typeface="Calibri" pitchFamily="34" charset="-122"/>
-                <a:cs typeface="Calibri" pitchFamily="34" charset="-120"/>
-              </a:rPr>
-              <a:t>‫חציית סף ‪80%‬‬</a:t>
-            </a:r>
-            <a:endParaRPr lang="he-IL" sz="1050" dirty="0"/>
-          </a:p>
-        </p:txBody>
-      </p:sp>
-      <p:sp>
-        <p:nvSpPr>
-          <p:cNvPr id="14" name="Text 12"/>
-          <p:cNvSpPr/>
-          <p:nvPr/>
-        </p:nvSpPr>
-        <p:spPr>
-          <a:xfrm>
-            <a:off x="4722266" y="4315968"/>
-            <a:ext cx="2747162" cy="420624"/>
-          </a:xfrm>
-          <a:prstGeom prst="rect">
-            <a:avLst/>
-          </a:prstGeom>
-          <a:noFill/>
-          <a:ln/>
-        </p:spPr>
-        <p:txBody>
-          <a:bodyPr wrap="square" lIns="0" tIns="0" rIns="0" bIns="0" rtlCol="0" anchor="ctr"/>
-          <a:lstStyle/>
-          <a:p>
-            <a:pPr rtl="1" algn="r" indent="0" marL="0">
-              <a:lnSpc>
-                <a:spcPct val="100000"/>
-              </a:lnSpc>
-              <a:buNone/>
-            </a:pPr>
-            <a:r>
-              <a:rPr lang="he-IL" altLang="en-US" sz="2600" b="1" dirty="0">
-                <a:solidFill>
-                  <a:srgbClr val="FF6B7A"/>
-                </a:solidFill>
-                <a:latin typeface="Calibri" pitchFamily="34" charset="0"/>
-                <a:ea typeface="Calibri" pitchFamily="34" charset="-122"/>
-                <a:cs typeface="Calibri" pitchFamily="34" charset="-120"/>
-              </a:rPr>
-              <a:t>‫דצמבר ‪2026‬‬</a:t>
-            </a:r>
-            <a:endParaRPr lang="he-IL" sz="2600" dirty="0"/>
-          </a:p>
-        </p:txBody>
-      </p:sp>
-      <p:sp>
-        <p:nvSpPr>
-          <p:cNvPr id="15" name="Text 13"/>
-          <p:cNvSpPr/>
-          <p:nvPr/>
-        </p:nvSpPr>
-        <p:spPr>
-          <a:xfrm>
-            <a:off x="4722266" y="4745736"/>
-            <a:ext cx="2747162" cy="256032"/>
-          </a:xfrm>
-          <a:prstGeom prst="rect">
-            <a:avLst/>
-          </a:prstGeom>
-          <a:noFill/>
-          <a:ln/>
-        </p:spPr>
-        <p:txBody>
-          <a:bodyPr wrap="square" lIns="0" tIns="0" rIns="0" bIns="0" rtlCol="0" anchor="ctr"/>
-          <a:lstStyle/>
-          <a:p>
-            <a:pPr rtl="1" algn="r" indent="0" marL="0">
-              <a:lnSpc>
-                <a:spcPct val="100000"/>
-              </a:lnSpc>
-              <a:buNone/>
-            </a:pPr>
-            <a:r>
-              <a:rPr lang="he-IL" altLang="en-US" sz="1100" dirty="0">
-                <a:solidFill>
-                  <a:srgbClr val="5E6E85"/>
-                </a:solidFill>
-                <a:latin typeface="Calibri" pitchFamily="34" charset="0"/>
-                <a:ea typeface="Calibri" pitchFamily="34" charset="-122"/>
-                <a:cs typeface="Calibri" pitchFamily="34" charset="-120"/>
-              </a:rPr>
-              <a:t>‫‪733 TB‬ · סיכון לזמינות‬</a:t>
-            </a:r>
-            <a:endParaRPr lang="he-IL" sz="1100" dirty="0"/>
-          </a:p>
-        </p:txBody>
-      </p:sp>
-      <p:sp>
-        <p:nvSpPr>
-          <p:cNvPr id="16" name="Shape 14"/>
-          <p:cNvSpPr/>
-          <p:nvPr/>
-        </p:nvSpPr>
-        <p:spPr>
-          <a:xfrm>
-            <a:off x="822960" y="3950208"/>
-            <a:ext cx="3259226" cy="1170432"/>
-          </a:xfrm>
-          <a:prstGeom prst="roundRect">
-            <a:avLst>
-              <a:gd name="adj" fmla="val 3906"/>
-            </a:avLst>
-          </a:prstGeom>
-          <a:solidFill>
-            <a:srgbClr val="182133"/>
-          </a:solidFill>
-          <a:ln w="12700">
-            <a:solidFill>
-              <a:srgbClr val="23304A"/>
-            </a:solidFill>
-            <a:prstDash val="solid"/>
-          </a:ln>
-        </p:spPr>
-      </p:sp>
-      <p:sp>
-        <p:nvSpPr>
-          <p:cNvPr id="17" name="Text 15"/>
-          <p:cNvSpPr/>
-          <p:nvPr/>
-        </p:nvSpPr>
-        <p:spPr>
-          <a:xfrm>
-            <a:off x="1078992" y="4078224"/>
-            <a:ext cx="2747162" cy="219456"/>
-          </a:xfrm>
-          <a:prstGeom prst="rect">
-            <a:avLst/>
-          </a:prstGeom>
-          <a:noFill/>
-          <a:ln/>
-        </p:spPr>
-        <p:txBody>
-          <a:bodyPr wrap="square" lIns="0" tIns="0" rIns="0" bIns="0" rtlCol="0" anchor="ctr"/>
-          <a:lstStyle/>
-          <a:p>
-            <a:pPr rtl="1" algn="r" indent="0" marL="0">
-              <a:lnSpc>
-                <a:spcPct val="100000"/>
-              </a:lnSpc>
-              <a:buNone/>
-            </a:pPr>
-            <a:r>
-              <a:rPr lang="he-IL" altLang="en-US" sz="1050" b="1" spc="80" kern="0" dirty="0">
-                <a:solidFill>
-                  <a:srgbClr val="91A0B7"/>
-                </a:solidFill>
-                <a:latin typeface="Calibri" pitchFamily="34" charset="0"/>
-                <a:ea typeface="Calibri" pitchFamily="34" charset="-122"/>
-                <a:cs typeface="Calibri" pitchFamily="34" charset="-120"/>
-              </a:rPr>
-              <a:t>‫מועד אחרון להוצאת ‪PO‬‬</a:t>
-            </a:r>
-            <a:endParaRPr lang="he-IL" sz="1050" dirty="0"/>
-          </a:p>
-        </p:txBody>
-      </p:sp>
-      <p:sp>
-        <p:nvSpPr>
-          <p:cNvPr id="18" name="Text 16"/>
-          <p:cNvSpPr/>
-          <p:nvPr/>
-        </p:nvSpPr>
-        <p:spPr>
-          <a:xfrm>
-            <a:off x="1078992" y="4315968"/>
-            <a:ext cx="2747162" cy="420624"/>
-          </a:xfrm>
-          <a:prstGeom prst="rect">
-            <a:avLst/>
-          </a:prstGeom>
-          <a:noFill/>
-          <a:ln/>
-        </p:spPr>
-        <p:txBody>
-          <a:bodyPr wrap="square" lIns="0" tIns="0" rIns="0" bIns="0" rtlCol="0" anchor="ctr"/>
-          <a:lstStyle/>
-          <a:p>
-            <a:pPr rtl="1" algn="r" indent="0" marL="0">
-              <a:lnSpc>
-                <a:spcPct val="100000"/>
-              </a:lnSpc>
-              <a:buNone/>
-            </a:pPr>
-            <a:r>
-              <a:rPr lang="he-IL" altLang="en-US" sz="2600" b="1" dirty="0">
-                <a:solidFill>
-                  <a:srgbClr val="3DD9EB"/>
-                </a:solidFill>
-                <a:latin typeface="Calibri" pitchFamily="34" charset="0"/>
-                <a:ea typeface="Calibri" pitchFamily="34" charset="-122"/>
-                <a:cs typeface="Calibri" pitchFamily="34" charset="-120"/>
-              </a:rPr>
-              <a:t>‫אוקטובר ‪2026‬‬</a:t>
-            </a:r>
-            <a:endParaRPr lang="he-IL" sz="2600" dirty="0"/>
-          </a:p>
-        </p:txBody>
-      </p:sp>
-      <p:sp>
-        <p:nvSpPr>
-          <p:cNvPr id="19" name="Text 17"/>
-          <p:cNvSpPr/>
-          <p:nvPr/>
-        </p:nvSpPr>
-        <p:spPr>
-          <a:xfrm>
-            <a:off x="1078992" y="4745736"/>
-            <a:ext cx="2747162" cy="256032"/>
-          </a:xfrm>
-          <a:prstGeom prst="rect">
-            <a:avLst/>
-          </a:prstGeom>
-          <a:noFill/>
-          <a:ln/>
-        </p:spPr>
-        <p:txBody>
-          <a:bodyPr wrap="square" lIns="0" tIns="0" rIns="0" bIns="0" rtlCol="0" anchor="ctr"/>
-          <a:lstStyle/>
-          <a:p>
-            <a:pPr rtl="1" algn="r" indent="0" marL="0">
-              <a:lnSpc>
-                <a:spcPct val="100000"/>
-              </a:lnSpc>
-              <a:buNone/>
-            </a:pPr>
-            <a:r>
-              <a:rPr lang="he-IL" altLang="en-US" sz="1100" dirty="0">
-                <a:solidFill>
-                  <a:srgbClr val="5E6E85"/>
-                </a:solidFill>
-                <a:latin typeface="Calibri" pitchFamily="34" charset="0"/>
-                <a:ea typeface="Calibri" pitchFamily="34" charset="-122"/>
-                <a:cs typeface="Calibri" pitchFamily="34" charset="-120"/>
-              </a:rPr>
-              <a:t>‫חודשיים אספקה מ-‪Dell‬‬</a:t>
-            </a:r>
-            <a:endParaRPr lang="he-IL" sz="1100" dirty="0"/>
-          </a:p>
-        </p:txBody>
-      </p:sp>
-      <p:sp>
-        <p:nvSpPr>
-          <p:cNvPr id="20" name="Shape 18"/>
+              <a:t>‫מ-‪ECS On-Prem‬ ל-‪AWS S3‬ · מצגת לקבלת החלטה‬</a:t>
+            </a:r>
+            <a:endParaRPr lang="he-IL" sz="1600" dirty="0"/>
+          </a:p>
+        </p:txBody>
+      </p:sp>
+      <p:sp>
+        <p:nvSpPr>
+          <p:cNvPr id="9" name="Shape 7"/>
           <p:cNvSpPr/>
           <p:nvPr/>
         </p:nvSpPr>
@@ -3699,7 +3265,7 @@
       </p:sp>
       <p:sp>
         <p:nvSpPr>
-          <p:cNvPr id="21" name="Text 19"/>
+          <p:cNvPr id="10" name="Text 8"/>
           <p:cNvSpPr/>
           <p:nvPr/>
         </p:nvSpPr>

</xml_diff>

<commit_message>
Clean up the cover and rebuild slide 2's layout
Cover: drop the two tinted background blocks. They were only a few points off
the canvas colour, so instead of reading as a motif they banded on projection
and looked like smudges. Replaced with a hairline and accent square at the top
that mirror the footer, leaving the title block on a flat canvas.

Slide 2: same content, better hierarchy. The middle step of the timeline is the
ask, so it now sits on the lit card fill with a cyan border while the two
flanking steps drop back to the darker fill; each step carries an accent bar on
its RTL start edge. Timeline cards grew to 1.5in so the value line can breathe,
and the two option cards were retightened to 2.02in, which removes the dead band
that used to sit between the body copy and the action chip.

Co-Authored-By: Claude Opus 5 <noreply@anthropic.com>
Claude-Session: https://claude.ai/code/session_01MZnQ3bUVeTyJdPFvjg3J88
</commit_message>
<xml_diff>
--- a/presentations/ecs-to-s3/Harel_ECS_to_S3_CIO.pptx
+++ b/presentations/ecs-to-s3/Harel_ECS_to_S3_CIO.pptx
@@ -3045,18 +3045,18 @@
         </p:nvSpPr>
         <p:spPr>
           <a:xfrm>
-            <a:off x="-1645920" y="-1005840"/>
-            <a:ext cx="4754880" cy="4754880"/>
+            <a:off x="822960" y="566928"/>
+            <a:ext cx="10545775" cy="10973"/>
           </a:xfrm>
           <a:prstGeom prst="rect">
             <a:avLst/>
           </a:prstGeom>
           <a:solidFill>
-            <a:srgbClr val="0C1322"/>
+            <a:srgbClr val="23304A"/>
           </a:solidFill>
           <a:ln w="12700">
             <a:solidFill>
-              <a:srgbClr val="0C1322"/>
+              <a:srgbClr val="23304A"/>
             </a:solidFill>
             <a:prstDash val="solid"/>
           </a:ln>
@@ -3070,18 +3070,18 @@
         </p:nvSpPr>
         <p:spPr>
           <a:xfrm>
-            <a:off x="-1280160" y="3017520"/>
-            <a:ext cx="3108960" cy="3108960"/>
+            <a:off x="11249863" y="512064"/>
+            <a:ext cx="118872" cy="118872"/>
           </a:xfrm>
           <a:prstGeom prst="rect">
             <a:avLst/>
           </a:prstGeom>
           <a:solidFill>
-            <a:srgbClr val="0A101C"/>
+            <a:srgbClr val="3DD9EB"/>
           </a:solidFill>
           <a:ln w="12700">
             <a:solidFill>
-              <a:srgbClr val="0A101C"/>
+              <a:srgbClr val="3DD9EB"/>
             </a:solidFill>
             <a:prstDash val="solid"/>
           </a:ln>
@@ -4492,16 +4492,16 @@
         </p:nvSpPr>
         <p:spPr>
           <a:xfrm>
-            <a:off x="8168335" y="2048256"/>
-            <a:ext cx="3200400" cy="1170432"/>
+            <a:off x="8168335" y="1956816"/>
+            <a:ext cx="3200400" cy="1371600"/>
           </a:xfrm>
           <a:prstGeom prst="roundRect">
             <a:avLst>
-              <a:gd name="adj" fmla="val 3906"/>
+              <a:gd name="adj" fmla="val 3333"/>
             </a:avLst>
           </a:prstGeom>
           <a:solidFill>
-            <a:srgbClr val="182133"/>
+            <a:srgbClr val="141C2C"/>
           </a:solidFill>
           <a:ln w="12700">
             <a:solidFill>
@@ -4513,14 +4513,39 @@
       </p:sp>
       <p:sp>
         <p:nvSpPr>
-          <p:cNvPr id="6" name="Text 4"/>
-          <p:cNvSpPr/>
-          <p:nvPr/>
-        </p:nvSpPr>
-        <p:spPr>
-          <a:xfrm>
-            <a:off x="8424367" y="2212848"/>
-            <a:ext cx="2688336" cy="237744"/>
+          <p:cNvPr id="6" name="Shape 4"/>
+          <p:cNvSpPr/>
+          <p:nvPr/>
+        </p:nvSpPr>
+        <p:spPr>
+          <a:xfrm>
+            <a:off x="11318443" y="2139696"/>
+            <a:ext cx="50292" cy="1005840"/>
+          </a:xfrm>
+          <a:prstGeom prst="rect">
+            <a:avLst/>
+          </a:prstGeom>
+          <a:solidFill>
+            <a:srgbClr val="FF9F43"/>
+          </a:solidFill>
+          <a:ln w="12700">
+            <a:solidFill>
+              <a:srgbClr val="FF9F43"/>
+            </a:solidFill>
+            <a:prstDash val="solid"/>
+          </a:ln>
+        </p:spPr>
+      </p:sp>
+      <p:sp>
+        <p:nvSpPr>
+          <p:cNvPr id="7" name="Text 5"/>
+          <p:cNvSpPr/>
+          <p:nvPr/>
+        </p:nvSpPr>
+        <p:spPr>
+          <a:xfrm>
+            <a:off x="8442655" y="2139696"/>
+            <a:ext cx="2633472" cy="237744"/>
           </a:xfrm>
           <a:prstGeom prst="rect">
             <a:avLst/>
@@ -4555,14 +4580,14 @@
       </p:sp>
       <p:sp>
         <p:nvSpPr>
-          <p:cNvPr id="7" name="Text 5"/>
-          <p:cNvSpPr/>
-          <p:nvPr/>
-        </p:nvSpPr>
-        <p:spPr>
-          <a:xfrm>
-            <a:off x="8424367" y="2468880"/>
-            <a:ext cx="2688336" cy="420624"/>
+          <p:cNvPr id="8" name="Text 6"/>
+          <p:cNvSpPr/>
+          <p:nvPr/>
+        </p:nvSpPr>
+        <p:spPr>
+          <a:xfrm>
+            <a:off x="8442655" y="2432304"/>
+            <a:ext cx="2633472" cy="457200"/>
           </a:xfrm>
           <a:prstGeom prst="rect">
             <a:avLst/>
@@ -4581,7 +4606,7 @@
               <a:buNone/>
             </a:pPr>
             <a:r>
-              <a:rPr lang="he-IL" altLang="en-US" sz="2400" b="1" dirty="0">
+              <a:rPr lang="he-IL" altLang="en-US" sz="2500" b="1" dirty="0">
                 <a:solidFill>
                   <a:srgbClr val="FF9F43"/>
                 </a:solidFill>
@@ -4591,20 +4616,20 @@
               </a:rPr>
               <a:t>‫‪75%‬‬</a:t>
             </a:r>
-            <a:endParaRPr lang="he-IL" sz="2400" dirty="0"/>
-          </a:p>
-        </p:txBody>
-      </p:sp>
-      <p:sp>
-        <p:nvSpPr>
-          <p:cNvPr id="8" name="Text 6"/>
-          <p:cNvSpPr/>
-          <p:nvPr/>
-        </p:nvSpPr>
-        <p:spPr>
-          <a:xfrm>
-            <a:off x="8424367" y="2907792"/>
-            <a:ext cx="2688336" cy="237744"/>
+            <a:endParaRPr lang="he-IL" sz="2500" dirty="0"/>
+          </a:p>
+        </p:txBody>
+      </p:sp>
+      <p:sp>
+        <p:nvSpPr>
+          <p:cNvPr id="9" name="Text 7"/>
+          <p:cNvSpPr/>
+          <p:nvPr/>
+        </p:nvSpPr>
+        <p:spPr>
+          <a:xfrm>
+            <a:off x="8442655" y="2944368"/>
+            <a:ext cx="2633472" cy="256032"/>
           </a:xfrm>
           <a:prstGeom prst="rect">
             <a:avLst/>
@@ -4639,13 +4664,13 @@
       </p:sp>
       <p:sp>
         <p:nvSpPr>
-          <p:cNvPr id="9" name="Text 7"/>
-          <p:cNvSpPr/>
-          <p:nvPr/>
-        </p:nvSpPr>
-        <p:spPr>
-          <a:xfrm>
-            <a:off x="7692847" y="2450592"/>
+          <p:cNvPr id="10" name="Text 8"/>
+          <p:cNvSpPr/>
+          <p:nvPr/>
+        </p:nvSpPr>
+        <p:spPr>
+          <a:xfrm>
+            <a:off x="7692847" y="2459736"/>
             <a:ext cx="475488" cy="365760"/>
           </a:xfrm>
           <a:prstGeom prst="rect">
@@ -4665,7 +4690,7 @@
               <a:buNone/>
             </a:pPr>
             <a:r>
-              <a:rPr lang="en-US" altLang="en-US" sz="1900" b="1" dirty="0">
+              <a:rPr lang="en-US" altLang="en-US" sz="2100" b="1" dirty="0">
                 <a:solidFill>
                   <a:srgbClr val="5E6E85"/>
                 </a:solidFill>
@@ -4675,28 +4700,248 @@
               </a:rPr>
               <a:t>←</a:t>
             </a:r>
-            <a:endParaRPr lang="en-US" sz="1900" dirty="0"/>
-          </a:p>
-        </p:txBody>
-      </p:sp>
-      <p:sp>
-        <p:nvSpPr>
-          <p:cNvPr id="10" name="Shape 8"/>
-          <p:cNvSpPr/>
-          <p:nvPr/>
-        </p:nvSpPr>
-        <p:spPr>
-          <a:xfrm>
-            <a:off x="4492447" y="2048256"/>
-            <a:ext cx="3200400" cy="1170432"/>
+            <a:endParaRPr lang="en-US" sz="2100" dirty="0"/>
+          </a:p>
+        </p:txBody>
+      </p:sp>
+      <p:sp>
+        <p:nvSpPr>
+          <p:cNvPr id="11" name="Shape 9"/>
+          <p:cNvSpPr/>
+          <p:nvPr/>
+        </p:nvSpPr>
+        <p:spPr>
+          <a:xfrm>
+            <a:off x="4492447" y="1956816"/>
+            <a:ext cx="3200400" cy="1371600"/>
           </a:xfrm>
           <a:prstGeom prst="roundRect">
             <a:avLst>
-              <a:gd name="adj" fmla="val 3906"/>
+              <a:gd name="adj" fmla="val 3333"/>
             </a:avLst>
           </a:prstGeom>
           <a:solidFill>
             <a:srgbClr val="182133"/>
+          </a:solidFill>
+          <a:ln w="19050">
+            <a:solidFill>
+              <a:srgbClr val="3DD9EB"/>
+            </a:solidFill>
+            <a:prstDash val="solid"/>
+          </a:ln>
+        </p:spPr>
+      </p:sp>
+      <p:sp>
+        <p:nvSpPr>
+          <p:cNvPr id="12" name="Shape 10"/>
+          <p:cNvSpPr/>
+          <p:nvPr/>
+        </p:nvSpPr>
+        <p:spPr>
+          <a:xfrm>
+            <a:off x="7642555" y="2139696"/>
+            <a:ext cx="50292" cy="1005840"/>
+          </a:xfrm>
+          <a:prstGeom prst="rect">
+            <a:avLst/>
+          </a:prstGeom>
+          <a:solidFill>
+            <a:srgbClr val="3DD9EB"/>
+          </a:solidFill>
+          <a:ln w="12700">
+            <a:solidFill>
+              <a:srgbClr val="3DD9EB"/>
+            </a:solidFill>
+            <a:prstDash val="solid"/>
+          </a:ln>
+        </p:spPr>
+      </p:sp>
+      <p:sp>
+        <p:nvSpPr>
+          <p:cNvPr id="13" name="Text 11"/>
+          <p:cNvSpPr/>
+          <p:nvPr/>
+        </p:nvSpPr>
+        <p:spPr>
+          <a:xfrm>
+            <a:off x="4766767" y="2139696"/>
+            <a:ext cx="2633472" cy="237744"/>
+          </a:xfrm>
+          <a:prstGeom prst="rect">
+            <a:avLst/>
+          </a:prstGeom>
+          <a:noFill/>
+          <a:ln/>
+        </p:spPr>
+        <p:txBody>
+          <a:bodyPr wrap="square" lIns="0" tIns="0" rIns="0" bIns="0" rtlCol="0" anchor="ctr"/>
+          <a:lstStyle/>
+          <a:p>
+            <a:pPr rtl="1" algn="r" indent="0" marL="0">
+              <a:lnSpc>
+                <a:spcPct val="100000"/>
+              </a:lnSpc>
+              <a:buNone/>
+            </a:pPr>
+            <a:r>
+              <a:rPr lang="he-IL" altLang="en-US" sz="1050" b="1" spc="80" kern="0" dirty="0">
+                <a:solidFill>
+                  <a:srgbClr val="91A0B7"/>
+                </a:solidFill>
+                <a:latin typeface="Calibri" pitchFamily="34" charset="0"/>
+                <a:ea typeface="Calibri" pitchFamily="34" charset="-122"/>
+                <a:cs typeface="Calibri" pitchFamily="34" charset="-120"/>
+              </a:rPr>
+              <a:t>‫אוקטובר ‪2026‬‬</a:t>
+            </a:r>
+            <a:endParaRPr lang="he-IL" sz="1050" dirty="0"/>
+          </a:p>
+        </p:txBody>
+      </p:sp>
+      <p:sp>
+        <p:nvSpPr>
+          <p:cNvPr id="14" name="Text 12"/>
+          <p:cNvSpPr/>
+          <p:nvPr/>
+        </p:nvSpPr>
+        <p:spPr>
+          <a:xfrm>
+            <a:off x="4766767" y="2432304"/>
+            <a:ext cx="2633472" cy="457200"/>
+          </a:xfrm>
+          <a:prstGeom prst="rect">
+            <a:avLst/>
+          </a:prstGeom>
+          <a:noFill/>
+          <a:ln/>
+        </p:spPr>
+        <p:txBody>
+          <a:bodyPr wrap="square" lIns="0" tIns="0" rIns="0" bIns="0" rtlCol="0" anchor="ctr"/>
+          <a:lstStyle/>
+          <a:p>
+            <a:pPr rtl="1" algn="r" indent="0" marL="0">
+              <a:lnSpc>
+                <a:spcPct val="100000"/>
+              </a:lnSpc>
+              <a:buNone/>
+            </a:pPr>
+            <a:r>
+              <a:rPr lang="he-IL" altLang="en-US" sz="2500" b="1" dirty="0">
+                <a:solidFill>
+                  <a:srgbClr val="3DD9EB"/>
+                </a:solidFill>
+                <a:latin typeface="Calibri" pitchFamily="34" charset="0"/>
+                <a:ea typeface="Calibri" pitchFamily="34" charset="-122"/>
+                <a:cs typeface="Calibri" pitchFamily="34" charset="-120"/>
+              </a:rPr>
+              <a:t>‫הוצאת ‪PO‬‬</a:t>
+            </a:r>
+            <a:endParaRPr lang="he-IL" sz="2500" dirty="0"/>
+          </a:p>
+        </p:txBody>
+      </p:sp>
+      <p:sp>
+        <p:nvSpPr>
+          <p:cNvPr id="15" name="Text 13"/>
+          <p:cNvSpPr/>
+          <p:nvPr/>
+        </p:nvSpPr>
+        <p:spPr>
+          <a:xfrm>
+            <a:off x="4766767" y="2944368"/>
+            <a:ext cx="2633472" cy="256032"/>
+          </a:xfrm>
+          <a:prstGeom prst="rect">
+            <a:avLst/>
+          </a:prstGeom>
+          <a:noFill/>
+          <a:ln/>
+        </p:spPr>
+        <p:txBody>
+          <a:bodyPr wrap="square" lIns="0" tIns="0" rIns="0" bIns="0" rtlCol="0" anchor="ctr"/>
+          <a:lstStyle/>
+          <a:p>
+            <a:pPr rtl="1" algn="r" indent="0" marL="0">
+              <a:lnSpc>
+                <a:spcPct val="100000"/>
+              </a:lnSpc>
+              <a:buNone/>
+            </a:pPr>
+            <a:r>
+              <a:rPr lang="he-IL" altLang="en-US" sz="1100" dirty="0">
+                <a:solidFill>
+                  <a:srgbClr val="5E6E85"/>
+                </a:solidFill>
+                <a:latin typeface="Calibri" pitchFamily="34" charset="0"/>
+                <a:ea typeface="Calibri" pitchFamily="34" charset="-122"/>
+                <a:cs typeface="Calibri" pitchFamily="34" charset="-120"/>
+              </a:rPr>
+              <a:t>‫חודשיים זמן אספקה מ-‪Dell‬‬</a:t>
+            </a:r>
+            <a:endParaRPr lang="he-IL" sz="1100" dirty="0"/>
+          </a:p>
+        </p:txBody>
+      </p:sp>
+      <p:sp>
+        <p:nvSpPr>
+          <p:cNvPr id="16" name="Text 14"/>
+          <p:cNvSpPr/>
+          <p:nvPr/>
+        </p:nvSpPr>
+        <p:spPr>
+          <a:xfrm>
+            <a:off x="4016959" y="2459736"/>
+            <a:ext cx="475488" cy="365760"/>
+          </a:xfrm>
+          <a:prstGeom prst="rect">
+            <a:avLst/>
+          </a:prstGeom>
+          <a:noFill/>
+          <a:ln/>
+        </p:spPr>
+        <p:txBody>
+          <a:bodyPr wrap="square" lIns="0" tIns="0" rIns="0" bIns="0" rtlCol="0" anchor="ctr"/>
+          <a:lstStyle/>
+          <a:p>
+            <a:pPr algn="ctr" indent="0" marL="0">
+              <a:lnSpc>
+                <a:spcPct val="100000"/>
+              </a:lnSpc>
+              <a:buNone/>
+            </a:pPr>
+            <a:r>
+              <a:rPr lang="en-US" altLang="en-US" sz="2100" b="1" dirty="0">
+                <a:solidFill>
+                  <a:srgbClr val="5E6E85"/>
+                </a:solidFill>
+                <a:latin typeface="Calibri" pitchFamily="34" charset="0"/>
+                <a:ea typeface="Calibri" pitchFamily="34" charset="-122"/>
+                <a:cs typeface="Calibri" pitchFamily="34" charset="-120"/>
+              </a:rPr>
+              <a:t>←</a:t>
+            </a:r>
+            <a:endParaRPr lang="en-US" sz="2100" dirty="0"/>
+          </a:p>
+        </p:txBody>
+      </p:sp>
+      <p:sp>
+        <p:nvSpPr>
+          <p:cNvPr id="17" name="Shape 15"/>
+          <p:cNvSpPr/>
+          <p:nvPr/>
+        </p:nvSpPr>
+        <p:spPr>
+          <a:xfrm>
+            <a:off x="816559" y="1956816"/>
+            <a:ext cx="3200400" cy="1371600"/>
+          </a:xfrm>
+          <a:prstGeom prst="roundRect">
+            <a:avLst>
+              <a:gd name="adj" fmla="val 3333"/>
+            </a:avLst>
+          </a:prstGeom>
+          <a:solidFill>
+            <a:srgbClr val="141C2C"/>
           </a:solidFill>
           <a:ln w="12700">
             <a:solidFill>
@@ -4708,194 +4953,24 @@
       </p:sp>
       <p:sp>
         <p:nvSpPr>
-          <p:cNvPr id="11" name="Text 9"/>
-          <p:cNvSpPr/>
-          <p:nvPr/>
-        </p:nvSpPr>
-        <p:spPr>
-          <a:xfrm>
-            <a:off x="4748479" y="2212848"/>
-            <a:ext cx="2688336" cy="237744"/>
-          </a:xfrm>
-          <a:prstGeom prst="rect">
-            <a:avLst/>
-          </a:prstGeom>
-          <a:noFill/>
-          <a:ln/>
-        </p:spPr>
-        <p:txBody>
-          <a:bodyPr wrap="square" lIns="0" tIns="0" rIns="0" bIns="0" rtlCol="0" anchor="ctr"/>
-          <a:lstStyle/>
-          <a:p>
-            <a:pPr rtl="1" algn="r" indent="0" marL="0">
-              <a:lnSpc>
-                <a:spcPct val="100000"/>
-              </a:lnSpc>
-              <a:buNone/>
-            </a:pPr>
-            <a:r>
-              <a:rPr lang="he-IL" altLang="en-US" sz="1050" b="1" spc="80" kern="0" dirty="0">
-                <a:solidFill>
-                  <a:srgbClr val="91A0B7"/>
-                </a:solidFill>
-                <a:latin typeface="Calibri" pitchFamily="34" charset="0"/>
-                <a:ea typeface="Calibri" pitchFamily="34" charset="-122"/>
-                <a:cs typeface="Calibri" pitchFamily="34" charset="-120"/>
-              </a:rPr>
-              <a:t>‫אוקטובר ‪2026‬‬</a:t>
-            </a:r>
-            <a:endParaRPr lang="he-IL" sz="1050" dirty="0"/>
-          </a:p>
-        </p:txBody>
-      </p:sp>
-      <p:sp>
-        <p:nvSpPr>
-          <p:cNvPr id="12" name="Text 10"/>
-          <p:cNvSpPr/>
-          <p:nvPr/>
-        </p:nvSpPr>
-        <p:spPr>
-          <a:xfrm>
-            <a:off x="4748479" y="2468880"/>
-            <a:ext cx="2688336" cy="420624"/>
-          </a:xfrm>
-          <a:prstGeom prst="rect">
-            <a:avLst/>
-          </a:prstGeom>
-          <a:noFill/>
-          <a:ln/>
-        </p:spPr>
-        <p:txBody>
-          <a:bodyPr wrap="square" lIns="0" tIns="0" rIns="0" bIns="0" rtlCol="0" anchor="ctr"/>
-          <a:lstStyle/>
-          <a:p>
-            <a:pPr rtl="1" algn="r" indent="0" marL="0">
-              <a:lnSpc>
-                <a:spcPct val="100000"/>
-              </a:lnSpc>
-              <a:buNone/>
-            </a:pPr>
-            <a:r>
-              <a:rPr lang="he-IL" altLang="en-US" sz="2400" b="1" dirty="0">
-                <a:solidFill>
-                  <a:srgbClr val="3DD9EB"/>
-                </a:solidFill>
-                <a:latin typeface="Calibri" pitchFamily="34" charset="0"/>
-                <a:ea typeface="Calibri" pitchFamily="34" charset="-122"/>
-                <a:cs typeface="Calibri" pitchFamily="34" charset="-120"/>
-              </a:rPr>
-              <a:t>‫הוצאת ‪PO‬‬</a:t>
-            </a:r>
-            <a:endParaRPr lang="he-IL" sz="2400" dirty="0"/>
-          </a:p>
-        </p:txBody>
-      </p:sp>
-      <p:sp>
-        <p:nvSpPr>
-          <p:cNvPr id="13" name="Text 11"/>
-          <p:cNvSpPr/>
-          <p:nvPr/>
-        </p:nvSpPr>
-        <p:spPr>
-          <a:xfrm>
-            <a:off x="4748479" y="2907792"/>
-            <a:ext cx="2688336" cy="237744"/>
-          </a:xfrm>
-          <a:prstGeom prst="rect">
-            <a:avLst/>
-          </a:prstGeom>
-          <a:noFill/>
-          <a:ln/>
-        </p:spPr>
-        <p:txBody>
-          <a:bodyPr wrap="square" lIns="0" tIns="0" rIns="0" bIns="0" rtlCol="0" anchor="ctr"/>
-          <a:lstStyle/>
-          <a:p>
-            <a:pPr rtl="1" algn="r" indent="0" marL="0">
-              <a:lnSpc>
-                <a:spcPct val="100000"/>
-              </a:lnSpc>
-              <a:buNone/>
-            </a:pPr>
-            <a:r>
-              <a:rPr lang="he-IL" altLang="en-US" sz="1100" dirty="0">
-                <a:solidFill>
-                  <a:srgbClr val="5E6E85"/>
-                </a:solidFill>
-                <a:latin typeface="Calibri" pitchFamily="34" charset="0"/>
-                <a:ea typeface="Calibri" pitchFamily="34" charset="-122"/>
-                <a:cs typeface="Calibri" pitchFamily="34" charset="-120"/>
-              </a:rPr>
-              <a:t>‫חודשיים זמן אספקה מ-‪Dell‬‬</a:t>
-            </a:r>
-            <a:endParaRPr lang="he-IL" sz="1100" dirty="0"/>
-          </a:p>
-        </p:txBody>
-      </p:sp>
-      <p:sp>
-        <p:nvSpPr>
-          <p:cNvPr id="14" name="Text 12"/>
-          <p:cNvSpPr/>
-          <p:nvPr/>
-        </p:nvSpPr>
-        <p:spPr>
-          <a:xfrm>
-            <a:off x="4016959" y="2450592"/>
-            <a:ext cx="475488" cy="365760"/>
-          </a:xfrm>
-          <a:prstGeom prst="rect">
-            <a:avLst/>
-          </a:prstGeom>
-          <a:noFill/>
-          <a:ln/>
-        </p:spPr>
-        <p:txBody>
-          <a:bodyPr wrap="square" lIns="0" tIns="0" rIns="0" bIns="0" rtlCol="0" anchor="ctr"/>
-          <a:lstStyle/>
-          <a:p>
-            <a:pPr algn="ctr" indent="0" marL="0">
-              <a:lnSpc>
-                <a:spcPct val="100000"/>
-              </a:lnSpc>
-              <a:buNone/>
-            </a:pPr>
-            <a:r>
-              <a:rPr lang="en-US" altLang="en-US" sz="1900" b="1" dirty="0">
-                <a:solidFill>
-                  <a:srgbClr val="5E6E85"/>
-                </a:solidFill>
-                <a:latin typeface="Calibri" pitchFamily="34" charset="0"/>
-                <a:ea typeface="Calibri" pitchFamily="34" charset="-122"/>
-                <a:cs typeface="Calibri" pitchFamily="34" charset="-120"/>
-              </a:rPr>
-              <a:t>←</a:t>
-            </a:r>
-            <a:endParaRPr lang="en-US" sz="1900" dirty="0"/>
-          </a:p>
-        </p:txBody>
-      </p:sp>
-      <p:sp>
-        <p:nvSpPr>
-          <p:cNvPr id="15" name="Shape 13"/>
-          <p:cNvSpPr/>
-          <p:nvPr/>
-        </p:nvSpPr>
-        <p:spPr>
-          <a:xfrm>
-            <a:off x="816559" y="2048256"/>
-            <a:ext cx="3200400" cy="1170432"/>
-          </a:xfrm>
-          <a:prstGeom prst="roundRect">
-            <a:avLst>
-              <a:gd name="adj" fmla="val 3906"/>
-            </a:avLst>
+          <p:cNvPr id="18" name="Shape 16"/>
+          <p:cNvSpPr/>
+          <p:nvPr/>
+        </p:nvSpPr>
+        <p:spPr>
+          <a:xfrm>
+            <a:off x="3966667" y="2139696"/>
+            <a:ext cx="50292" cy="1005840"/>
+          </a:xfrm>
+          <a:prstGeom prst="rect">
+            <a:avLst/>
           </a:prstGeom>
           <a:solidFill>
-            <a:srgbClr val="182133"/>
+            <a:srgbClr val="FF6B7A"/>
           </a:solidFill>
           <a:ln w="12700">
             <a:solidFill>
-              <a:srgbClr val="5A2A38"/>
+              <a:srgbClr val="FF6B7A"/>
             </a:solidFill>
             <a:prstDash val="solid"/>
           </a:ln>
@@ -4903,14 +4978,14 @@
       </p:sp>
       <p:sp>
         <p:nvSpPr>
-          <p:cNvPr id="16" name="Text 14"/>
-          <p:cNvSpPr/>
-          <p:nvPr/>
-        </p:nvSpPr>
-        <p:spPr>
-          <a:xfrm>
-            <a:off x="1072591" y="2212848"/>
-            <a:ext cx="2688336" cy="237744"/>
+          <p:cNvPr id="19" name="Text 17"/>
+          <p:cNvSpPr/>
+          <p:nvPr/>
+        </p:nvSpPr>
+        <p:spPr>
+          <a:xfrm>
+            <a:off x="1090879" y="2139696"/>
+            <a:ext cx="2633472" cy="237744"/>
           </a:xfrm>
           <a:prstGeom prst="rect">
             <a:avLst/>
@@ -4945,14 +5020,14 @@
       </p:sp>
       <p:sp>
         <p:nvSpPr>
-          <p:cNvPr id="17" name="Text 15"/>
-          <p:cNvSpPr/>
-          <p:nvPr/>
-        </p:nvSpPr>
-        <p:spPr>
-          <a:xfrm>
-            <a:off x="1072591" y="2468880"/>
-            <a:ext cx="2688336" cy="420624"/>
+          <p:cNvPr id="20" name="Text 18"/>
+          <p:cNvSpPr/>
+          <p:nvPr/>
+        </p:nvSpPr>
+        <p:spPr>
+          <a:xfrm>
+            <a:off x="1090879" y="2432304"/>
+            <a:ext cx="2633472" cy="457200"/>
           </a:xfrm>
           <a:prstGeom prst="rect">
             <a:avLst/>
@@ -4971,7 +5046,7 @@
               <a:buNone/>
             </a:pPr>
             <a:r>
-              <a:rPr lang="he-IL" altLang="en-US" sz="2400" b="1" dirty="0">
+              <a:rPr lang="he-IL" altLang="en-US" sz="2500" b="1" dirty="0">
                 <a:solidFill>
                   <a:srgbClr val="FF6B7A"/>
                 </a:solidFill>
@@ -4981,20 +5056,20 @@
               </a:rPr>
               <a:t>‫‪80%‬ ואספקה‬</a:t>
             </a:r>
-            <a:endParaRPr lang="he-IL" sz="2400" dirty="0"/>
-          </a:p>
-        </p:txBody>
-      </p:sp>
-      <p:sp>
-        <p:nvSpPr>
-          <p:cNvPr id="18" name="Text 16"/>
-          <p:cNvSpPr/>
-          <p:nvPr/>
-        </p:nvSpPr>
-        <p:spPr>
-          <a:xfrm>
-            <a:off x="1072591" y="2907792"/>
-            <a:ext cx="2688336" cy="237744"/>
+            <a:endParaRPr lang="he-IL" sz="2500" dirty="0"/>
+          </a:p>
+        </p:txBody>
+      </p:sp>
+      <p:sp>
+        <p:nvSpPr>
+          <p:cNvPr id="21" name="Text 19"/>
+          <p:cNvSpPr/>
+          <p:nvPr/>
+        </p:nvSpPr>
+        <p:spPr>
+          <a:xfrm>
+            <a:off x="1090879" y="2944368"/>
+            <a:ext cx="2633472" cy="256032"/>
           </a:xfrm>
           <a:prstGeom prst="rect">
             <a:avLst/>
@@ -5029,18 +5104,18 @@
       </p:sp>
       <p:sp>
         <p:nvSpPr>
-          <p:cNvPr id="19" name="Shape 17"/>
-          <p:cNvSpPr/>
-          <p:nvPr/>
-        </p:nvSpPr>
-        <p:spPr>
-          <a:xfrm>
-            <a:off x="6229807" y="3529584"/>
-            <a:ext cx="5138928" cy="1700784"/>
+          <p:cNvPr id="22" name="Shape 20"/>
+          <p:cNvSpPr/>
+          <p:nvPr/>
+        </p:nvSpPr>
+        <p:spPr>
+          <a:xfrm>
+            <a:off x="6229807" y="3657600"/>
+            <a:ext cx="5138928" cy="1847088"/>
           </a:xfrm>
           <a:prstGeom prst="roundRect">
             <a:avLst>
-              <a:gd name="adj" fmla="val 2688"/>
+              <a:gd name="adj" fmla="val 2475"/>
             </a:avLst>
           </a:prstGeom>
           <a:solidFill>
@@ -5056,13 +5131,13 @@
       </p:sp>
       <p:sp>
         <p:nvSpPr>
-          <p:cNvPr id="20" name="Text 18"/>
-          <p:cNvSpPr/>
-          <p:nvPr/>
-        </p:nvSpPr>
-        <p:spPr>
-          <a:xfrm>
-            <a:off x="10454335" y="3730752"/>
+          <p:cNvPr id="23" name="Text 21"/>
+          <p:cNvSpPr/>
+          <p:nvPr/>
+        </p:nvSpPr>
+        <p:spPr>
+          <a:xfrm>
+            <a:off x="10454335" y="3858768"/>
             <a:ext cx="640080" cy="384048"/>
           </a:xfrm>
           <a:prstGeom prst="rect">
@@ -5098,13 +5173,13 @@
       </p:sp>
       <p:sp>
         <p:nvSpPr>
-          <p:cNvPr id="21" name="Text 19"/>
-          <p:cNvSpPr/>
-          <p:nvPr/>
-        </p:nvSpPr>
-        <p:spPr>
-          <a:xfrm>
-            <a:off x="6540703" y="3749040"/>
+          <p:cNvPr id="24" name="Text 22"/>
+          <p:cNvSpPr/>
+          <p:nvPr/>
+        </p:nvSpPr>
+        <p:spPr>
+          <a:xfrm>
+            <a:off x="6540703" y="3877056"/>
             <a:ext cx="3822192" cy="365760"/>
           </a:xfrm>
           <a:prstGeom prst="rect">
@@ -5140,14 +5215,14 @@
       </p:sp>
       <p:sp>
         <p:nvSpPr>
-          <p:cNvPr id="22" name="Text 20"/>
-          <p:cNvSpPr/>
-          <p:nvPr/>
-        </p:nvSpPr>
-        <p:spPr>
-          <a:xfrm>
-            <a:off x="6540703" y="4169664"/>
-            <a:ext cx="4517136" cy="603504"/>
+          <p:cNvPr id="25" name="Text 23"/>
+          <p:cNvSpPr/>
+          <p:nvPr/>
+        </p:nvSpPr>
+        <p:spPr>
+          <a:xfrm>
+            <a:off x="6540703" y="4352544"/>
+            <a:ext cx="4517136" cy="786384"/>
           </a:xfrm>
           <a:prstGeom prst="rect">
             <a:avLst/>
@@ -5161,12 +5236,12 @@
           <a:p>
             <a:pPr rtl="1" algn="r" indent="0" marL="0">
               <a:lnSpc>
-                <a:spcPct val="122000"/>
-              </a:lnSpc>
-              <a:buNone/>
-            </a:pPr>
-            <a:r>
-              <a:rPr lang="he-IL" altLang="en-US" sz="1200" dirty="0">
+                <a:spcPct val="126000"/>
+              </a:lnSpc>
+              <a:buNone/>
+            </a:pPr>
+            <a:r>
+              <a:rPr lang="he-IL" altLang="en-US" sz="1250" dirty="0">
                 <a:solidFill>
                   <a:srgbClr val="91A0B7"/>
                 </a:solidFill>
@@ -5176,24 +5251,24 @@
               </a:rPr>
               <a:t>‫חציית ‪80%‬ מסכנת את זמינות המערכת. חודשיים אספקה מ-‪Dell‬ פירושם שהחלון להוצאת ‪PO‬ נסגר באוקטובר. הצעת ‪Dell‬ עומדת על ‪$695,520‬ עבור ‪600 TB‬ לוגי.‬</a:t>
             </a:r>
-            <a:endParaRPr lang="he-IL" sz="1200" dirty="0"/>
-          </a:p>
-        </p:txBody>
-      </p:sp>
-      <p:sp>
-        <p:nvSpPr>
-          <p:cNvPr id="23" name="Shape 21"/>
-          <p:cNvSpPr/>
-          <p:nvPr/>
-        </p:nvSpPr>
-        <p:spPr>
-          <a:xfrm>
-            <a:off x="6540703" y="4773168"/>
-            <a:ext cx="4517136" cy="329184"/>
+            <a:endParaRPr lang="he-IL" sz="1250" dirty="0"/>
+          </a:p>
+        </p:txBody>
+      </p:sp>
+      <p:sp>
+        <p:nvSpPr>
+          <p:cNvPr id="26" name="Shape 24"/>
+          <p:cNvSpPr/>
+          <p:nvPr/>
+        </p:nvSpPr>
+        <p:spPr>
+          <a:xfrm>
+            <a:off x="6540703" y="4992624"/>
+            <a:ext cx="4517136" cy="365760"/>
           </a:xfrm>
           <a:prstGeom prst="roundRect">
             <a:avLst>
-              <a:gd name="adj" fmla="val 44444"/>
+              <a:gd name="adj" fmla="val 40000"/>
             </a:avLst>
           </a:prstGeom>
           <a:solidFill>
@@ -5209,14 +5284,14 @@
       </p:sp>
       <p:sp>
         <p:nvSpPr>
-          <p:cNvPr id="24" name="Text 22"/>
-          <p:cNvSpPr/>
-          <p:nvPr/>
-        </p:nvSpPr>
-        <p:spPr>
-          <a:xfrm>
-            <a:off x="6687007" y="4773168"/>
-            <a:ext cx="4224528" cy="329184"/>
+          <p:cNvPr id="27" name="Text 25"/>
+          <p:cNvSpPr/>
+          <p:nvPr/>
+        </p:nvSpPr>
+        <p:spPr>
+          <a:xfrm>
+            <a:off x="6687007" y="4992624"/>
+            <a:ext cx="4224528" cy="365760"/>
           </a:xfrm>
           <a:prstGeom prst="rect">
             <a:avLst/>
@@ -5251,18 +5326,18 @@
       </p:sp>
       <p:sp>
         <p:nvSpPr>
-          <p:cNvPr id="25" name="Shape 23"/>
-          <p:cNvSpPr/>
-          <p:nvPr/>
-        </p:nvSpPr>
-        <p:spPr>
-          <a:xfrm>
-            <a:off x="822960" y="3529584"/>
-            <a:ext cx="5138928" cy="1700784"/>
+          <p:cNvPr id="28" name="Shape 26"/>
+          <p:cNvSpPr/>
+          <p:nvPr/>
+        </p:nvSpPr>
+        <p:spPr>
+          <a:xfrm>
+            <a:off x="822960" y="3657600"/>
+            <a:ext cx="5138928" cy="1847088"/>
           </a:xfrm>
           <a:prstGeom prst="roundRect">
             <a:avLst>
-              <a:gd name="adj" fmla="val 2688"/>
+              <a:gd name="adj" fmla="val 2475"/>
             </a:avLst>
           </a:prstGeom>
           <a:solidFill>
@@ -5278,13 +5353,13 @@
       </p:sp>
       <p:sp>
         <p:nvSpPr>
-          <p:cNvPr id="26" name="Text 24"/>
-          <p:cNvSpPr/>
-          <p:nvPr/>
-        </p:nvSpPr>
-        <p:spPr>
-          <a:xfrm>
-            <a:off x="5047488" y="3730752"/>
+          <p:cNvPr id="29" name="Text 27"/>
+          <p:cNvSpPr/>
+          <p:nvPr/>
+        </p:nvSpPr>
+        <p:spPr>
+          <a:xfrm>
+            <a:off x="5047488" y="3858768"/>
             <a:ext cx="640080" cy="384048"/>
           </a:xfrm>
           <a:prstGeom prst="rect">
@@ -5320,13 +5395,13 @@
       </p:sp>
       <p:sp>
         <p:nvSpPr>
-          <p:cNvPr id="27" name="Text 25"/>
-          <p:cNvSpPr/>
-          <p:nvPr/>
-        </p:nvSpPr>
-        <p:spPr>
-          <a:xfrm>
-            <a:off x="1133856" y="3749040"/>
+          <p:cNvPr id="30" name="Text 28"/>
+          <p:cNvSpPr/>
+          <p:nvPr/>
+        </p:nvSpPr>
+        <p:spPr>
+          <a:xfrm>
+            <a:off x="1133856" y="3877056"/>
             <a:ext cx="3822192" cy="365760"/>
           </a:xfrm>
           <a:prstGeom prst="rect">
@@ -5362,14 +5437,14 @@
       </p:sp>
       <p:sp>
         <p:nvSpPr>
-          <p:cNvPr id="28" name="Text 26"/>
-          <p:cNvSpPr/>
-          <p:nvPr/>
-        </p:nvSpPr>
-        <p:spPr>
-          <a:xfrm>
-            <a:off x="1133856" y="4169664"/>
-            <a:ext cx="4517136" cy="603504"/>
+          <p:cNvPr id="31" name="Text 29"/>
+          <p:cNvSpPr/>
+          <p:nvPr/>
+        </p:nvSpPr>
+        <p:spPr>
+          <a:xfrm>
+            <a:off x="1133856" y="4352544"/>
+            <a:ext cx="4517136" cy="786384"/>
           </a:xfrm>
           <a:prstGeom prst="rect">
             <a:avLst/>
@@ -5383,12 +5458,12 @@
           <a:p>
             <a:pPr rtl="1" algn="r" indent="0" marL="0">
               <a:lnSpc>
-                <a:spcPct val="122000"/>
-              </a:lnSpc>
-              <a:buNone/>
-            </a:pPr>
-            <a:r>
-              <a:rPr lang="he-IL" altLang="en-US" sz="1200" dirty="0">
+                <a:spcPct val="126000"/>
+              </a:lnSpc>
+              <a:buNone/>
+            </a:pPr>
+            <a:r>
+              <a:rPr lang="he-IL" altLang="en-US" sz="1250" dirty="0">
                 <a:solidFill>
                   <a:srgbClr val="91A0B7"/>
                 </a:solidFill>
@@ -5398,24 +5473,24 @@
               </a:rPr>
               <a:t>‫מפנה שטח ב-‪ECS‬ תוך שבועות, ללא ‪PO‬ וללא זמן אספקה. רץ במקביל לרכש ומקטין את הלחץ על הסף — אך אינו מחליף את הדיסקים ואינו עוצר את השעון.‬</a:t>
             </a:r>
-            <a:endParaRPr lang="he-IL" sz="1200" dirty="0"/>
-          </a:p>
-        </p:txBody>
-      </p:sp>
-      <p:sp>
-        <p:nvSpPr>
-          <p:cNvPr id="29" name="Shape 27"/>
-          <p:cNvSpPr/>
-          <p:nvPr/>
-        </p:nvSpPr>
-        <p:spPr>
-          <a:xfrm>
-            <a:off x="1133856" y="4773168"/>
-            <a:ext cx="4517136" cy="329184"/>
+            <a:endParaRPr lang="he-IL" sz="1250" dirty="0"/>
+          </a:p>
+        </p:txBody>
+      </p:sp>
+      <p:sp>
+        <p:nvSpPr>
+          <p:cNvPr id="32" name="Shape 30"/>
+          <p:cNvSpPr/>
+          <p:nvPr/>
+        </p:nvSpPr>
+        <p:spPr>
+          <a:xfrm>
+            <a:off x="1133856" y="4992624"/>
+            <a:ext cx="4517136" cy="365760"/>
           </a:xfrm>
           <a:prstGeom prst="roundRect">
             <a:avLst>
-              <a:gd name="adj" fmla="val 44444"/>
+              <a:gd name="adj" fmla="val 40000"/>
             </a:avLst>
           </a:prstGeom>
           <a:solidFill>
@@ -5431,14 +5506,14 @@
       </p:sp>
       <p:sp>
         <p:nvSpPr>
-          <p:cNvPr id="30" name="Text 28"/>
-          <p:cNvSpPr/>
-          <p:nvPr/>
-        </p:nvSpPr>
-        <p:spPr>
-          <a:xfrm>
-            <a:off x="1280160" y="4773168"/>
-            <a:ext cx="4224528" cy="329184"/>
+          <p:cNvPr id="33" name="Text 31"/>
+          <p:cNvSpPr/>
+          <p:nvPr/>
+        </p:nvSpPr>
+        <p:spPr>
+          <a:xfrm>
+            <a:off x="1280160" y="4992624"/>
+            <a:ext cx="4224528" cy="365760"/>
           </a:xfrm>
           <a:prstGeom prst="rect">
             <a:avLst/>
@@ -5473,7 +5548,7 @@
       </p:sp>
       <p:sp>
         <p:nvSpPr>
-          <p:cNvPr id="31" name="Shape 29"/>
+          <p:cNvPr id="34" name="Shape 32"/>
           <p:cNvSpPr/>
           <p:nvPr/>
         </p:nvSpPr>
@@ -5498,7 +5573,7 @@
       </p:sp>
       <p:sp>
         <p:nvSpPr>
-          <p:cNvPr id="32" name="Shape 30"/>
+          <p:cNvPr id="35" name="Shape 33"/>
           <p:cNvSpPr/>
           <p:nvPr/>
         </p:nvSpPr>
@@ -5523,7 +5598,7 @@
       </p:sp>
       <p:sp>
         <p:nvSpPr>
-          <p:cNvPr id="33" name="Text 31"/>
+          <p:cNvPr id="36" name="Text 34"/>
           <p:cNvSpPr/>
           <p:nvPr/>
         </p:nvSpPr>

</xml_diff>

<commit_message>
Reduce slide 2 to the two options
Drops the utilisation / PO / threshold timeline row. That chain is the subject of
slides 3 and 4, so repeating it on the decision slide only split the reader's
attention away from the two things being decided.

What is left is the two options at full size: option 01 (Dell capacity
expansion) and option 02 (archive to S3), each with a title rule, body copy at
14pt and its own approval chip. The Dell quote moved into option 01's body,
since the timeline card that used to carry it is gone.

Headline and footnote now frame the two paths rather than the capacity
arithmetic, keeping only the October PO deadline and pointing forward for the
rationale.

Co-Authored-By: Claude Opus 5 <noreply@anthropic.com>
Claude-Session: https://claude.ai/code/session_01MZnQ3bUVeTyJdPFvjg3J88
</commit_message>
<xml_diff>
--- a/presentations/ecs-to-s3/Harel_ECS_to_S3_CIO.pptx
+++ b/presentations/ecs-to-s3/Harel_ECS_to_S3_CIO.pptx
@@ -4445,7 +4445,7 @@
               <a:buNone/>
             </a:pPr>
             <a:r>
-              <a:rPr lang="he-IL" altLang="en-US" sz="2500" b="1" dirty="0">
+              <a:rPr lang="he-IL" altLang="en-US" sz="2600" b="1" dirty="0">
                 <a:solidFill>
                   <a:srgbClr val="F4F7FB"/>
                 </a:solidFill>
@@ -4453,9 +4453,9 @@
                 <a:ea typeface="Calibri" pitchFamily="34" charset="-122"/>
                 <a:cs typeface="Calibri" pitchFamily="34" charset="-120"/>
               </a:rPr>
-              <a:t>‫ה-‪PO‬ חייב לצאת באוקטובר ‪2026‬ — אחרת נגיע ל-‪80%‬ בדצמבר בלי דיסקים‬</a:t>
-            </a:r>
-            <a:endParaRPr lang="he-IL" sz="2500" dirty="0"/>
+              <a:t>‫שני מסלולים על השולחן — ושניהם צריכים תשובה עוד באוקטובר‬</a:t>
+            </a:r>
+            <a:endParaRPr lang="he-IL" sz="2600" dirty="0"/>
           </a:p>
         </p:txBody>
       </p:sp>
@@ -4492,16 +4492,150 @@
         </p:nvSpPr>
         <p:spPr>
           <a:xfrm>
-            <a:off x="8168335" y="1956816"/>
-            <a:ext cx="3200400" cy="1371600"/>
+            <a:off x="6229807" y="2560320"/>
+            <a:ext cx="5138928" cy="2761488"/>
           </a:xfrm>
           <a:prstGeom prst="roundRect">
             <a:avLst>
-              <a:gd name="adj" fmla="val 3333"/>
+              <a:gd name="adj" fmla="val 1656"/>
             </a:avLst>
           </a:prstGeom>
           <a:solidFill>
-            <a:srgbClr val="141C2C"/>
+            <a:srgbClr val="182133"/>
+          </a:solidFill>
+          <a:ln w="12700">
+            <a:solidFill>
+              <a:srgbClr val="5A4222"/>
+            </a:solidFill>
+            <a:prstDash val="solid"/>
+          </a:ln>
+        </p:spPr>
+      </p:sp>
+      <p:sp>
+        <p:nvSpPr>
+          <p:cNvPr id="6" name="Shape 4"/>
+          <p:cNvSpPr/>
+          <p:nvPr/>
+        </p:nvSpPr>
+        <p:spPr>
+          <a:xfrm>
+            <a:off x="11213287" y="2871216"/>
+            <a:ext cx="50292" cy="384048"/>
+          </a:xfrm>
+          <a:prstGeom prst="rect">
+            <a:avLst/>
+          </a:prstGeom>
+          <a:solidFill>
+            <a:srgbClr val="FF9F43"/>
+          </a:solidFill>
+          <a:ln w="12700">
+            <a:solidFill>
+              <a:srgbClr val="FF9F43"/>
+            </a:solidFill>
+            <a:prstDash val="solid"/>
+          </a:ln>
+        </p:spPr>
+      </p:sp>
+      <p:sp>
+        <p:nvSpPr>
+          <p:cNvPr id="7" name="Text 5"/>
+          <p:cNvSpPr/>
+          <p:nvPr/>
+        </p:nvSpPr>
+        <p:spPr>
+          <a:xfrm>
+            <a:off x="10234879" y="2852928"/>
+            <a:ext cx="658368" cy="420624"/>
+          </a:xfrm>
+          <a:prstGeom prst="rect">
+            <a:avLst/>
+          </a:prstGeom>
+          <a:noFill/>
+          <a:ln/>
+        </p:spPr>
+        <p:txBody>
+          <a:bodyPr wrap="square" lIns="0" tIns="0" rIns="0" bIns="0" rtlCol="0" anchor="ctr"/>
+          <a:lstStyle/>
+          <a:p>
+            <a:pPr algn="r" indent="0" marL="0">
+              <a:lnSpc>
+                <a:spcPct val="100000"/>
+              </a:lnSpc>
+              <a:buNone/>
+            </a:pPr>
+            <a:r>
+              <a:rPr lang="en-US" altLang="en-US" sz="2300" b="1" dirty="0">
+                <a:solidFill>
+                  <a:srgbClr val="FF9F43"/>
+                </a:solidFill>
+                <a:latin typeface="Calibri" pitchFamily="34" charset="0"/>
+                <a:ea typeface="Calibri" pitchFamily="34" charset="-122"/>
+                <a:cs typeface="Calibri" pitchFamily="34" charset="-120"/>
+              </a:rPr>
+              <a:t>01</a:t>
+            </a:r>
+            <a:endParaRPr lang="en-US" sz="2300" dirty="0"/>
+          </a:p>
+        </p:txBody>
+      </p:sp>
+      <p:sp>
+        <p:nvSpPr>
+          <p:cNvPr id="8" name="Text 6"/>
+          <p:cNvSpPr/>
+          <p:nvPr/>
+        </p:nvSpPr>
+        <p:spPr>
+          <a:xfrm>
+            <a:off x="6558991" y="2834640"/>
+            <a:ext cx="3566160" cy="457200"/>
+          </a:xfrm>
+          <a:prstGeom prst="rect">
+            <a:avLst/>
+          </a:prstGeom>
+          <a:noFill/>
+          <a:ln/>
+        </p:spPr>
+        <p:txBody>
+          <a:bodyPr wrap="square" lIns="0" tIns="0" rIns="0" bIns="0" rtlCol="0" anchor="ctr"/>
+          <a:lstStyle/>
+          <a:p>
+            <a:pPr rtl="1" algn="r" indent="0" marL="0">
+              <a:lnSpc>
+                <a:spcPct val="100000"/>
+              </a:lnSpc>
+              <a:buNone/>
+            </a:pPr>
+            <a:r>
+              <a:rPr lang="he-IL" altLang="en-US" sz="1800" b="1" dirty="0">
+                <a:solidFill>
+                  <a:srgbClr val="F4F7FB"/>
+                </a:solidFill>
+                <a:latin typeface="Calibri" pitchFamily="34" charset="0"/>
+                <a:ea typeface="Calibri" pitchFamily="34" charset="-122"/>
+                <a:cs typeface="Calibri" pitchFamily="34" charset="-120"/>
+              </a:rPr>
+              <a:t>‫הרחבת דיסקים ב-‪Dell ECS On-Prem‬‬</a:t>
+            </a:r>
+            <a:endParaRPr lang="he-IL" sz="1800" dirty="0"/>
+          </a:p>
+        </p:txBody>
+      </p:sp>
+      <p:sp>
+        <p:nvSpPr>
+          <p:cNvPr id="9" name="Shape 7"/>
+          <p:cNvSpPr/>
+          <p:nvPr/>
+        </p:nvSpPr>
+        <p:spPr>
+          <a:xfrm>
+            <a:off x="6558991" y="3438144"/>
+            <a:ext cx="4480560" cy="10973"/>
+          </a:xfrm>
+          <a:prstGeom prst="rect">
+            <a:avLst/>
+          </a:prstGeom>
+          <a:solidFill>
+            <a:srgbClr val="23304A"/>
           </a:solidFill>
           <a:ln w="12700">
             <a:solidFill>
@@ -4513,24 +4647,68 @@
       </p:sp>
       <p:sp>
         <p:nvSpPr>
-          <p:cNvPr id="6" name="Shape 4"/>
-          <p:cNvSpPr/>
-          <p:nvPr/>
-        </p:nvSpPr>
-        <p:spPr>
-          <a:xfrm>
-            <a:off x="11318443" y="2139696"/>
-            <a:ext cx="50292" cy="1005840"/>
-          </a:xfrm>
-          <a:prstGeom prst="rect">
-            <a:avLst/>
-          </a:prstGeom>
-          <a:solidFill>
-            <a:srgbClr val="FF9F43"/>
+          <p:cNvPr id="10" name="Text 8"/>
+          <p:cNvSpPr/>
+          <p:nvPr/>
+        </p:nvSpPr>
+        <p:spPr>
+          <a:xfrm>
+            <a:off x="6558991" y="3584448"/>
+            <a:ext cx="4480560" cy="1024128"/>
+          </a:xfrm>
+          <a:prstGeom prst="rect">
+            <a:avLst/>
+          </a:prstGeom>
+          <a:noFill/>
+          <a:ln/>
+        </p:spPr>
+        <p:txBody>
+          <a:bodyPr wrap="square" lIns="0" tIns="0" rIns="0" bIns="0" rtlCol="0" anchor="t"/>
+          <a:lstStyle/>
+          <a:p>
+            <a:pPr rtl="1" algn="r" indent="0" marL="0">
+              <a:lnSpc>
+                <a:spcPct val="134000"/>
+              </a:lnSpc>
+              <a:buNone/>
+            </a:pPr>
+            <a:r>
+              <a:rPr lang="he-IL" altLang="en-US" sz="1400" dirty="0">
+                <a:solidFill>
+                  <a:srgbClr val="91A0B7"/>
+                </a:solidFill>
+                <a:latin typeface="Calibri" pitchFamily="34" charset="0"/>
+                <a:ea typeface="Calibri" pitchFamily="34" charset="-122"/>
+                <a:cs typeface="Calibri" pitchFamily="34" charset="-120"/>
+              </a:rPr>
+              <a:t>‫רכש תוספת קיבולת מ-‪Dell‬. הצעה קיימת: ‪$695,520‬ עבור ‪600 TB‬ לוגי, כולל ‪Replica x3‬ בין שלושה אתרים. פתרון מוכר, בתוך המרכז שלנו — אך כרוך ב-‪PO‬, בזמן אספקה ובהוצאה הונית מלאה.‬</a:t>
+            </a:r>
+            <a:endParaRPr lang="he-IL" sz="1400" dirty="0"/>
+          </a:p>
+        </p:txBody>
+      </p:sp>
+      <p:sp>
+        <p:nvSpPr>
+          <p:cNvPr id="11" name="Shape 9"/>
+          <p:cNvSpPr/>
+          <p:nvPr/>
+        </p:nvSpPr>
+        <p:spPr>
+          <a:xfrm>
+            <a:off x="6558991" y="4626864"/>
+            <a:ext cx="4480560" cy="420624"/>
+          </a:xfrm>
+          <a:prstGeom prst="roundRect">
+            <a:avLst>
+              <a:gd name="adj" fmla="val 34783"/>
+            </a:avLst>
+          </a:prstGeom>
+          <a:solidFill>
+            <a:srgbClr val="3A2A12"/>
           </a:solidFill>
           <a:ln w="12700">
             <a:solidFill>
-              <a:srgbClr val="FF9F43"/>
+              <a:srgbClr val="3A2A12"/>
             </a:solidFill>
             <a:prstDash val="solid"/>
           </a:ln>
@@ -4538,14 +4716,14 @@
       </p:sp>
       <p:sp>
         <p:nvSpPr>
-          <p:cNvPr id="7" name="Text 5"/>
-          <p:cNvSpPr/>
-          <p:nvPr/>
-        </p:nvSpPr>
-        <p:spPr>
-          <a:xfrm>
-            <a:off x="8442655" y="2139696"/>
-            <a:ext cx="2633472" cy="237744"/>
+          <p:cNvPr id="12" name="Text 10"/>
+          <p:cNvSpPr/>
+          <p:nvPr/>
+        </p:nvSpPr>
+        <p:spPr>
+          <a:xfrm>
+            <a:off x="6705295" y="4626864"/>
+            <a:ext cx="4187952" cy="420624"/>
           </a:xfrm>
           <a:prstGeom prst="rect">
             <a:avLst/>
@@ -4564,49 +4742,7 @@
               <a:buNone/>
             </a:pPr>
             <a:r>
-              <a:rPr lang="he-IL" altLang="en-US" sz="1050" b="1" spc="80" kern="0" dirty="0">
-                <a:solidFill>
-                  <a:srgbClr val="91A0B7"/>
-                </a:solidFill>
-                <a:latin typeface="Calibri" pitchFamily="34" charset="0"/>
-                <a:ea typeface="Calibri" pitchFamily="34" charset="-122"/>
-                <a:cs typeface="Calibri" pitchFamily="34" charset="-120"/>
-              </a:rPr>
-              <a:t>‫היום · אוגוסט ‪2026‬‬</a:t>
-            </a:r>
-            <a:endParaRPr lang="he-IL" sz="1050" dirty="0"/>
-          </a:p>
-        </p:txBody>
-      </p:sp>
-      <p:sp>
-        <p:nvSpPr>
-          <p:cNvPr id="8" name="Text 6"/>
-          <p:cNvSpPr/>
-          <p:nvPr/>
-        </p:nvSpPr>
-        <p:spPr>
-          <a:xfrm>
-            <a:off x="8442655" y="2432304"/>
-            <a:ext cx="2633472" cy="457200"/>
-          </a:xfrm>
-          <a:prstGeom prst="rect">
-            <a:avLst/>
-          </a:prstGeom>
-          <a:noFill/>
-          <a:ln/>
-        </p:spPr>
-        <p:txBody>
-          <a:bodyPr wrap="square" lIns="0" tIns="0" rIns="0" bIns="0" rtlCol="0" anchor="ctr"/>
-          <a:lstStyle/>
-          <a:p>
-            <a:pPr rtl="1" algn="r" indent="0" marL="0">
-              <a:lnSpc>
-                <a:spcPct val="100000"/>
-              </a:lnSpc>
-              <a:buNone/>
-            </a:pPr>
-            <a:r>
-              <a:rPr lang="he-IL" altLang="en-US" sz="2500" b="1" dirty="0">
+              <a:rPr lang="he-IL" altLang="en-US" sz="1250" b="1" dirty="0">
                 <a:solidFill>
                   <a:srgbClr val="FF9F43"/>
                 </a:solidFill>
@@ -4614,118 +4750,34 @@
                 <a:ea typeface="Calibri" pitchFamily="34" charset="-122"/>
                 <a:cs typeface="Calibri" pitchFamily="34" charset="-120"/>
               </a:rPr>
-              <a:t>‫‪75%‬‬</a:t>
-            </a:r>
-            <a:endParaRPr lang="he-IL" sz="2500" dirty="0"/>
-          </a:p>
-        </p:txBody>
-      </p:sp>
-      <p:sp>
-        <p:nvSpPr>
-          <p:cNvPr id="9" name="Text 7"/>
-          <p:cNvSpPr/>
-          <p:nvPr/>
-        </p:nvSpPr>
-        <p:spPr>
-          <a:xfrm>
-            <a:off x="8442655" y="2944368"/>
-            <a:ext cx="2633472" cy="256032"/>
-          </a:xfrm>
-          <a:prstGeom prst="rect">
-            <a:avLst/>
-          </a:prstGeom>
-          <a:noFill/>
-          <a:ln/>
-        </p:spPr>
-        <p:txBody>
-          <a:bodyPr wrap="square" lIns="0" tIns="0" rIns="0" bIns="0" rtlCol="0" anchor="ctr"/>
-          <a:lstStyle/>
-          <a:p>
-            <a:pPr rtl="1" algn="r" indent="0" marL="0">
-              <a:lnSpc>
-                <a:spcPct val="100000"/>
-              </a:lnSpc>
-              <a:buNone/>
-            </a:pPr>
-            <a:r>
-              <a:rPr lang="he-IL" altLang="en-US" sz="1100" dirty="0">
-                <a:solidFill>
-                  <a:srgbClr val="5E6E85"/>
-                </a:solidFill>
-                <a:latin typeface="Calibri" pitchFamily="34" charset="0"/>
-                <a:ea typeface="Calibri" pitchFamily="34" charset="-122"/>
-                <a:cs typeface="Calibri" pitchFamily="34" charset="-120"/>
-              </a:rPr>
-              <a:t>‫‪687 TB‬ מתוך ‪916 TB‬ בשימוש‬</a:t>
-            </a:r>
-            <a:endParaRPr lang="he-IL" sz="1100" dirty="0"/>
-          </a:p>
-        </p:txBody>
-      </p:sp>
-      <p:sp>
-        <p:nvSpPr>
-          <p:cNvPr id="10" name="Text 8"/>
-          <p:cNvSpPr/>
-          <p:nvPr/>
-        </p:nvSpPr>
-        <p:spPr>
-          <a:xfrm>
-            <a:off x="7692847" y="2459736"/>
-            <a:ext cx="475488" cy="365760"/>
-          </a:xfrm>
-          <a:prstGeom prst="rect">
-            <a:avLst/>
-          </a:prstGeom>
-          <a:noFill/>
-          <a:ln/>
-        </p:spPr>
-        <p:txBody>
-          <a:bodyPr wrap="square" lIns="0" tIns="0" rIns="0" bIns="0" rtlCol="0" anchor="ctr"/>
-          <a:lstStyle/>
-          <a:p>
-            <a:pPr algn="ctr" indent="0" marL="0">
-              <a:lnSpc>
-                <a:spcPct val="100000"/>
-              </a:lnSpc>
-              <a:buNone/>
-            </a:pPr>
-            <a:r>
-              <a:rPr lang="en-US" altLang="en-US" sz="2100" b="1" dirty="0">
-                <a:solidFill>
-                  <a:srgbClr val="5E6E85"/>
-                </a:solidFill>
-                <a:latin typeface="Calibri" pitchFamily="34" charset="0"/>
-                <a:ea typeface="Calibri" pitchFamily="34" charset="-122"/>
-                <a:cs typeface="Calibri" pitchFamily="34" charset="-120"/>
-              </a:rPr>
-              <a:t>←</a:t>
-            </a:r>
-            <a:endParaRPr lang="en-US" sz="2100" dirty="0"/>
-          </a:p>
-        </p:txBody>
-      </p:sp>
-      <p:sp>
-        <p:nvSpPr>
-          <p:cNvPr id="11" name="Shape 9"/>
-          <p:cNvSpPr/>
-          <p:nvPr/>
-        </p:nvSpPr>
-        <p:spPr>
-          <a:xfrm>
-            <a:off x="4492447" y="1956816"/>
-            <a:ext cx="3200400" cy="1371600"/>
+              <a:t>‫נדרש: אישור תקציב ויציאה ל-‪PO‬ באוקטובר‬</a:t>
+            </a:r>
+            <a:endParaRPr lang="he-IL" sz="1250" dirty="0"/>
+          </a:p>
+        </p:txBody>
+      </p:sp>
+      <p:sp>
+        <p:nvSpPr>
+          <p:cNvPr id="13" name="Shape 11"/>
+          <p:cNvSpPr/>
+          <p:nvPr/>
+        </p:nvSpPr>
+        <p:spPr>
+          <a:xfrm>
+            <a:off x="822960" y="2560320"/>
+            <a:ext cx="5138928" cy="2761488"/>
           </a:xfrm>
           <a:prstGeom prst="roundRect">
             <a:avLst>
-              <a:gd name="adj" fmla="val 3333"/>
+              <a:gd name="adj" fmla="val 1656"/>
             </a:avLst>
           </a:prstGeom>
           <a:solidFill>
             <a:srgbClr val="182133"/>
           </a:solidFill>
-          <a:ln w="19050">
+          <a:ln w="12700">
             <a:solidFill>
-              <a:srgbClr val="3DD9EB"/>
+              <a:srgbClr val="2E5F6B"/>
             </a:solidFill>
             <a:prstDash val="solid"/>
           </a:ln>
@@ -4733,14 +4785,14 @@
       </p:sp>
       <p:sp>
         <p:nvSpPr>
-          <p:cNvPr id="12" name="Shape 10"/>
-          <p:cNvSpPr/>
-          <p:nvPr/>
-        </p:nvSpPr>
-        <p:spPr>
-          <a:xfrm>
-            <a:off x="7642555" y="2139696"/>
-            <a:ext cx="50292" cy="1005840"/>
+          <p:cNvPr id="14" name="Shape 12"/>
+          <p:cNvSpPr/>
+          <p:nvPr/>
+        </p:nvSpPr>
+        <p:spPr>
+          <a:xfrm>
+            <a:off x="5806440" y="2871216"/>
+            <a:ext cx="50292" cy="384048"/>
           </a:xfrm>
           <a:prstGeom prst="rect">
             <a:avLst/>
@@ -4758,14 +4810,14 @@
       </p:sp>
       <p:sp>
         <p:nvSpPr>
-          <p:cNvPr id="13" name="Text 11"/>
-          <p:cNvSpPr/>
-          <p:nvPr/>
-        </p:nvSpPr>
-        <p:spPr>
-          <a:xfrm>
-            <a:off x="4766767" y="2139696"/>
-            <a:ext cx="2633472" cy="237744"/>
+          <p:cNvPr id="15" name="Text 13"/>
+          <p:cNvSpPr/>
+          <p:nvPr/>
+        </p:nvSpPr>
+        <p:spPr>
+          <a:xfrm>
+            <a:off x="4828032" y="2852928"/>
+            <a:ext cx="658368" cy="420624"/>
           </a:xfrm>
           <a:prstGeom prst="rect">
             <a:avLst/>
@@ -4777,37 +4829,37 @@
           <a:bodyPr wrap="square" lIns="0" tIns="0" rIns="0" bIns="0" rtlCol="0" anchor="ctr"/>
           <a:lstStyle/>
           <a:p>
-            <a:pPr rtl="1" algn="r" indent="0" marL="0">
+            <a:pPr algn="r" indent="0" marL="0">
               <a:lnSpc>
                 <a:spcPct val="100000"/>
               </a:lnSpc>
               <a:buNone/>
             </a:pPr>
             <a:r>
-              <a:rPr lang="he-IL" altLang="en-US" sz="1050" b="1" spc="80" kern="0" dirty="0">
-                <a:solidFill>
-                  <a:srgbClr val="91A0B7"/>
-                </a:solidFill>
-                <a:latin typeface="Calibri" pitchFamily="34" charset="0"/>
-                <a:ea typeface="Calibri" pitchFamily="34" charset="-122"/>
-                <a:cs typeface="Calibri" pitchFamily="34" charset="-120"/>
-              </a:rPr>
-              <a:t>‫אוקטובר ‪2026‬‬</a:t>
-            </a:r>
-            <a:endParaRPr lang="he-IL" sz="1050" dirty="0"/>
-          </a:p>
-        </p:txBody>
-      </p:sp>
-      <p:sp>
-        <p:nvSpPr>
-          <p:cNvPr id="14" name="Text 12"/>
-          <p:cNvSpPr/>
-          <p:nvPr/>
-        </p:nvSpPr>
-        <p:spPr>
-          <a:xfrm>
-            <a:off x="4766767" y="2432304"/>
-            <a:ext cx="2633472" cy="457200"/>
+              <a:rPr lang="en-US" altLang="en-US" sz="2300" b="1" dirty="0">
+                <a:solidFill>
+                  <a:srgbClr val="3DD9EB"/>
+                </a:solidFill>
+                <a:latin typeface="Calibri" pitchFamily="34" charset="0"/>
+                <a:ea typeface="Calibri" pitchFamily="34" charset="-122"/>
+                <a:cs typeface="Calibri" pitchFamily="34" charset="-120"/>
+              </a:rPr>
+              <a:t>02</a:t>
+            </a:r>
+            <a:endParaRPr lang="en-US" sz="2300" dirty="0"/>
+          </a:p>
+        </p:txBody>
+      </p:sp>
+      <p:sp>
+        <p:nvSpPr>
+          <p:cNvPr id="16" name="Text 14"/>
+          <p:cNvSpPr/>
+          <p:nvPr/>
+        </p:nvSpPr>
+        <p:spPr>
+          <a:xfrm>
+            <a:off x="1152144" y="2834640"/>
+            <a:ext cx="3566160" cy="457200"/>
           </a:xfrm>
           <a:prstGeom prst="rect">
             <a:avLst/>
@@ -4826,101 +4878,17 @@
               <a:buNone/>
             </a:pPr>
             <a:r>
-              <a:rPr lang="he-IL" altLang="en-US" sz="2500" b="1" dirty="0">
-                <a:solidFill>
-                  <a:srgbClr val="3DD9EB"/>
-                </a:solidFill>
-                <a:latin typeface="Calibri" pitchFamily="34" charset="0"/>
-                <a:ea typeface="Calibri" pitchFamily="34" charset="-122"/>
-                <a:cs typeface="Calibri" pitchFamily="34" charset="-120"/>
-              </a:rPr>
-              <a:t>‫הוצאת ‪PO‬‬</a:t>
-            </a:r>
-            <a:endParaRPr lang="he-IL" sz="2500" dirty="0"/>
-          </a:p>
-        </p:txBody>
-      </p:sp>
-      <p:sp>
-        <p:nvSpPr>
-          <p:cNvPr id="15" name="Text 13"/>
-          <p:cNvSpPr/>
-          <p:nvPr/>
-        </p:nvSpPr>
-        <p:spPr>
-          <a:xfrm>
-            <a:off x="4766767" y="2944368"/>
-            <a:ext cx="2633472" cy="256032"/>
-          </a:xfrm>
-          <a:prstGeom prst="rect">
-            <a:avLst/>
-          </a:prstGeom>
-          <a:noFill/>
-          <a:ln/>
-        </p:spPr>
-        <p:txBody>
-          <a:bodyPr wrap="square" lIns="0" tIns="0" rIns="0" bIns="0" rtlCol="0" anchor="ctr"/>
-          <a:lstStyle/>
-          <a:p>
-            <a:pPr rtl="1" algn="r" indent="0" marL="0">
-              <a:lnSpc>
-                <a:spcPct val="100000"/>
-              </a:lnSpc>
-              <a:buNone/>
-            </a:pPr>
-            <a:r>
-              <a:rPr lang="he-IL" altLang="en-US" sz="1100" dirty="0">
-                <a:solidFill>
-                  <a:srgbClr val="5E6E85"/>
-                </a:solidFill>
-                <a:latin typeface="Calibri" pitchFamily="34" charset="0"/>
-                <a:ea typeface="Calibri" pitchFamily="34" charset="-122"/>
-                <a:cs typeface="Calibri" pitchFamily="34" charset="-120"/>
-              </a:rPr>
-              <a:t>‫חודשיים זמן אספקה מ-‪Dell‬‬</a:t>
-            </a:r>
-            <a:endParaRPr lang="he-IL" sz="1100" dirty="0"/>
-          </a:p>
-        </p:txBody>
-      </p:sp>
-      <p:sp>
-        <p:nvSpPr>
-          <p:cNvPr id="16" name="Text 14"/>
-          <p:cNvSpPr/>
-          <p:nvPr/>
-        </p:nvSpPr>
-        <p:spPr>
-          <a:xfrm>
-            <a:off x="4016959" y="2459736"/>
-            <a:ext cx="475488" cy="365760"/>
-          </a:xfrm>
-          <a:prstGeom prst="rect">
-            <a:avLst/>
-          </a:prstGeom>
-          <a:noFill/>
-          <a:ln/>
-        </p:spPr>
-        <p:txBody>
-          <a:bodyPr wrap="square" lIns="0" tIns="0" rIns="0" bIns="0" rtlCol="0" anchor="ctr"/>
-          <a:lstStyle/>
-          <a:p>
-            <a:pPr algn="ctr" indent="0" marL="0">
-              <a:lnSpc>
-                <a:spcPct val="100000"/>
-              </a:lnSpc>
-              <a:buNone/>
-            </a:pPr>
-            <a:r>
-              <a:rPr lang="en-US" altLang="en-US" sz="2100" b="1" dirty="0">
-                <a:solidFill>
-                  <a:srgbClr val="5E6E85"/>
-                </a:solidFill>
-                <a:latin typeface="Calibri" pitchFamily="34" charset="0"/>
-                <a:ea typeface="Calibri" pitchFamily="34" charset="-122"/>
-                <a:cs typeface="Calibri" pitchFamily="34" charset="-120"/>
-              </a:rPr>
-              <a:t>←</a:t>
-            </a:r>
-            <a:endParaRPr lang="en-US" sz="2100" dirty="0"/>
+              <a:rPr lang="he-IL" altLang="en-US" sz="1800" b="1" dirty="0">
+                <a:solidFill>
+                  <a:srgbClr val="F4F7FB"/>
+                </a:solidFill>
+                <a:latin typeface="Calibri" pitchFamily="34" charset="0"/>
+                <a:ea typeface="Calibri" pitchFamily="34" charset="-122"/>
+                <a:cs typeface="Calibri" pitchFamily="34" charset="-120"/>
+              </a:rPr>
+              <a:t>‫העתקת מסמכי דימות ו-‪Verint‬ ל-‪AWS S3‬‬</a:t>
+            </a:r>
+            <a:endParaRPr lang="he-IL" sz="1800" dirty="0"/>
           </a:p>
         </p:txBody>
       </p:sp>
@@ -4932,16 +4900,14 @@
         </p:nvSpPr>
         <p:spPr>
           <a:xfrm>
-            <a:off x="816559" y="1956816"/>
-            <a:ext cx="3200400" cy="1371600"/>
-          </a:xfrm>
-          <a:prstGeom prst="roundRect">
-            <a:avLst>
-              <a:gd name="adj" fmla="val 3333"/>
-            </a:avLst>
-          </a:prstGeom>
-          <a:solidFill>
-            <a:srgbClr val="141C2C"/>
+            <a:off x="1152144" y="3438144"/>
+            <a:ext cx="4480560" cy="10973"/>
+          </a:xfrm>
+          <a:prstGeom prst="rect">
+            <a:avLst/>
+          </a:prstGeom>
+          <a:solidFill>
+            <a:srgbClr val="23304A"/>
           </a:solidFill>
           <a:ln w="12700">
             <a:solidFill>
@@ -4953,14 +4919,150 @@
       </p:sp>
       <p:sp>
         <p:nvSpPr>
-          <p:cNvPr id="18" name="Shape 16"/>
-          <p:cNvSpPr/>
-          <p:nvPr/>
-        </p:nvSpPr>
-        <p:spPr>
-          <a:xfrm>
-            <a:off x="3966667" y="2139696"/>
-            <a:ext cx="50292" cy="1005840"/>
+          <p:cNvPr id="18" name="Text 16"/>
+          <p:cNvSpPr/>
+          <p:nvPr/>
+        </p:nvSpPr>
+        <p:spPr>
+          <a:xfrm>
+            <a:off x="1152144" y="3584448"/>
+            <a:ext cx="4480560" cy="1024128"/>
+          </a:xfrm>
+          <a:prstGeom prst="rect">
+            <a:avLst/>
+          </a:prstGeom>
+          <a:noFill/>
+          <a:ln/>
+        </p:spPr>
+        <p:txBody>
+          <a:bodyPr wrap="square" lIns="0" tIns="0" rIns="0" bIns="0" rtlCol="0" anchor="t"/>
+          <a:lstStyle/>
+          <a:p>
+            <a:pPr rtl="1" algn="r" indent="0" marL="0">
+              <a:lnSpc>
+                <a:spcPct val="134000"/>
+              </a:lnSpc>
+              <a:buNone/>
+            </a:pPr>
+            <a:r>
+              <a:rPr lang="he-IL" altLang="en-US" sz="1400" dirty="0">
+                <a:solidFill>
+                  <a:srgbClr val="91A0B7"/>
+                </a:solidFill>
+                <a:latin typeface="Calibri" pitchFamily="34" charset="0"/>
+                <a:ea typeface="Calibri" pitchFamily="34" charset="-122"/>
+                <a:cs typeface="Calibri" pitchFamily="34" charset="-120"/>
+              </a:rPr>
+              <a:t>‫העברת הארכיון לאחסון אובייקטים בענן. מפנה שטח ב-‪ECS‬ תוך שבועות, ללא ‪PO‬ וללא זמן אספקה, בתשלום לפי צריכה. רץ במקביל לרכש — אך אינו מחליף את הדיסקים.‬</a:t>
+            </a:r>
+            <a:endParaRPr lang="he-IL" sz="1400" dirty="0"/>
+          </a:p>
+        </p:txBody>
+      </p:sp>
+      <p:sp>
+        <p:nvSpPr>
+          <p:cNvPr id="19" name="Shape 17"/>
+          <p:cNvSpPr/>
+          <p:nvPr/>
+        </p:nvSpPr>
+        <p:spPr>
+          <a:xfrm>
+            <a:off x="1152144" y="4626864"/>
+            <a:ext cx="4480560" cy="420624"/>
+          </a:xfrm>
+          <a:prstGeom prst="roundRect">
+            <a:avLst>
+              <a:gd name="adj" fmla="val 34783"/>
+            </a:avLst>
+          </a:prstGeom>
+          <a:solidFill>
+            <a:srgbClr val="13303A"/>
+          </a:solidFill>
+          <a:ln w="12700">
+            <a:solidFill>
+              <a:srgbClr val="13303A"/>
+            </a:solidFill>
+            <a:prstDash val="solid"/>
+          </a:ln>
+        </p:spPr>
+      </p:sp>
+      <p:sp>
+        <p:nvSpPr>
+          <p:cNvPr id="20" name="Text 18"/>
+          <p:cNvSpPr/>
+          <p:nvPr/>
+        </p:nvSpPr>
+        <p:spPr>
+          <a:xfrm>
+            <a:off x="1298448" y="4626864"/>
+            <a:ext cx="4187952" cy="420624"/>
+          </a:xfrm>
+          <a:prstGeom prst="rect">
+            <a:avLst/>
+          </a:prstGeom>
+          <a:noFill/>
+          <a:ln/>
+        </p:spPr>
+        <p:txBody>
+          <a:bodyPr wrap="square" lIns="0" tIns="0" rIns="0" bIns="0" rtlCol="0" anchor="ctr"/>
+          <a:lstStyle/>
+          <a:p>
+            <a:pPr rtl="1" algn="r" indent="0" marL="0">
+              <a:lnSpc>
+                <a:spcPct val="100000"/>
+              </a:lnSpc>
+              <a:buNone/>
+            </a:pPr>
+            <a:r>
+              <a:rPr lang="he-IL" altLang="en-US" sz="1250" b="1" dirty="0">
+                <a:solidFill>
+                  <a:srgbClr val="3DD9EB"/>
+                </a:solidFill>
+                <a:latin typeface="Calibri" pitchFamily="34" charset="0"/>
+                <a:ea typeface="Calibri" pitchFamily="34" charset="-122"/>
+                <a:cs typeface="Calibri" pitchFamily="34" charset="-120"/>
+              </a:rPr>
+              <a:t>‫נדרש: אישור עקרוני + תקציב ‪POC‬‬</a:t>
+            </a:r>
+            <a:endParaRPr lang="he-IL" sz="1250" dirty="0"/>
+          </a:p>
+        </p:txBody>
+      </p:sp>
+      <p:sp>
+        <p:nvSpPr>
+          <p:cNvPr id="21" name="Shape 19"/>
+          <p:cNvSpPr/>
+          <p:nvPr/>
+        </p:nvSpPr>
+        <p:spPr>
+          <a:xfrm>
+            <a:off x="822960" y="5907024"/>
+            <a:ext cx="10545775" cy="10973"/>
+          </a:xfrm>
+          <a:prstGeom prst="rect">
+            <a:avLst/>
+          </a:prstGeom>
+          <a:solidFill>
+            <a:srgbClr val="23304A"/>
+          </a:solidFill>
+          <a:ln w="12700">
+            <a:solidFill>
+              <a:srgbClr val="23304A"/>
+            </a:solidFill>
+            <a:prstDash val="solid"/>
+          </a:ln>
+        </p:spPr>
+      </p:sp>
+      <p:sp>
+        <p:nvSpPr>
+          <p:cNvPr id="22" name="Shape 20"/>
+          <p:cNvSpPr/>
+          <p:nvPr/>
+        </p:nvSpPr>
+        <p:spPr>
+          <a:xfrm>
+            <a:off x="11249863" y="6172200"/>
+            <a:ext cx="118872" cy="118872"/>
           </a:xfrm>
           <a:prstGeom prst="rect">
             <a:avLst/>
@@ -4978,627 +5080,7 @@
       </p:sp>
       <p:sp>
         <p:nvSpPr>
-          <p:cNvPr id="19" name="Text 17"/>
-          <p:cNvSpPr/>
-          <p:nvPr/>
-        </p:nvSpPr>
-        <p:spPr>
-          <a:xfrm>
-            <a:off x="1090879" y="2139696"/>
-            <a:ext cx="2633472" cy="237744"/>
-          </a:xfrm>
-          <a:prstGeom prst="rect">
-            <a:avLst/>
-          </a:prstGeom>
-          <a:noFill/>
-          <a:ln/>
-        </p:spPr>
-        <p:txBody>
-          <a:bodyPr wrap="square" lIns="0" tIns="0" rIns="0" bIns="0" rtlCol="0" anchor="ctr"/>
-          <a:lstStyle/>
-          <a:p>
-            <a:pPr rtl="1" algn="r" indent="0" marL="0">
-              <a:lnSpc>
-                <a:spcPct val="100000"/>
-              </a:lnSpc>
-              <a:buNone/>
-            </a:pPr>
-            <a:r>
-              <a:rPr lang="he-IL" altLang="en-US" sz="1050" b="1" spc="80" kern="0" dirty="0">
-                <a:solidFill>
-                  <a:srgbClr val="91A0B7"/>
-                </a:solidFill>
-                <a:latin typeface="Calibri" pitchFamily="34" charset="0"/>
-                <a:ea typeface="Calibri" pitchFamily="34" charset="-122"/>
-                <a:cs typeface="Calibri" pitchFamily="34" charset="-120"/>
-              </a:rPr>
-              <a:t>‫דצמבר ‪2026‬‬</a:t>
-            </a:r>
-            <a:endParaRPr lang="he-IL" sz="1050" dirty="0"/>
-          </a:p>
-        </p:txBody>
-      </p:sp>
-      <p:sp>
-        <p:nvSpPr>
-          <p:cNvPr id="20" name="Text 18"/>
-          <p:cNvSpPr/>
-          <p:nvPr/>
-        </p:nvSpPr>
-        <p:spPr>
-          <a:xfrm>
-            <a:off x="1090879" y="2432304"/>
-            <a:ext cx="2633472" cy="457200"/>
-          </a:xfrm>
-          <a:prstGeom prst="rect">
-            <a:avLst/>
-          </a:prstGeom>
-          <a:noFill/>
-          <a:ln/>
-        </p:spPr>
-        <p:txBody>
-          <a:bodyPr wrap="square" lIns="0" tIns="0" rIns="0" bIns="0" rtlCol="0" anchor="ctr"/>
-          <a:lstStyle/>
-          <a:p>
-            <a:pPr rtl="1" algn="r" indent="0" marL="0">
-              <a:lnSpc>
-                <a:spcPct val="100000"/>
-              </a:lnSpc>
-              <a:buNone/>
-            </a:pPr>
-            <a:r>
-              <a:rPr lang="he-IL" altLang="en-US" sz="2500" b="1" dirty="0">
-                <a:solidFill>
-                  <a:srgbClr val="FF6B7A"/>
-                </a:solidFill>
-                <a:latin typeface="Calibri" pitchFamily="34" charset="0"/>
-                <a:ea typeface="Calibri" pitchFamily="34" charset="-122"/>
-                <a:cs typeface="Calibri" pitchFamily="34" charset="-120"/>
-              </a:rPr>
-              <a:t>‫‪80%‬ ואספקה‬</a:t>
-            </a:r>
-            <a:endParaRPr lang="he-IL" sz="2500" dirty="0"/>
-          </a:p>
-        </p:txBody>
-      </p:sp>
-      <p:sp>
-        <p:nvSpPr>
-          <p:cNvPr id="21" name="Text 19"/>
-          <p:cNvSpPr/>
-          <p:nvPr/>
-        </p:nvSpPr>
-        <p:spPr>
-          <a:xfrm>
-            <a:off x="1090879" y="2944368"/>
-            <a:ext cx="2633472" cy="256032"/>
-          </a:xfrm>
-          <a:prstGeom prst="rect">
-            <a:avLst/>
-          </a:prstGeom>
-          <a:noFill/>
-          <a:ln/>
-        </p:spPr>
-        <p:txBody>
-          <a:bodyPr wrap="square" lIns="0" tIns="0" rIns="0" bIns="0" rtlCol="0" anchor="ctr"/>
-          <a:lstStyle/>
-          <a:p>
-            <a:pPr rtl="1" algn="r" indent="0" marL="0">
-              <a:lnSpc>
-                <a:spcPct val="100000"/>
-              </a:lnSpc>
-              <a:buNone/>
-            </a:pPr>
-            <a:r>
-              <a:rPr lang="he-IL" altLang="en-US" sz="1100" dirty="0">
-                <a:solidFill>
-                  <a:srgbClr val="5E6E85"/>
-                </a:solidFill>
-                <a:latin typeface="Calibri" pitchFamily="34" charset="0"/>
-                <a:ea typeface="Calibri" pitchFamily="34" charset="-122"/>
-                <a:cs typeface="Calibri" pitchFamily="34" charset="-120"/>
-              </a:rPr>
-              <a:t>‫הדיסקים מגיעים בדיוק בזמן‬</a:t>
-            </a:r>
-            <a:endParaRPr lang="he-IL" sz="1100" dirty="0"/>
-          </a:p>
-        </p:txBody>
-      </p:sp>
-      <p:sp>
-        <p:nvSpPr>
-          <p:cNvPr id="22" name="Shape 20"/>
-          <p:cNvSpPr/>
-          <p:nvPr/>
-        </p:nvSpPr>
-        <p:spPr>
-          <a:xfrm>
-            <a:off x="6229807" y="3657600"/>
-            <a:ext cx="5138928" cy="1847088"/>
-          </a:xfrm>
-          <a:prstGeom prst="roundRect">
-            <a:avLst>
-              <a:gd name="adj" fmla="val 2475"/>
-            </a:avLst>
-          </a:prstGeom>
-          <a:solidFill>
-            <a:srgbClr val="182133"/>
-          </a:solidFill>
-          <a:ln w="12700">
-            <a:solidFill>
-              <a:srgbClr val="5A4222"/>
-            </a:solidFill>
-            <a:prstDash val="solid"/>
-          </a:ln>
-        </p:spPr>
-      </p:sp>
-      <p:sp>
-        <p:nvSpPr>
           <p:cNvPr id="23" name="Text 21"/>
-          <p:cNvSpPr/>
-          <p:nvPr/>
-        </p:nvSpPr>
-        <p:spPr>
-          <a:xfrm>
-            <a:off x="10454335" y="3858768"/>
-            <a:ext cx="640080" cy="384048"/>
-          </a:xfrm>
-          <a:prstGeom prst="rect">
-            <a:avLst/>
-          </a:prstGeom>
-          <a:noFill/>
-          <a:ln/>
-        </p:spPr>
-        <p:txBody>
-          <a:bodyPr wrap="square" lIns="0" tIns="0" rIns="0" bIns="0" rtlCol="0" anchor="ctr"/>
-          <a:lstStyle/>
-          <a:p>
-            <a:pPr algn="r" indent="0" marL="0">
-              <a:lnSpc>
-                <a:spcPct val="100000"/>
-              </a:lnSpc>
-              <a:buNone/>
-            </a:pPr>
-            <a:r>
-              <a:rPr lang="en-US" altLang="en-US" sz="2100" b="1" dirty="0">
-                <a:solidFill>
-                  <a:srgbClr val="FF9F43"/>
-                </a:solidFill>
-                <a:latin typeface="Calibri" pitchFamily="34" charset="0"/>
-                <a:ea typeface="Calibri" pitchFamily="34" charset="-122"/>
-                <a:cs typeface="Calibri" pitchFamily="34" charset="-120"/>
-              </a:rPr>
-              <a:t>01</a:t>
-            </a:r>
-            <a:endParaRPr lang="en-US" sz="2100" dirty="0"/>
-          </a:p>
-        </p:txBody>
-      </p:sp>
-      <p:sp>
-        <p:nvSpPr>
-          <p:cNvPr id="24" name="Text 22"/>
-          <p:cNvSpPr/>
-          <p:nvPr/>
-        </p:nvSpPr>
-        <p:spPr>
-          <a:xfrm>
-            <a:off x="6540703" y="3877056"/>
-            <a:ext cx="3822192" cy="365760"/>
-          </a:xfrm>
-          <a:prstGeom prst="rect">
-            <a:avLst/>
-          </a:prstGeom>
-          <a:noFill/>
-          <a:ln/>
-        </p:spPr>
-        <p:txBody>
-          <a:bodyPr wrap="square" lIns="0" tIns="0" rIns="0" bIns="0" rtlCol="0" anchor="ctr"/>
-          <a:lstStyle/>
-          <a:p>
-            <a:pPr rtl="1" algn="r" indent="0" marL="0">
-              <a:lnSpc>
-                <a:spcPct val="100000"/>
-              </a:lnSpc>
-              <a:buNone/>
-            </a:pPr>
-            <a:r>
-              <a:rPr lang="he-IL" altLang="en-US" sz="1600" b="1" dirty="0">
-                <a:solidFill>
-                  <a:srgbClr val="F4F7FB"/>
-                </a:solidFill>
-                <a:latin typeface="Calibri" pitchFamily="34" charset="0"/>
-                <a:ea typeface="Calibri" pitchFamily="34" charset="-122"/>
-                <a:cs typeface="Calibri" pitchFamily="34" charset="-120"/>
-              </a:rPr>
-              <a:t>‫הרחבת דיסקים ב-‪Dell ECS On-Prem‬‬</a:t>
-            </a:r>
-            <a:endParaRPr lang="he-IL" sz="1600" dirty="0"/>
-          </a:p>
-        </p:txBody>
-      </p:sp>
-      <p:sp>
-        <p:nvSpPr>
-          <p:cNvPr id="25" name="Text 23"/>
-          <p:cNvSpPr/>
-          <p:nvPr/>
-        </p:nvSpPr>
-        <p:spPr>
-          <a:xfrm>
-            <a:off x="6540703" y="4352544"/>
-            <a:ext cx="4517136" cy="786384"/>
-          </a:xfrm>
-          <a:prstGeom prst="rect">
-            <a:avLst/>
-          </a:prstGeom>
-          <a:noFill/>
-          <a:ln/>
-        </p:spPr>
-        <p:txBody>
-          <a:bodyPr wrap="square" lIns="0" tIns="0" rIns="0" bIns="0" rtlCol="0" anchor="t"/>
-          <a:lstStyle/>
-          <a:p>
-            <a:pPr rtl="1" algn="r" indent="0" marL="0">
-              <a:lnSpc>
-                <a:spcPct val="126000"/>
-              </a:lnSpc>
-              <a:buNone/>
-            </a:pPr>
-            <a:r>
-              <a:rPr lang="he-IL" altLang="en-US" sz="1250" dirty="0">
-                <a:solidFill>
-                  <a:srgbClr val="91A0B7"/>
-                </a:solidFill>
-                <a:latin typeface="Calibri" pitchFamily="34" charset="0"/>
-                <a:ea typeface="Calibri" pitchFamily="34" charset="-122"/>
-                <a:cs typeface="Calibri" pitchFamily="34" charset="-120"/>
-              </a:rPr>
-              <a:t>‫חציית ‪80%‬ מסכנת את זמינות המערכת. חודשיים אספקה מ-‪Dell‬ פירושם שהחלון להוצאת ‪PO‬ נסגר באוקטובר. הצעת ‪Dell‬ עומדת על ‪$695,520‬ עבור ‪600 TB‬ לוגי.‬</a:t>
-            </a:r>
-            <a:endParaRPr lang="he-IL" sz="1250" dirty="0"/>
-          </a:p>
-        </p:txBody>
-      </p:sp>
-      <p:sp>
-        <p:nvSpPr>
-          <p:cNvPr id="26" name="Shape 24"/>
-          <p:cNvSpPr/>
-          <p:nvPr/>
-        </p:nvSpPr>
-        <p:spPr>
-          <a:xfrm>
-            <a:off x="6540703" y="4992624"/>
-            <a:ext cx="4517136" cy="365760"/>
-          </a:xfrm>
-          <a:prstGeom prst="roundRect">
-            <a:avLst>
-              <a:gd name="adj" fmla="val 40000"/>
-            </a:avLst>
-          </a:prstGeom>
-          <a:solidFill>
-            <a:srgbClr val="3A2A12"/>
-          </a:solidFill>
-          <a:ln w="12700">
-            <a:solidFill>
-              <a:srgbClr val="3A2A12"/>
-            </a:solidFill>
-            <a:prstDash val="solid"/>
-          </a:ln>
-        </p:spPr>
-      </p:sp>
-      <p:sp>
-        <p:nvSpPr>
-          <p:cNvPr id="27" name="Text 25"/>
-          <p:cNvSpPr/>
-          <p:nvPr/>
-        </p:nvSpPr>
-        <p:spPr>
-          <a:xfrm>
-            <a:off x="6687007" y="4992624"/>
-            <a:ext cx="4224528" cy="365760"/>
-          </a:xfrm>
-          <a:prstGeom prst="rect">
-            <a:avLst/>
-          </a:prstGeom>
-          <a:noFill/>
-          <a:ln/>
-        </p:spPr>
-        <p:txBody>
-          <a:bodyPr wrap="square" lIns="0" tIns="0" rIns="0" bIns="0" rtlCol="0" anchor="ctr"/>
-          <a:lstStyle/>
-          <a:p>
-            <a:pPr rtl="1" algn="r" indent="0" marL="0">
-              <a:lnSpc>
-                <a:spcPct val="100000"/>
-              </a:lnSpc>
-              <a:buNone/>
-            </a:pPr>
-            <a:r>
-              <a:rPr lang="he-IL" altLang="en-US" sz="1200" b="1" dirty="0">
-                <a:solidFill>
-                  <a:srgbClr val="FF9F43"/>
-                </a:solidFill>
-                <a:latin typeface="Calibri" pitchFamily="34" charset="0"/>
-                <a:ea typeface="Calibri" pitchFamily="34" charset="-122"/>
-                <a:cs typeface="Calibri" pitchFamily="34" charset="-120"/>
-              </a:rPr>
-              <a:t>‫נדרש: אישור תקציב ויציאה ל-‪PO‬ באוקטובר‬</a:t>
-            </a:r>
-            <a:endParaRPr lang="he-IL" sz="1200" dirty="0"/>
-          </a:p>
-        </p:txBody>
-      </p:sp>
-      <p:sp>
-        <p:nvSpPr>
-          <p:cNvPr id="28" name="Shape 26"/>
-          <p:cNvSpPr/>
-          <p:nvPr/>
-        </p:nvSpPr>
-        <p:spPr>
-          <a:xfrm>
-            <a:off x="822960" y="3657600"/>
-            <a:ext cx="5138928" cy="1847088"/>
-          </a:xfrm>
-          <a:prstGeom prst="roundRect">
-            <a:avLst>
-              <a:gd name="adj" fmla="val 2475"/>
-            </a:avLst>
-          </a:prstGeom>
-          <a:solidFill>
-            <a:srgbClr val="182133"/>
-          </a:solidFill>
-          <a:ln w="12700">
-            <a:solidFill>
-              <a:srgbClr val="2E5F6B"/>
-            </a:solidFill>
-            <a:prstDash val="solid"/>
-          </a:ln>
-        </p:spPr>
-      </p:sp>
-      <p:sp>
-        <p:nvSpPr>
-          <p:cNvPr id="29" name="Text 27"/>
-          <p:cNvSpPr/>
-          <p:nvPr/>
-        </p:nvSpPr>
-        <p:spPr>
-          <a:xfrm>
-            <a:off x="5047488" y="3858768"/>
-            <a:ext cx="640080" cy="384048"/>
-          </a:xfrm>
-          <a:prstGeom prst="rect">
-            <a:avLst/>
-          </a:prstGeom>
-          <a:noFill/>
-          <a:ln/>
-        </p:spPr>
-        <p:txBody>
-          <a:bodyPr wrap="square" lIns="0" tIns="0" rIns="0" bIns="0" rtlCol="0" anchor="ctr"/>
-          <a:lstStyle/>
-          <a:p>
-            <a:pPr algn="r" indent="0" marL="0">
-              <a:lnSpc>
-                <a:spcPct val="100000"/>
-              </a:lnSpc>
-              <a:buNone/>
-            </a:pPr>
-            <a:r>
-              <a:rPr lang="en-US" altLang="en-US" sz="2100" b="1" dirty="0">
-                <a:solidFill>
-                  <a:srgbClr val="3DD9EB"/>
-                </a:solidFill>
-                <a:latin typeface="Calibri" pitchFamily="34" charset="0"/>
-                <a:ea typeface="Calibri" pitchFamily="34" charset="-122"/>
-                <a:cs typeface="Calibri" pitchFamily="34" charset="-120"/>
-              </a:rPr>
-              <a:t>02</a:t>
-            </a:r>
-            <a:endParaRPr lang="en-US" sz="2100" dirty="0"/>
-          </a:p>
-        </p:txBody>
-      </p:sp>
-      <p:sp>
-        <p:nvSpPr>
-          <p:cNvPr id="30" name="Text 28"/>
-          <p:cNvSpPr/>
-          <p:nvPr/>
-        </p:nvSpPr>
-        <p:spPr>
-          <a:xfrm>
-            <a:off x="1133856" y="3877056"/>
-            <a:ext cx="3822192" cy="365760"/>
-          </a:xfrm>
-          <a:prstGeom prst="rect">
-            <a:avLst/>
-          </a:prstGeom>
-          <a:noFill/>
-          <a:ln/>
-        </p:spPr>
-        <p:txBody>
-          <a:bodyPr wrap="square" lIns="0" tIns="0" rIns="0" bIns="0" rtlCol="0" anchor="ctr"/>
-          <a:lstStyle/>
-          <a:p>
-            <a:pPr rtl="1" algn="r" indent="0" marL="0">
-              <a:lnSpc>
-                <a:spcPct val="100000"/>
-              </a:lnSpc>
-              <a:buNone/>
-            </a:pPr>
-            <a:r>
-              <a:rPr lang="he-IL" altLang="en-US" sz="1600" b="1" dirty="0">
-                <a:solidFill>
-                  <a:srgbClr val="F4F7FB"/>
-                </a:solidFill>
-                <a:latin typeface="Calibri" pitchFamily="34" charset="0"/>
-                <a:ea typeface="Calibri" pitchFamily="34" charset="-122"/>
-                <a:cs typeface="Calibri" pitchFamily="34" charset="-120"/>
-              </a:rPr>
-              <a:t>‫העתקת מסמכי דימות ו-‪Verint‬ ל-‪AWS S3‬‬</a:t>
-            </a:r>
-            <a:endParaRPr lang="he-IL" sz="1600" dirty="0"/>
-          </a:p>
-        </p:txBody>
-      </p:sp>
-      <p:sp>
-        <p:nvSpPr>
-          <p:cNvPr id="31" name="Text 29"/>
-          <p:cNvSpPr/>
-          <p:nvPr/>
-        </p:nvSpPr>
-        <p:spPr>
-          <a:xfrm>
-            <a:off x="1133856" y="4352544"/>
-            <a:ext cx="4517136" cy="786384"/>
-          </a:xfrm>
-          <a:prstGeom prst="rect">
-            <a:avLst/>
-          </a:prstGeom>
-          <a:noFill/>
-          <a:ln/>
-        </p:spPr>
-        <p:txBody>
-          <a:bodyPr wrap="square" lIns="0" tIns="0" rIns="0" bIns="0" rtlCol="0" anchor="t"/>
-          <a:lstStyle/>
-          <a:p>
-            <a:pPr rtl="1" algn="r" indent="0" marL="0">
-              <a:lnSpc>
-                <a:spcPct val="126000"/>
-              </a:lnSpc>
-              <a:buNone/>
-            </a:pPr>
-            <a:r>
-              <a:rPr lang="he-IL" altLang="en-US" sz="1250" dirty="0">
-                <a:solidFill>
-                  <a:srgbClr val="91A0B7"/>
-                </a:solidFill>
-                <a:latin typeface="Calibri" pitchFamily="34" charset="0"/>
-                <a:ea typeface="Calibri" pitchFamily="34" charset="-122"/>
-                <a:cs typeface="Calibri" pitchFamily="34" charset="-120"/>
-              </a:rPr>
-              <a:t>‫מפנה שטח ב-‪ECS‬ תוך שבועות, ללא ‪PO‬ וללא זמן אספקה. רץ במקביל לרכש ומקטין את הלחץ על הסף — אך אינו מחליף את הדיסקים ואינו עוצר את השעון.‬</a:t>
-            </a:r>
-            <a:endParaRPr lang="he-IL" sz="1250" dirty="0"/>
-          </a:p>
-        </p:txBody>
-      </p:sp>
-      <p:sp>
-        <p:nvSpPr>
-          <p:cNvPr id="32" name="Shape 30"/>
-          <p:cNvSpPr/>
-          <p:nvPr/>
-        </p:nvSpPr>
-        <p:spPr>
-          <a:xfrm>
-            <a:off x="1133856" y="4992624"/>
-            <a:ext cx="4517136" cy="365760"/>
-          </a:xfrm>
-          <a:prstGeom prst="roundRect">
-            <a:avLst>
-              <a:gd name="adj" fmla="val 40000"/>
-            </a:avLst>
-          </a:prstGeom>
-          <a:solidFill>
-            <a:srgbClr val="13303A"/>
-          </a:solidFill>
-          <a:ln w="12700">
-            <a:solidFill>
-              <a:srgbClr val="13303A"/>
-            </a:solidFill>
-            <a:prstDash val="solid"/>
-          </a:ln>
-        </p:spPr>
-      </p:sp>
-      <p:sp>
-        <p:nvSpPr>
-          <p:cNvPr id="33" name="Text 31"/>
-          <p:cNvSpPr/>
-          <p:nvPr/>
-        </p:nvSpPr>
-        <p:spPr>
-          <a:xfrm>
-            <a:off x="1280160" y="4992624"/>
-            <a:ext cx="4224528" cy="365760"/>
-          </a:xfrm>
-          <a:prstGeom prst="rect">
-            <a:avLst/>
-          </a:prstGeom>
-          <a:noFill/>
-          <a:ln/>
-        </p:spPr>
-        <p:txBody>
-          <a:bodyPr wrap="square" lIns="0" tIns="0" rIns="0" bIns="0" rtlCol="0" anchor="ctr"/>
-          <a:lstStyle/>
-          <a:p>
-            <a:pPr rtl="1" algn="r" indent="0" marL="0">
-              <a:lnSpc>
-                <a:spcPct val="100000"/>
-              </a:lnSpc>
-              <a:buNone/>
-            </a:pPr>
-            <a:r>
-              <a:rPr lang="he-IL" altLang="en-US" sz="1200" b="1" dirty="0">
-                <a:solidFill>
-                  <a:srgbClr val="3DD9EB"/>
-                </a:solidFill>
-                <a:latin typeface="Calibri" pitchFamily="34" charset="0"/>
-                <a:ea typeface="Calibri" pitchFamily="34" charset="-122"/>
-                <a:cs typeface="Calibri" pitchFamily="34" charset="-120"/>
-              </a:rPr>
-              <a:t>‫נדרש: אישור עקרוני + תקציב ‪POC‬‬</a:t>
-            </a:r>
-            <a:endParaRPr lang="he-IL" sz="1200" dirty="0"/>
-          </a:p>
-        </p:txBody>
-      </p:sp>
-      <p:sp>
-        <p:nvSpPr>
-          <p:cNvPr id="34" name="Shape 32"/>
-          <p:cNvSpPr/>
-          <p:nvPr/>
-        </p:nvSpPr>
-        <p:spPr>
-          <a:xfrm>
-            <a:off x="822960" y="5907024"/>
-            <a:ext cx="10545775" cy="10973"/>
-          </a:xfrm>
-          <a:prstGeom prst="rect">
-            <a:avLst/>
-          </a:prstGeom>
-          <a:solidFill>
-            <a:srgbClr val="23304A"/>
-          </a:solidFill>
-          <a:ln w="12700">
-            <a:solidFill>
-              <a:srgbClr val="23304A"/>
-            </a:solidFill>
-            <a:prstDash val="solid"/>
-          </a:ln>
-        </p:spPr>
-      </p:sp>
-      <p:sp>
-        <p:nvSpPr>
-          <p:cNvPr id="35" name="Shape 33"/>
-          <p:cNvSpPr/>
-          <p:nvPr/>
-        </p:nvSpPr>
-        <p:spPr>
-          <a:xfrm>
-            <a:off x="11249863" y="6172200"/>
-            <a:ext cx="118872" cy="118872"/>
-          </a:xfrm>
-          <a:prstGeom prst="rect">
-            <a:avLst/>
-          </a:prstGeom>
-          <a:solidFill>
-            <a:srgbClr val="FF6B7A"/>
-          </a:solidFill>
-          <a:ln w="12700">
-            <a:solidFill>
-              <a:srgbClr val="FF6B7A"/>
-            </a:solidFill>
-            <a:prstDash val="solid"/>
-          </a:ln>
-        </p:spPr>
-      </p:sp>
-      <p:sp>
-        <p:nvSpPr>
-          <p:cNvPr id="36" name="Text 34"/>
           <p:cNvSpPr/>
           <p:nvPr/>
         </p:nvSpPr>
@@ -5632,7 +5114,7 @@
                 <a:ea typeface="Calibri" pitchFamily="34" charset="-122"/>
                 <a:cs typeface="Calibri" pitchFamily="34" charset="-120"/>
               </a:rPr>
-              <a:t>‫כל חודש עיכוב בהוצאת ה-‪PO‬ דוחה את האספקה בחודש — אך אינו דוחה את חציית ‪80%‬. עיכוב לנובמבר פירושו הגעה ל-‪80%‬ לפני שהדיסקים בבית.‬</a:t>
+              <a:t>‫שני המסלולים אינם חלופיים: ‪01‬ מוסיף קיבולת, ‪02‬ מקטין את הצריכה. ה-‪PO‬ של ‪01‬ חייב לצאת באוקטובר — הרציונל והנתונים בשקפים הבאים.‬</a:t>
             </a:r>
             <a:endParaRPr lang="he-IL" sz="1150" dirty="0"/>
           </a:p>

</xml_diff>

<commit_message>
State the Dell expansion's in-place advantages on the decision slide
Option 01 now says the expansion adds disks to nodes we already run — no new
nodes — and that maintenance on that storage is already paid five years forward.
Both are advantages of staying on ECS and were only implied before, in the cost
footnote on the comparison slide.

Kept it to one fact row so the card still fits: the two points share a line, the
lead shortened to one line, and option 02 gained a matching row about starting
with a single corpus so the two cards stay symmetric.

Co-Authored-By: Claude Opus 5 <noreply@anthropic.com>
Claude-Session: https://claude.ai/code/session_01MZnQ3bUVeTyJdPFvjg3J88
</commit_message>
<xml_diff>
--- a/presentations/ecs-to-s3/Harel_ECS_to_S3_CIO.pptx
+++ b/presentations/ecs-to-s3/Harel_ECS_to_S3_CIO.pptx
@@ -4492,12 +4492,12 @@
         </p:nvSpPr>
         <p:spPr>
           <a:xfrm>
-            <a:off x="6229807" y="2066544"/>
-            <a:ext cx="5138928" cy="3657600"/>
+            <a:off x="6229807" y="2029968"/>
+            <a:ext cx="5138928" cy="3749040"/>
           </a:xfrm>
           <a:prstGeom prst="roundRect">
             <a:avLst>
-              <a:gd name="adj" fmla="val 1250"/>
+              <a:gd name="adj" fmla="val 1220"/>
             </a:avLst>
           </a:prstGeom>
           <a:solidFill>
@@ -4519,7 +4519,7 @@
         </p:nvSpPr>
         <p:spPr>
           <a:xfrm>
-            <a:off x="11213287" y="2395728"/>
+            <a:off x="11213287" y="2359152"/>
             <a:ext cx="50292" cy="402336"/>
           </a:xfrm>
           <a:prstGeom prst="rect">
@@ -4544,7 +4544,7 @@
         </p:nvSpPr>
         <p:spPr>
           <a:xfrm>
-            <a:off x="10198303" y="2377440"/>
+            <a:off x="10198303" y="2340864"/>
             <a:ext cx="676656" cy="438912"/>
           </a:xfrm>
           <a:prstGeom prst="rect">
@@ -4586,7 +4586,7 @@
         </p:nvSpPr>
         <p:spPr>
           <a:xfrm>
-            <a:off x="6577279" y="2359152"/>
+            <a:off x="6577279" y="2322576"/>
             <a:ext cx="3511296" cy="475488"/>
           </a:xfrm>
           <a:prstGeom prst="rect">
@@ -4628,7 +4628,7 @@
         </p:nvSpPr>
         <p:spPr>
           <a:xfrm>
-            <a:off x="6577279" y="2980944"/>
+            <a:off x="6577279" y="2944368"/>
             <a:ext cx="4443984" cy="10973"/>
           </a:xfrm>
           <a:prstGeom prst="rect">
@@ -4653,8 +4653,8 @@
         </p:nvSpPr>
         <p:spPr>
           <a:xfrm>
-            <a:off x="6577279" y="3108960"/>
-            <a:ext cx="4443984" cy="603504"/>
+            <a:off x="6577279" y="3054096"/>
+            <a:ext cx="4443984" cy="475488"/>
           </a:xfrm>
           <a:prstGeom prst="rect">
             <a:avLst/>
@@ -4681,7 +4681,7 @@
                 <a:ea typeface="Calibri" pitchFamily="34" charset="-122"/>
                 <a:cs typeface="Calibri" pitchFamily="34" charset="-120"/>
               </a:rPr>
-              <a:t>‫הרחבת המערך הקיים: רכש תוספת דיסקים מ-‪Dell‬, באותה ארכיטקטורה ובאותם ממשקים.‬</a:t>
+              <a:t>‫הרחבת המערך הקיים — באותה ארכיטקטורה ובאותם ממשקים.‬</a:t>
             </a:r>
             <a:endParaRPr lang="he-IL" sz="1400" dirty="0"/>
           </a:p>
@@ -4695,7 +4695,7 @@
         </p:nvSpPr>
         <p:spPr>
           <a:xfrm>
-            <a:off x="10966399" y="3931920"/>
+            <a:off x="10966399" y="3694176"/>
             <a:ext cx="91440" cy="91440"/>
           </a:xfrm>
           <a:prstGeom prst="rect">
@@ -4720,8 +4720,8 @@
         </p:nvSpPr>
         <p:spPr>
           <a:xfrm>
-            <a:off x="6577279" y="3803904"/>
-            <a:ext cx="4279392" cy="384048"/>
+            <a:off x="6577279" y="3566160"/>
+            <a:ext cx="4279392" cy="365760"/>
           </a:xfrm>
           <a:prstGeom prst="rect">
             <a:avLst/>
@@ -4762,7 +4762,7 @@
         </p:nvSpPr>
         <p:spPr>
           <a:xfrm>
-            <a:off x="10966399" y="4334256"/>
+            <a:off x="10966399" y="4078224"/>
             <a:ext cx="91440" cy="91440"/>
           </a:xfrm>
           <a:prstGeom prst="rect">
@@ -4787,8 +4787,8 @@
         </p:nvSpPr>
         <p:spPr>
           <a:xfrm>
-            <a:off x="6577279" y="4206240"/>
-            <a:ext cx="4279392" cy="384048"/>
+            <a:off x="6577279" y="3950208"/>
+            <a:ext cx="4279392" cy="365760"/>
           </a:xfrm>
           <a:prstGeom prst="rect">
             <a:avLst/>
@@ -4829,7 +4829,74 @@
         </p:nvSpPr>
         <p:spPr>
           <a:xfrm>
-            <a:off x="10966399" y="4736592"/>
+            <a:off x="10966399" y="4462272"/>
+            <a:ext cx="91440" cy="91440"/>
+          </a:xfrm>
+          <a:prstGeom prst="rect">
+            <a:avLst/>
+          </a:prstGeom>
+          <a:solidFill>
+            <a:srgbClr val="FF9F43"/>
+          </a:solidFill>
+          <a:ln w="12700">
+            <a:solidFill>
+              <a:srgbClr val="FF9F43"/>
+            </a:solidFill>
+            <a:prstDash val="solid"/>
+          </a:ln>
+        </p:spPr>
+      </p:sp>
+      <p:sp>
+        <p:nvSpPr>
+          <p:cNvPr id="16" name="Text 14"/>
+          <p:cNvSpPr/>
+          <p:nvPr/>
+        </p:nvSpPr>
+        <p:spPr>
+          <a:xfrm>
+            <a:off x="6577279" y="4334256"/>
+            <a:ext cx="4279392" cy="365760"/>
+          </a:xfrm>
+          <a:prstGeom prst="rect">
+            <a:avLst/>
+          </a:prstGeom>
+          <a:noFill/>
+          <a:ln/>
+        </p:spPr>
+        <p:txBody>
+          <a:bodyPr wrap="square" lIns="0" tIns="0" rIns="0" bIns="0" rtlCol="0" anchor="ctr"/>
+          <a:lstStyle/>
+          <a:p>
+            <a:pPr rtl="1" algn="r" indent="0" marL="0">
+              <a:lnSpc>
+                <a:spcPct val="100000"/>
+              </a:lnSpc>
+              <a:buNone/>
+            </a:pPr>
+            <a:r>
+              <a:rPr lang="he-IL" altLang="en-US" sz="1300" dirty="0">
+                <a:solidFill>
+                  <a:srgbClr val="F4F7FB"/>
+                </a:solidFill>
+                <a:latin typeface="Calibri" pitchFamily="34" charset="0"/>
+                <a:ea typeface="Calibri" pitchFamily="34" charset="-122"/>
+                <a:cs typeface="Calibri" pitchFamily="34" charset="-120"/>
+              </a:rPr>
+              <a:t>‫תוספת דיסקים ל-‪nodes‬ קיימים · תחזוקה ל-‪5‬ שנים‬</a:t>
+            </a:r>
+            <a:endParaRPr lang="he-IL" sz="1300" dirty="0"/>
+          </a:p>
+        </p:txBody>
+      </p:sp>
+      <p:sp>
+        <p:nvSpPr>
+          <p:cNvPr id="17" name="Shape 15"/>
+          <p:cNvSpPr/>
+          <p:nvPr/>
+        </p:nvSpPr>
+        <p:spPr>
+          <a:xfrm>
+            <a:off x="10966399" y="4846320"/>
             <a:ext cx="91440" cy="91440"/>
           </a:xfrm>
           <a:prstGeom prst="rect">
@@ -4848,14 +4915,14 @@
       </p:sp>
       <p:sp>
         <p:nvSpPr>
-          <p:cNvPr id="16" name="Text 14"/>
-          <p:cNvSpPr/>
-          <p:nvPr/>
-        </p:nvSpPr>
-        <p:spPr>
-          <a:xfrm>
-            <a:off x="6577279" y="4608576"/>
-            <a:ext cx="4279392" cy="384048"/>
+          <p:cNvPr id="18" name="Text 16"/>
+          <p:cNvSpPr/>
+          <p:nvPr/>
+        </p:nvSpPr>
+        <p:spPr>
+          <a:xfrm>
+            <a:off x="6577279" y="4718304"/>
+            <a:ext cx="4279392" cy="365760"/>
           </a:xfrm>
           <a:prstGeom prst="rect">
             <a:avLst/>
@@ -4890,13 +4957,13 @@
       </p:sp>
       <p:sp>
         <p:nvSpPr>
-          <p:cNvPr id="17" name="Shape 15"/>
-          <p:cNvSpPr/>
-          <p:nvPr/>
-        </p:nvSpPr>
-        <p:spPr>
-          <a:xfrm>
-            <a:off x="6577279" y="5120640"/>
+          <p:cNvPr id="19" name="Shape 17"/>
+          <p:cNvSpPr/>
+          <p:nvPr/>
+        </p:nvSpPr>
+        <p:spPr>
+          <a:xfrm>
+            <a:off x="6577279" y="5175504"/>
             <a:ext cx="4443984" cy="457200"/>
           </a:xfrm>
           <a:prstGeom prst="roundRect">
@@ -4917,13 +4984,13 @@
       </p:sp>
       <p:sp>
         <p:nvSpPr>
-          <p:cNvPr id="18" name="Text 16"/>
-          <p:cNvSpPr/>
-          <p:nvPr/>
-        </p:nvSpPr>
-        <p:spPr>
-          <a:xfrm>
-            <a:off x="6723583" y="5120640"/>
+          <p:cNvPr id="20" name="Text 18"/>
+          <p:cNvSpPr/>
+          <p:nvPr/>
+        </p:nvSpPr>
+        <p:spPr>
+          <a:xfrm>
+            <a:off x="6723583" y="5175504"/>
             <a:ext cx="4151376" cy="457200"/>
           </a:xfrm>
           <a:prstGeom prst="rect">
@@ -4959,18 +5026,18 @@
       </p:sp>
       <p:sp>
         <p:nvSpPr>
-          <p:cNvPr id="19" name="Shape 17"/>
-          <p:cNvSpPr/>
-          <p:nvPr/>
-        </p:nvSpPr>
-        <p:spPr>
-          <a:xfrm>
-            <a:off x="822960" y="2066544"/>
-            <a:ext cx="5138928" cy="3657600"/>
+          <p:cNvPr id="21" name="Shape 19"/>
+          <p:cNvSpPr/>
+          <p:nvPr/>
+        </p:nvSpPr>
+        <p:spPr>
+          <a:xfrm>
+            <a:off x="822960" y="2029968"/>
+            <a:ext cx="5138928" cy="3749040"/>
           </a:xfrm>
           <a:prstGeom prst="roundRect">
             <a:avLst>
-              <a:gd name="adj" fmla="val 1250"/>
+              <a:gd name="adj" fmla="val 1220"/>
             </a:avLst>
           </a:prstGeom>
           <a:solidFill>
@@ -4986,13 +5053,13 @@
       </p:sp>
       <p:sp>
         <p:nvSpPr>
-          <p:cNvPr id="20" name="Shape 18"/>
-          <p:cNvSpPr/>
-          <p:nvPr/>
-        </p:nvSpPr>
-        <p:spPr>
-          <a:xfrm>
-            <a:off x="5806440" y="2395728"/>
+          <p:cNvPr id="22" name="Shape 20"/>
+          <p:cNvSpPr/>
+          <p:nvPr/>
+        </p:nvSpPr>
+        <p:spPr>
+          <a:xfrm>
+            <a:off x="5806440" y="2359152"/>
             <a:ext cx="50292" cy="402336"/>
           </a:xfrm>
           <a:prstGeom prst="rect">
@@ -5011,13 +5078,13 @@
       </p:sp>
       <p:sp>
         <p:nvSpPr>
-          <p:cNvPr id="21" name="Text 19"/>
-          <p:cNvSpPr/>
-          <p:nvPr/>
-        </p:nvSpPr>
-        <p:spPr>
-          <a:xfrm>
-            <a:off x="4791456" y="2377440"/>
+          <p:cNvPr id="23" name="Text 21"/>
+          <p:cNvSpPr/>
+          <p:nvPr/>
+        </p:nvSpPr>
+        <p:spPr>
+          <a:xfrm>
+            <a:off x="4791456" y="2340864"/>
             <a:ext cx="676656" cy="438912"/>
           </a:xfrm>
           <a:prstGeom prst="rect">
@@ -5053,13 +5120,13 @@
       </p:sp>
       <p:sp>
         <p:nvSpPr>
-          <p:cNvPr id="22" name="Text 20"/>
-          <p:cNvSpPr/>
-          <p:nvPr/>
-        </p:nvSpPr>
-        <p:spPr>
-          <a:xfrm>
-            <a:off x="1170432" y="2359152"/>
+          <p:cNvPr id="24" name="Text 22"/>
+          <p:cNvSpPr/>
+          <p:nvPr/>
+        </p:nvSpPr>
+        <p:spPr>
+          <a:xfrm>
+            <a:off x="1170432" y="2322576"/>
             <a:ext cx="3511296" cy="475488"/>
           </a:xfrm>
           <a:prstGeom prst="rect">
@@ -5095,13 +5162,13 @@
       </p:sp>
       <p:sp>
         <p:nvSpPr>
-          <p:cNvPr id="23" name="Shape 21"/>
-          <p:cNvSpPr/>
-          <p:nvPr/>
-        </p:nvSpPr>
-        <p:spPr>
-          <a:xfrm>
-            <a:off x="1170432" y="2980944"/>
+          <p:cNvPr id="25" name="Shape 23"/>
+          <p:cNvSpPr/>
+          <p:nvPr/>
+        </p:nvSpPr>
+        <p:spPr>
+          <a:xfrm>
+            <a:off x="1170432" y="2944368"/>
             <a:ext cx="4443984" cy="10973"/>
           </a:xfrm>
           <a:prstGeom prst="rect">
@@ -5120,14 +5187,14 @@
       </p:sp>
       <p:sp>
         <p:nvSpPr>
-          <p:cNvPr id="24" name="Text 22"/>
-          <p:cNvSpPr/>
-          <p:nvPr/>
-        </p:nvSpPr>
-        <p:spPr>
-          <a:xfrm>
-            <a:off x="1170432" y="3108960"/>
-            <a:ext cx="4443984" cy="603504"/>
+          <p:cNvPr id="26" name="Text 24"/>
+          <p:cNvSpPr/>
+          <p:nvPr/>
+        </p:nvSpPr>
+        <p:spPr>
+          <a:xfrm>
+            <a:off x="1170432" y="3054096"/>
+            <a:ext cx="4443984" cy="475488"/>
           </a:xfrm>
           <a:prstGeom prst="rect">
             <a:avLst/>
@@ -5162,13 +5229,13 @@
       </p:sp>
       <p:sp>
         <p:nvSpPr>
-          <p:cNvPr id="25" name="Shape 23"/>
-          <p:cNvSpPr/>
-          <p:nvPr/>
-        </p:nvSpPr>
-        <p:spPr>
-          <a:xfrm>
-            <a:off x="5559552" y="3931920"/>
+          <p:cNvPr id="27" name="Shape 25"/>
+          <p:cNvSpPr/>
+          <p:nvPr/>
+        </p:nvSpPr>
+        <p:spPr>
+          <a:xfrm>
+            <a:off x="5559552" y="3694176"/>
             <a:ext cx="91440" cy="91440"/>
           </a:xfrm>
           <a:prstGeom prst="rect">
@@ -5187,14 +5254,14 @@
       </p:sp>
       <p:sp>
         <p:nvSpPr>
-          <p:cNvPr id="26" name="Text 24"/>
-          <p:cNvSpPr/>
-          <p:nvPr/>
-        </p:nvSpPr>
-        <p:spPr>
-          <a:xfrm>
-            <a:off x="1170432" y="3803904"/>
-            <a:ext cx="4279392" cy="384048"/>
+          <p:cNvPr id="28" name="Text 26"/>
+          <p:cNvSpPr/>
+          <p:nvPr/>
+        </p:nvSpPr>
+        <p:spPr>
+          <a:xfrm>
+            <a:off x="1170432" y="3566160"/>
+            <a:ext cx="4279392" cy="365760"/>
           </a:xfrm>
           <a:prstGeom prst="rect">
             <a:avLst/>
@@ -5229,13 +5296,13 @@
       </p:sp>
       <p:sp>
         <p:nvSpPr>
-          <p:cNvPr id="27" name="Shape 25"/>
-          <p:cNvSpPr/>
-          <p:nvPr/>
-        </p:nvSpPr>
-        <p:spPr>
-          <a:xfrm>
-            <a:off x="5559552" y="4334256"/>
+          <p:cNvPr id="29" name="Shape 27"/>
+          <p:cNvSpPr/>
+          <p:nvPr/>
+        </p:nvSpPr>
+        <p:spPr>
+          <a:xfrm>
+            <a:off x="5559552" y="4078224"/>
             <a:ext cx="91440" cy="91440"/>
           </a:xfrm>
           <a:prstGeom prst="rect">
@@ -5254,14 +5321,14 @@
       </p:sp>
       <p:sp>
         <p:nvSpPr>
-          <p:cNvPr id="28" name="Text 26"/>
-          <p:cNvSpPr/>
-          <p:nvPr/>
-        </p:nvSpPr>
-        <p:spPr>
-          <a:xfrm>
-            <a:off x="1170432" y="4206240"/>
-            <a:ext cx="4279392" cy="384048"/>
+          <p:cNvPr id="30" name="Text 28"/>
+          <p:cNvSpPr/>
+          <p:nvPr/>
+        </p:nvSpPr>
+        <p:spPr>
+          <a:xfrm>
+            <a:off x="1170432" y="3950208"/>
+            <a:ext cx="4279392" cy="365760"/>
           </a:xfrm>
           <a:prstGeom prst="rect">
             <a:avLst/>
@@ -5296,13 +5363,80 @@
       </p:sp>
       <p:sp>
         <p:nvSpPr>
-          <p:cNvPr id="29" name="Shape 27"/>
-          <p:cNvSpPr/>
-          <p:nvPr/>
-        </p:nvSpPr>
-        <p:spPr>
-          <a:xfrm>
-            <a:off x="5559552" y="4736592"/>
+          <p:cNvPr id="31" name="Shape 29"/>
+          <p:cNvSpPr/>
+          <p:nvPr/>
+        </p:nvSpPr>
+        <p:spPr>
+          <a:xfrm>
+            <a:off x="5559552" y="4462272"/>
+            <a:ext cx="91440" cy="91440"/>
+          </a:xfrm>
+          <a:prstGeom prst="rect">
+            <a:avLst/>
+          </a:prstGeom>
+          <a:solidFill>
+            <a:srgbClr val="3DD9EB"/>
+          </a:solidFill>
+          <a:ln w="12700">
+            <a:solidFill>
+              <a:srgbClr val="3DD9EB"/>
+            </a:solidFill>
+            <a:prstDash val="solid"/>
+          </a:ln>
+        </p:spPr>
+      </p:sp>
+      <p:sp>
+        <p:nvSpPr>
+          <p:cNvPr id="32" name="Text 30"/>
+          <p:cNvSpPr/>
+          <p:nvPr/>
+        </p:nvSpPr>
+        <p:spPr>
+          <a:xfrm>
+            <a:off x="1170432" y="4334256"/>
+            <a:ext cx="4279392" cy="365760"/>
+          </a:xfrm>
+          <a:prstGeom prst="rect">
+            <a:avLst/>
+          </a:prstGeom>
+          <a:noFill/>
+          <a:ln/>
+        </p:spPr>
+        <p:txBody>
+          <a:bodyPr wrap="square" lIns="0" tIns="0" rIns="0" bIns="0" rtlCol="0" anchor="ctr"/>
+          <a:lstStyle/>
+          <a:p>
+            <a:pPr rtl="1" algn="r" indent="0" marL="0">
+              <a:lnSpc>
+                <a:spcPct val="100000"/>
+              </a:lnSpc>
+              <a:buNone/>
+            </a:pPr>
+            <a:r>
+              <a:rPr lang="he-IL" altLang="en-US" sz="1300" dirty="0">
+                <a:solidFill>
+                  <a:srgbClr val="F4F7FB"/>
+                </a:solidFill>
+                <a:latin typeface="Calibri" pitchFamily="34" charset="0"/>
+                <a:ea typeface="Calibri" pitchFamily="34" charset="-122"/>
+                <a:cs typeface="Calibri" pitchFamily="34" charset="-120"/>
+              </a:rPr>
+              <a:t>‫ניתן להתחיל בקורפוס אחד ולהרחיב בהדרגה‬</a:t>
+            </a:r>
+            <a:endParaRPr lang="he-IL" sz="1300" dirty="0"/>
+          </a:p>
+        </p:txBody>
+      </p:sp>
+      <p:sp>
+        <p:nvSpPr>
+          <p:cNvPr id="33" name="Shape 31"/>
+          <p:cNvSpPr/>
+          <p:nvPr/>
+        </p:nvSpPr>
+        <p:spPr>
+          <a:xfrm>
+            <a:off x="5559552" y="4846320"/>
             <a:ext cx="91440" cy="91440"/>
           </a:xfrm>
           <a:prstGeom prst="rect">
@@ -5321,14 +5455,14 @@
       </p:sp>
       <p:sp>
         <p:nvSpPr>
-          <p:cNvPr id="30" name="Text 28"/>
-          <p:cNvSpPr/>
-          <p:nvPr/>
-        </p:nvSpPr>
-        <p:spPr>
-          <a:xfrm>
-            <a:off x="1170432" y="4608576"/>
-            <a:ext cx="4279392" cy="384048"/>
+          <p:cNvPr id="34" name="Text 32"/>
+          <p:cNvSpPr/>
+          <p:nvPr/>
+        </p:nvSpPr>
+        <p:spPr>
+          <a:xfrm>
+            <a:off x="1170432" y="4718304"/>
+            <a:ext cx="4279392" cy="365760"/>
           </a:xfrm>
           <a:prstGeom prst="rect">
             <a:avLst/>
@@ -5363,13 +5497,13 @@
       </p:sp>
       <p:sp>
         <p:nvSpPr>
-          <p:cNvPr id="31" name="Shape 29"/>
-          <p:cNvSpPr/>
-          <p:nvPr/>
-        </p:nvSpPr>
-        <p:spPr>
-          <a:xfrm>
-            <a:off x="1170432" y="5120640"/>
+          <p:cNvPr id="35" name="Shape 33"/>
+          <p:cNvSpPr/>
+          <p:nvPr/>
+        </p:nvSpPr>
+        <p:spPr>
+          <a:xfrm>
+            <a:off x="1170432" y="5175504"/>
             <a:ext cx="4443984" cy="457200"/>
           </a:xfrm>
           <a:prstGeom prst="roundRect">
@@ -5390,13 +5524,13 @@
       </p:sp>
       <p:sp>
         <p:nvSpPr>
-          <p:cNvPr id="32" name="Text 30"/>
-          <p:cNvSpPr/>
-          <p:nvPr/>
-        </p:nvSpPr>
-        <p:spPr>
-          <a:xfrm>
-            <a:off x="1316736" y="5120640"/>
+          <p:cNvPr id="36" name="Text 34"/>
+          <p:cNvSpPr/>
+          <p:nvPr/>
+        </p:nvSpPr>
+        <p:spPr>
+          <a:xfrm>
+            <a:off x="1316736" y="5175504"/>
             <a:ext cx="4151376" cy="457200"/>
           </a:xfrm>
           <a:prstGeom prst="rect">
@@ -5432,7 +5566,7 @@
       </p:sp>
       <p:sp>
         <p:nvSpPr>
-          <p:cNvPr id="33" name="Shape 31"/>
+          <p:cNvPr id="37" name="Shape 35"/>
           <p:cNvSpPr/>
           <p:nvPr/>
         </p:nvSpPr>
@@ -5457,7 +5591,7 @@
       </p:sp>
       <p:sp>
         <p:nvSpPr>
-          <p:cNvPr id="34" name="Shape 32"/>
+          <p:cNvPr id="38" name="Shape 36"/>
           <p:cNvSpPr/>
           <p:nvPr/>
         </p:nvSpPr>
@@ -5482,7 +5616,7 @@
       </p:sp>
       <p:sp>
         <p:nvSpPr>
-          <p:cNvPr id="35" name="Text 33"/>
+          <p:cNvPr id="39" name="Text 37"/>
           <p:cNvSpPr/>
           <p:nvPr/>
         </p:nvSpPr>

</xml_diff>

<commit_message>
Make the risk slide readable from the room
This slide carries the argument, and at 12.5/11/10.5pt it read like an appendix.
Type is up across the board — headings 14pt, the risk itself 12.5pt, mitigations
11.5pt — with line spacing opened to 1.2.

The blocking risks are now unmissable rather than inferred from a border colour:
they sit on the lit card fill with a red rule and a "blocking" pill next to the
heading, while the four manageable ones drop back to the darker fill. Every card
carries a full-height accent bar on its RTL start edge.

Larger type needs shorter lines, so headings were cut to two words and each risk
and mitigation was tightened to fit at the new size without shrinking anything.

Co-Authored-By: Claude Opus 5 <noreply@anthropic.com>
Claude-Session: https://claude.ai/code/session_01MZnQ3bUVeTyJdPFvjg3J88
</commit_message>
<xml_diff>
--- a/presentations/ecs-to-s3/Harel_ECS_to_S3_CIO.pptx
+++ b/presentations/ecs-to-s3/Harel_ECS_to_S3_CIO.pptx
@@ -9680,20 +9680,20 @@
         </p:nvSpPr>
         <p:spPr>
           <a:xfrm>
-            <a:off x="8122615" y="2011680"/>
-            <a:ext cx="3246120" cy="1773936"/>
+            <a:off x="8122615" y="1975104"/>
+            <a:ext cx="3246120" cy="1810512"/>
           </a:xfrm>
           <a:prstGeom prst="roundRect">
             <a:avLst>
-              <a:gd name="adj" fmla="val 2577"/>
+              <a:gd name="adj" fmla="val 2525"/>
             </a:avLst>
           </a:prstGeom>
           <a:solidFill>
             <a:srgbClr val="182133"/>
           </a:solidFill>
-          <a:ln w="12700">
+          <a:ln w="19050">
             <a:solidFill>
-              <a:srgbClr val="5A2A38"/>
+              <a:srgbClr val="FF6B7A"/>
             </a:solidFill>
             <a:prstDash val="solid"/>
           </a:ln>
@@ -9707,8 +9707,8 @@
         </p:nvSpPr>
         <p:spPr>
           <a:xfrm>
-            <a:off x="10948111" y="2231136"/>
-            <a:ext cx="118872" cy="118872"/>
+            <a:off x="11318443" y="2121408"/>
+            <a:ext cx="50292" cy="1517904"/>
           </a:xfrm>
           <a:prstGeom prst="rect">
             <a:avLst/>
@@ -9732,8 +9732,8 @@
         </p:nvSpPr>
         <p:spPr>
           <a:xfrm>
-            <a:off x="8378647" y="2157984"/>
-            <a:ext cx="2478024" cy="256032"/>
+            <a:off x="9421063" y="2103120"/>
+            <a:ext cx="1618488" cy="310896"/>
           </a:xfrm>
           <a:prstGeom prst="rect">
             <a:avLst/>
@@ -9752,7 +9752,7 @@
               <a:buNone/>
             </a:pPr>
             <a:r>
-              <a:rPr lang="he-IL" altLang="en-US" sz="1250" b="1" dirty="0">
+              <a:rPr lang="he-IL" altLang="en-US" sz="1400" b="1" dirty="0">
                 <a:solidFill>
                   <a:srgbClr val="FF6B7A"/>
                 </a:solidFill>
@@ -9760,7 +9760,118 @@
                 <a:ea typeface="Calibri" pitchFamily="34" charset="-122"/>
                 <a:cs typeface="Calibri" pitchFamily="34" charset="-120"/>
               </a:rPr>
-              <a:t>‫משפטי · קבילות ואישור‬</a:t>
+              <a:t>‫משפטי · קבילות‬</a:t>
+            </a:r>
+            <a:endParaRPr lang="he-IL" sz="1400" dirty="0"/>
+          </a:p>
+        </p:txBody>
+      </p:sp>
+      <p:sp>
+        <p:nvSpPr>
+          <p:cNvPr id="8" name="Shape 6"/>
+          <p:cNvSpPr/>
+          <p:nvPr/>
+        </p:nvSpPr>
+        <p:spPr>
+          <a:xfrm>
+            <a:off x="8378647" y="2139696"/>
+            <a:ext cx="932688" cy="237744"/>
+          </a:xfrm>
+          <a:prstGeom prst="roundRect">
+            <a:avLst>
+              <a:gd name="adj" fmla="val 115385"/>
+            </a:avLst>
+          </a:prstGeom>
+          <a:solidFill>
+            <a:srgbClr val="3A1620"/>
+          </a:solidFill>
+          <a:ln w="12700">
+            <a:solidFill>
+              <a:srgbClr val="3A1620"/>
+            </a:solidFill>
+            <a:prstDash val="solid"/>
+          </a:ln>
+        </p:spPr>
+      </p:sp>
+      <p:sp>
+        <p:nvSpPr>
+          <p:cNvPr id="9" name="Text 7"/>
+          <p:cNvSpPr/>
+          <p:nvPr/>
+        </p:nvSpPr>
+        <p:spPr>
+          <a:xfrm>
+            <a:off x="8378647" y="2139696"/>
+            <a:ext cx="932688" cy="237744"/>
+          </a:xfrm>
+          <a:prstGeom prst="rect">
+            <a:avLst/>
+          </a:prstGeom>
+          <a:noFill/>
+          <a:ln/>
+        </p:spPr>
+        <p:txBody>
+          <a:bodyPr wrap="square" lIns="0" tIns="0" rIns="0" bIns="0" rtlCol="0" anchor="ctr"/>
+          <a:lstStyle/>
+          <a:p>
+            <a:pPr rtl="1" algn="ctr" indent="0" marL="0">
+              <a:lnSpc>
+                <a:spcPct val="100000"/>
+              </a:lnSpc>
+              <a:buNone/>
+            </a:pPr>
+            <a:r>
+              <a:rPr lang="he-IL" altLang="en-US" sz="950" b="1" dirty="0">
+                <a:solidFill>
+                  <a:srgbClr val="FF6B7A"/>
+                </a:solidFill>
+                <a:latin typeface="Calibri" pitchFamily="34" charset="0"/>
+                <a:ea typeface="Calibri" pitchFamily="34" charset="-122"/>
+                <a:cs typeface="Calibri" pitchFamily="34" charset="-120"/>
+              </a:rPr>
+              <a:t>‫חוסם התחלה‬</a:t>
+            </a:r>
+            <a:endParaRPr lang="he-IL" sz="950" dirty="0"/>
+          </a:p>
+        </p:txBody>
+      </p:sp>
+      <p:sp>
+        <p:nvSpPr>
+          <p:cNvPr id="10" name="Text 8"/>
+          <p:cNvSpPr/>
+          <p:nvPr/>
+        </p:nvSpPr>
+        <p:spPr>
+          <a:xfrm>
+            <a:off x="8378647" y="2468880"/>
+            <a:ext cx="2679192" cy="457200"/>
+          </a:xfrm>
+          <a:prstGeom prst="rect">
+            <a:avLst/>
+          </a:prstGeom>
+          <a:noFill/>
+          <a:ln/>
+        </p:spPr>
+        <p:txBody>
+          <a:bodyPr wrap="square" lIns="0" tIns="0" rIns="0" bIns="0" rtlCol="0" anchor="t"/>
+          <a:lstStyle/>
+          <a:p>
+            <a:pPr rtl="1" algn="r" indent="0" marL="0">
+              <a:lnSpc>
+                <a:spcPct val="120000"/>
+              </a:lnSpc>
+              <a:buNone/>
+            </a:pPr>
+            <a:r>
+              <a:rPr lang="he-IL" altLang="en-US" sz="1250" dirty="0">
+                <a:solidFill>
+                  <a:srgbClr val="F4F7FB"/>
+                </a:solidFill>
+                <a:latin typeface="Calibri" pitchFamily="34" charset="0"/>
+                <a:ea typeface="Calibri" pitchFamily="34" charset="-122"/>
+                <a:cs typeface="Calibri" pitchFamily="34" charset="-120"/>
+              </a:rPr>
+              <a:t>‫שם הקובץ ותאריך היצירה משתנים בהעתקה. בית משפט עשוי לדרוש אסמכתא שהתוכן לא שונה.‬</a:t>
             </a:r>
             <a:endParaRPr lang="he-IL" sz="1250" dirty="0"/>
           </a:p>
@@ -9768,56 +9879,14 @@
       </p:sp>
       <p:sp>
         <p:nvSpPr>
-          <p:cNvPr id="8" name="Text 6"/>
-          <p:cNvSpPr/>
-          <p:nvPr/>
-        </p:nvSpPr>
-        <p:spPr>
-          <a:xfrm>
-            <a:off x="8378647" y="2450592"/>
-            <a:ext cx="2734056" cy="512064"/>
-          </a:xfrm>
-          <a:prstGeom prst="rect">
-            <a:avLst/>
-          </a:prstGeom>
-          <a:noFill/>
-          <a:ln/>
-        </p:spPr>
-        <p:txBody>
-          <a:bodyPr wrap="square" lIns="0" tIns="0" rIns="0" bIns="0" rtlCol="0" anchor="t"/>
-          <a:lstStyle/>
-          <a:p>
-            <a:pPr rtl="1" algn="r" indent="0" marL="0">
-              <a:lnSpc>
-                <a:spcPct val="116000"/>
-              </a:lnSpc>
-              <a:buNone/>
-            </a:pPr>
-            <a:r>
-              <a:rPr lang="he-IL" altLang="en-US" sz="1100" dirty="0">
-                <a:solidFill>
-                  <a:srgbClr val="F4F7FB"/>
-                </a:solidFill>
-                <a:latin typeface="Calibri" pitchFamily="34" charset="0"/>
-                <a:ea typeface="Calibri" pitchFamily="34" charset="-122"/>
-                <a:cs typeface="Calibri" pitchFamily="34" charset="-120"/>
-              </a:rPr>
-              <a:t>‫שם הקובץ ותאריך היצירה משתנים בהעתקה. בית משפט עשוי לדרוש אסמכתא שהתוכן לא שונה.‬</a:t>
-            </a:r>
-            <a:endParaRPr lang="he-IL" sz="1100" dirty="0"/>
-          </a:p>
-        </p:txBody>
-      </p:sp>
-      <p:sp>
-        <p:nvSpPr>
-          <p:cNvPr id="9" name="Shape 7"/>
-          <p:cNvSpPr/>
-          <p:nvPr/>
-        </p:nvSpPr>
-        <p:spPr>
-          <a:xfrm>
-            <a:off x="8378647" y="2999232"/>
-            <a:ext cx="2734056" cy="9144"/>
+          <p:cNvPr id="11" name="Shape 9"/>
+          <p:cNvSpPr/>
+          <p:nvPr/>
+        </p:nvSpPr>
+        <p:spPr>
+          <a:xfrm>
+            <a:off x="8378647" y="2962656"/>
+            <a:ext cx="2679192" cy="9144"/>
           </a:xfrm>
           <a:prstGeom prst="rect">
             <a:avLst/>
@@ -9835,14 +9904,14 @@
       </p:sp>
       <p:sp>
         <p:nvSpPr>
-          <p:cNvPr id="10" name="Text 8"/>
-          <p:cNvSpPr/>
-          <p:nvPr/>
-        </p:nvSpPr>
-        <p:spPr>
-          <a:xfrm>
-            <a:off x="8378647" y="3063240"/>
-            <a:ext cx="2734056" cy="658368"/>
+          <p:cNvPr id="12" name="Text 10"/>
+          <p:cNvSpPr/>
+          <p:nvPr/>
+        </p:nvSpPr>
+        <p:spPr>
+          <a:xfrm>
+            <a:off x="8378647" y="3035808"/>
+            <a:ext cx="2679192" cy="658368"/>
           </a:xfrm>
           <a:prstGeom prst="rect">
             <a:avLst/>
@@ -9856,12 +9925,12 @@
           <a:p>
             <a:pPr rtl="1" algn="r" indent="0" marL="0">
               <a:lnSpc>
-                <a:spcPct val="116000"/>
-              </a:lnSpc>
-              <a:buNone/>
-            </a:pPr>
-            <a:r>
-              <a:rPr lang="he-IL" altLang="en-US" sz="1050" dirty="0">
+                <a:spcPct val="120000"/>
+              </a:lnSpc>
+              <a:buNone/>
+            </a:pPr>
+            <a:r>
+              <a:rPr lang="he-IL" altLang="en-US" sz="1150" dirty="0">
                 <a:solidFill>
                   <a:srgbClr val="91A0B7"/>
                 </a:solidFill>
@@ -9869,34 +9938,34 @@
                 <a:ea typeface="Calibri" pitchFamily="34" charset="-122"/>
                 <a:cs typeface="Calibri" pitchFamily="34" charset="-120"/>
               </a:rPr>
-              <a:t>‫מיטיגציה: ‪manifest‬ חתום ‪SHA-256‬ לכל אובייקט — שם מקורי, שם יעד ותאריך מקור — יחד עם ‪S3 Object Lock‬. הפתרון מחייב אישור מפורש של הלשכה המשפטית לפני ההעתקה הראשונה.‬</a:t>
-            </a:r>
-            <a:endParaRPr lang="he-IL" sz="1050" dirty="0"/>
-          </a:p>
-        </p:txBody>
-      </p:sp>
-      <p:sp>
-        <p:nvSpPr>
-          <p:cNvPr id="11" name="Shape 9"/>
-          <p:cNvSpPr/>
-          <p:nvPr/>
-        </p:nvSpPr>
-        <p:spPr>
-          <a:xfrm>
-            <a:off x="4474159" y="2011680"/>
-            <a:ext cx="3246120" cy="1773936"/>
+              <a:t>‫מיטיגציה: ‪manifest‬ חתום ‪SHA-256‬ לכל אובייקט — שם מקורי, שם יעד ותאריך מקור — עם ‪S3 Object Lock‬. נדרש אישור מפורש של הלשכה המשפטית לפני ההעתקה.‬</a:t>
+            </a:r>
+            <a:endParaRPr lang="he-IL" sz="1150" dirty="0"/>
+          </a:p>
+        </p:txBody>
+      </p:sp>
+      <p:sp>
+        <p:nvSpPr>
+          <p:cNvPr id="13" name="Shape 11"/>
+          <p:cNvSpPr/>
+          <p:nvPr/>
+        </p:nvSpPr>
+        <p:spPr>
+          <a:xfrm>
+            <a:off x="4474159" y="1975104"/>
+            <a:ext cx="3246120" cy="1810512"/>
           </a:xfrm>
           <a:prstGeom prst="roundRect">
             <a:avLst>
-              <a:gd name="adj" fmla="val 2577"/>
+              <a:gd name="adj" fmla="val 2525"/>
             </a:avLst>
           </a:prstGeom>
           <a:solidFill>
             <a:srgbClr val="182133"/>
           </a:solidFill>
-          <a:ln w="12700">
+          <a:ln w="19050">
             <a:solidFill>
-              <a:srgbClr val="5A2A38"/>
+              <a:srgbClr val="FF6B7A"/>
             </a:solidFill>
             <a:prstDash val="solid"/>
           </a:ln>
@@ -9904,14 +9973,14 @@
       </p:sp>
       <p:sp>
         <p:nvSpPr>
-          <p:cNvPr id="12" name="Shape 10"/>
-          <p:cNvSpPr/>
-          <p:nvPr/>
-        </p:nvSpPr>
-        <p:spPr>
-          <a:xfrm>
-            <a:off x="7299655" y="2231136"/>
-            <a:ext cx="118872" cy="118872"/>
+          <p:cNvPr id="14" name="Shape 12"/>
+          <p:cNvSpPr/>
+          <p:nvPr/>
+        </p:nvSpPr>
+        <p:spPr>
+          <a:xfrm>
+            <a:off x="7669987" y="2121408"/>
+            <a:ext cx="50292" cy="1517904"/>
           </a:xfrm>
           <a:prstGeom prst="rect">
             <a:avLst/>
@@ -9929,14 +9998,14 @@
       </p:sp>
       <p:sp>
         <p:nvSpPr>
-          <p:cNvPr id="13" name="Text 11"/>
-          <p:cNvSpPr/>
-          <p:nvPr/>
-        </p:nvSpPr>
-        <p:spPr>
-          <a:xfrm>
-            <a:off x="4730191" y="2157984"/>
-            <a:ext cx="2478024" cy="256032"/>
+          <p:cNvPr id="15" name="Text 13"/>
+          <p:cNvSpPr/>
+          <p:nvPr/>
+        </p:nvSpPr>
+        <p:spPr>
+          <a:xfrm>
+            <a:off x="5772607" y="2103120"/>
+            <a:ext cx="1618488" cy="310896"/>
           </a:xfrm>
           <a:prstGeom prst="rect">
             <a:avLst/>
@@ -9955,7 +10024,7 @@
               <a:buNone/>
             </a:pPr>
             <a:r>
-              <a:rPr lang="he-IL" altLang="en-US" sz="1250" b="1" dirty="0">
+              <a:rPr lang="he-IL" altLang="en-US" sz="1400" b="1" dirty="0">
                 <a:solidFill>
                   <a:srgbClr val="FF6B7A"/>
                 </a:solidFill>
@@ -9965,62 +10034,131 @@
               </a:rPr>
               <a:t>‫רגולציה · ריבונות‬</a:t>
             </a:r>
+            <a:endParaRPr lang="he-IL" sz="1400" dirty="0"/>
+          </a:p>
+        </p:txBody>
+      </p:sp>
+      <p:sp>
+        <p:nvSpPr>
+          <p:cNvPr id="16" name="Shape 14"/>
+          <p:cNvSpPr/>
+          <p:nvPr/>
+        </p:nvSpPr>
+        <p:spPr>
+          <a:xfrm>
+            <a:off x="4730191" y="2139696"/>
+            <a:ext cx="932688" cy="237744"/>
+          </a:xfrm>
+          <a:prstGeom prst="roundRect">
+            <a:avLst>
+              <a:gd name="adj" fmla="val 115385"/>
+            </a:avLst>
+          </a:prstGeom>
+          <a:solidFill>
+            <a:srgbClr val="3A1620"/>
+          </a:solidFill>
+          <a:ln w="12700">
+            <a:solidFill>
+              <a:srgbClr val="3A1620"/>
+            </a:solidFill>
+            <a:prstDash val="solid"/>
+          </a:ln>
+        </p:spPr>
+      </p:sp>
+      <p:sp>
+        <p:nvSpPr>
+          <p:cNvPr id="17" name="Text 15"/>
+          <p:cNvSpPr/>
+          <p:nvPr/>
+        </p:nvSpPr>
+        <p:spPr>
+          <a:xfrm>
+            <a:off x="4730191" y="2139696"/>
+            <a:ext cx="932688" cy="237744"/>
+          </a:xfrm>
+          <a:prstGeom prst="rect">
+            <a:avLst/>
+          </a:prstGeom>
+          <a:noFill/>
+          <a:ln/>
+        </p:spPr>
+        <p:txBody>
+          <a:bodyPr wrap="square" lIns="0" tIns="0" rIns="0" bIns="0" rtlCol="0" anchor="ctr"/>
+          <a:lstStyle/>
+          <a:p>
+            <a:pPr rtl="1" algn="ctr" indent="0" marL="0">
+              <a:lnSpc>
+                <a:spcPct val="100000"/>
+              </a:lnSpc>
+              <a:buNone/>
+            </a:pPr>
+            <a:r>
+              <a:rPr lang="he-IL" altLang="en-US" sz="950" b="1" dirty="0">
+                <a:solidFill>
+                  <a:srgbClr val="FF6B7A"/>
+                </a:solidFill>
+                <a:latin typeface="Calibri" pitchFamily="34" charset="0"/>
+                <a:ea typeface="Calibri" pitchFamily="34" charset="-122"/>
+                <a:cs typeface="Calibri" pitchFamily="34" charset="-120"/>
+              </a:rPr>
+              <a:t>‫חוסם התחלה‬</a:t>
+            </a:r>
+            <a:endParaRPr lang="he-IL" sz="950" dirty="0"/>
+          </a:p>
+        </p:txBody>
+      </p:sp>
+      <p:sp>
+        <p:nvSpPr>
+          <p:cNvPr id="18" name="Text 16"/>
+          <p:cNvSpPr/>
+          <p:nvPr/>
+        </p:nvSpPr>
+        <p:spPr>
+          <a:xfrm>
+            <a:off x="4730191" y="2468880"/>
+            <a:ext cx="2679192" cy="457200"/>
+          </a:xfrm>
+          <a:prstGeom prst="rect">
+            <a:avLst/>
+          </a:prstGeom>
+          <a:noFill/>
+          <a:ln/>
+        </p:spPr>
+        <p:txBody>
+          <a:bodyPr wrap="square" lIns="0" tIns="0" rIns="0" bIns="0" rtlCol="0" anchor="t"/>
+          <a:lstStyle/>
+          <a:p>
+            <a:pPr rtl="1" algn="r" indent="0" marL="0">
+              <a:lnSpc>
+                <a:spcPct val="120000"/>
+              </a:lnSpc>
+              <a:buNone/>
+            </a:pPr>
+            <a:r>
+              <a:rPr lang="he-IL" altLang="en-US" sz="1250" dirty="0">
+                <a:solidFill>
+                  <a:srgbClr val="F4F7FB"/>
+                </a:solidFill>
+                <a:latin typeface="Calibri" pitchFamily="34" charset="0"/>
+                <a:ea typeface="Calibri" pitchFamily="34" charset="-122"/>
+                <a:cs typeface="Calibri" pitchFamily="34" charset="-120"/>
+              </a:rPr>
+              <a:t>‫מידע רפואי ופיננסי מזוהה היוצא משליטת הארגון.‬</a:t>
+            </a:r>
             <a:endParaRPr lang="he-IL" sz="1250" dirty="0"/>
           </a:p>
         </p:txBody>
       </p:sp>
       <p:sp>
         <p:nvSpPr>
-          <p:cNvPr id="14" name="Text 12"/>
-          <p:cNvSpPr/>
-          <p:nvPr/>
-        </p:nvSpPr>
-        <p:spPr>
-          <a:xfrm>
-            <a:off x="4730191" y="2450592"/>
-            <a:ext cx="2734056" cy="512064"/>
-          </a:xfrm>
-          <a:prstGeom prst="rect">
-            <a:avLst/>
-          </a:prstGeom>
-          <a:noFill/>
-          <a:ln/>
-        </p:spPr>
-        <p:txBody>
-          <a:bodyPr wrap="square" lIns="0" tIns="0" rIns="0" bIns="0" rtlCol="0" anchor="t"/>
-          <a:lstStyle/>
-          <a:p>
-            <a:pPr rtl="1" algn="r" indent="0" marL="0">
-              <a:lnSpc>
-                <a:spcPct val="116000"/>
-              </a:lnSpc>
-              <a:buNone/>
-            </a:pPr>
-            <a:r>
-              <a:rPr lang="he-IL" altLang="en-US" sz="1100" dirty="0">
-                <a:solidFill>
-                  <a:srgbClr val="F4F7FB"/>
-                </a:solidFill>
-                <a:latin typeface="Calibri" pitchFamily="34" charset="0"/>
-                <a:ea typeface="Calibri" pitchFamily="34" charset="-122"/>
-                <a:cs typeface="Calibri" pitchFamily="34" charset="-120"/>
-              </a:rPr>
-              <a:t>‫מידע רפואי ופיננסי מזוהה היוצא משליטת הארגון.‬</a:t>
-            </a:r>
-            <a:endParaRPr lang="he-IL" sz="1100" dirty="0"/>
-          </a:p>
-        </p:txBody>
-      </p:sp>
-      <p:sp>
-        <p:nvSpPr>
-          <p:cNvPr id="15" name="Shape 13"/>
-          <p:cNvSpPr/>
-          <p:nvPr/>
-        </p:nvSpPr>
-        <p:spPr>
-          <a:xfrm>
-            <a:off x="4730191" y="2999232"/>
-            <a:ext cx="2734056" cy="9144"/>
+          <p:cNvPr id="19" name="Shape 17"/>
+          <p:cNvSpPr/>
+          <p:nvPr/>
+        </p:nvSpPr>
+        <p:spPr>
+          <a:xfrm>
+            <a:off x="4730191" y="2962656"/>
+            <a:ext cx="2679192" cy="9144"/>
           </a:xfrm>
           <a:prstGeom prst="rect">
             <a:avLst/>
@@ -10038,14 +10176,14 @@
       </p:sp>
       <p:sp>
         <p:nvSpPr>
-          <p:cNvPr id="16" name="Text 14"/>
-          <p:cNvSpPr/>
-          <p:nvPr/>
-        </p:nvSpPr>
-        <p:spPr>
-          <a:xfrm>
-            <a:off x="4730191" y="3063240"/>
-            <a:ext cx="2734056" cy="658368"/>
+          <p:cNvPr id="20" name="Text 18"/>
+          <p:cNvSpPr/>
+          <p:nvPr/>
+        </p:nvSpPr>
+        <p:spPr>
+          <a:xfrm>
+            <a:off x="4730191" y="3035808"/>
+            <a:ext cx="2679192" cy="658368"/>
           </a:xfrm>
           <a:prstGeom prst="rect">
             <a:avLst/>
@@ -10059,12 +10197,12 @@
           <a:p>
             <a:pPr rtl="1" algn="r" indent="0" marL="0">
               <a:lnSpc>
-                <a:spcPct val="116000"/>
-              </a:lnSpc>
-              <a:buNone/>
-            </a:pPr>
-            <a:r>
-              <a:rPr lang="he-IL" altLang="en-US" sz="1050" dirty="0">
+                <a:spcPct val="120000"/>
+              </a:lnSpc>
+              <a:buNone/>
+            </a:pPr>
+            <a:r>
+              <a:rPr lang="he-IL" altLang="en-US" sz="1150" dirty="0">
                 <a:solidFill>
                   <a:srgbClr val="91A0B7"/>
                 </a:solidFill>
@@ -10074,28 +10212,28 @@
               </a:rPr>
               <a:t>‫מיטיגציה: אזור ‪il-central-1‬ בתל אביב, הצפנה ב-‪KMS‬ עם מפתח בבעלותנו, ואישור ‪DPO‬ ורגולטור לפני ההעתקה.‬</a:t>
             </a:r>
-            <a:endParaRPr lang="he-IL" sz="1050" dirty="0"/>
-          </a:p>
-        </p:txBody>
-      </p:sp>
-      <p:sp>
-        <p:nvSpPr>
-          <p:cNvPr id="17" name="Shape 15"/>
-          <p:cNvSpPr/>
-          <p:nvPr/>
-        </p:nvSpPr>
-        <p:spPr>
-          <a:xfrm>
-            <a:off x="825703" y="2011680"/>
-            <a:ext cx="3246120" cy="1773936"/>
+            <a:endParaRPr lang="he-IL" sz="1150" dirty="0"/>
+          </a:p>
+        </p:txBody>
+      </p:sp>
+      <p:sp>
+        <p:nvSpPr>
+          <p:cNvPr id="21" name="Shape 19"/>
+          <p:cNvSpPr/>
+          <p:nvPr/>
+        </p:nvSpPr>
+        <p:spPr>
+          <a:xfrm>
+            <a:off x="825703" y="1975104"/>
+            <a:ext cx="3246120" cy="1810512"/>
           </a:xfrm>
           <a:prstGeom prst="roundRect">
             <a:avLst>
-              <a:gd name="adj" fmla="val 2577"/>
+              <a:gd name="adj" fmla="val 2525"/>
             </a:avLst>
           </a:prstGeom>
           <a:solidFill>
-            <a:srgbClr val="182133"/>
+            <a:srgbClr val="141C2C"/>
           </a:solidFill>
           <a:ln w="12700">
             <a:solidFill>
@@ -10107,14 +10245,14 @@
       </p:sp>
       <p:sp>
         <p:nvSpPr>
-          <p:cNvPr id="18" name="Shape 16"/>
-          <p:cNvSpPr/>
-          <p:nvPr/>
-        </p:nvSpPr>
-        <p:spPr>
-          <a:xfrm>
-            <a:off x="3651199" y="2231136"/>
-            <a:ext cx="118872" cy="118872"/>
+          <p:cNvPr id="22" name="Shape 20"/>
+          <p:cNvSpPr/>
+          <p:nvPr/>
+        </p:nvSpPr>
+        <p:spPr>
+          <a:xfrm>
+            <a:off x="4021531" y="2121408"/>
+            <a:ext cx="50292" cy="1517904"/>
           </a:xfrm>
           <a:prstGeom prst="rect">
             <a:avLst/>
@@ -10132,14 +10270,14 @@
       </p:sp>
       <p:sp>
         <p:nvSpPr>
-          <p:cNvPr id="19" name="Text 17"/>
-          <p:cNvSpPr/>
-          <p:nvPr/>
-        </p:nvSpPr>
-        <p:spPr>
-          <a:xfrm>
-            <a:off x="1081735" y="2157984"/>
-            <a:ext cx="2478024" cy="256032"/>
+          <p:cNvPr id="23" name="Text 21"/>
+          <p:cNvSpPr/>
+          <p:nvPr/>
+        </p:nvSpPr>
+        <p:spPr>
+          <a:xfrm>
+            <a:off x="2124151" y="2103120"/>
+            <a:ext cx="1618488" cy="310896"/>
           </a:xfrm>
           <a:prstGeom prst="rect">
             <a:avLst/>
@@ -10158,7 +10296,7 @@
               <a:buNone/>
             </a:pPr>
             <a:r>
-              <a:rPr lang="he-IL" altLang="en-US" sz="1250" b="1" dirty="0">
+              <a:rPr lang="he-IL" altLang="en-US" sz="1400" b="1" dirty="0">
                 <a:solidFill>
                   <a:srgbClr val="FF9F43"/>
                 </a:solidFill>
@@ -10166,7 +10304,49 @@
                 <a:ea typeface="Calibri" pitchFamily="34" charset="-122"/>
                 <a:cs typeface="Calibri" pitchFamily="34" charset="-120"/>
               </a:rPr>
-              <a:t>‫אפליקציה · שינוי מצביעים‬</a:t>
+              <a:t>‫אפליקציה · מצביעים‬</a:t>
+            </a:r>
+            <a:endParaRPr lang="he-IL" sz="1400" dirty="0"/>
+          </a:p>
+        </p:txBody>
+      </p:sp>
+      <p:sp>
+        <p:nvSpPr>
+          <p:cNvPr id="24" name="Text 22"/>
+          <p:cNvSpPr/>
+          <p:nvPr/>
+        </p:nvSpPr>
+        <p:spPr>
+          <a:xfrm>
+            <a:off x="1081735" y="2468880"/>
+            <a:ext cx="2679192" cy="457200"/>
+          </a:xfrm>
+          <a:prstGeom prst="rect">
+            <a:avLst/>
+          </a:prstGeom>
+          <a:noFill/>
+          <a:ln/>
+        </p:spPr>
+        <p:txBody>
+          <a:bodyPr wrap="square" lIns="0" tIns="0" rIns="0" bIns="0" rtlCol="0" anchor="t"/>
+          <a:lstStyle/>
+          <a:p>
+            <a:pPr rtl="1" algn="r" indent="0" marL="0">
+              <a:lnSpc>
+                <a:spcPct val="120000"/>
+              </a:lnSpc>
+              <a:buNone/>
+            </a:pPr>
+            <a:r>
+              <a:rPr lang="he-IL" altLang="en-US" sz="1250" dirty="0">
+                <a:solidFill>
+                  <a:srgbClr val="F4F7FB"/>
+                </a:solidFill>
+                <a:latin typeface="Calibri" pitchFamily="34" charset="0"/>
+                <a:ea typeface="Calibri" pitchFamily="34" charset="-122"/>
+                <a:cs typeface="Calibri" pitchFamily="34" charset="-120"/>
+              </a:rPr>
+              <a:t>‫האפליקציות מצביעות לנתיב ב-‪ECS‬. מעבר ל-‪S3‬ מחייב פיתוח בצד היישום, לא רק העברת דאטה.‬</a:t>
             </a:r>
             <a:endParaRPr lang="he-IL" sz="1250" dirty="0"/>
           </a:p>
@@ -10174,56 +10354,14 @@
       </p:sp>
       <p:sp>
         <p:nvSpPr>
-          <p:cNvPr id="20" name="Text 18"/>
-          <p:cNvSpPr/>
-          <p:nvPr/>
-        </p:nvSpPr>
-        <p:spPr>
-          <a:xfrm>
-            <a:off x="1081735" y="2450592"/>
-            <a:ext cx="2734056" cy="512064"/>
-          </a:xfrm>
-          <a:prstGeom prst="rect">
-            <a:avLst/>
-          </a:prstGeom>
-          <a:noFill/>
-          <a:ln/>
-        </p:spPr>
-        <p:txBody>
-          <a:bodyPr wrap="square" lIns="0" tIns="0" rIns="0" bIns="0" rtlCol="0" anchor="t"/>
-          <a:lstStyle/>
-          <a:p>
-            <a:pPr rtl="1" algn="r" indent="0" marL="0">
-              <a:lnSpc>
-                <a:spcPct val="116000"/>
-              </a:lnSpc>
-              <a:buNone/>
-            </a:pPr>
-            <a:r>
-              <a:rPr lang="he-IL" altLang="en-US" sz="1100" dirty="0">
-                <a:solidFill>
-                  <a:srgbClr val="F4F7FB"/>
-                </a:solidFill>
-                <a:latin typeface="Calibri" pitchFamily="34" charset="0"/>
-                <a:ea typeface="Calibri" pitchFamily="34" charset="-122"/>
-                <a:cs typeface="Calibri" pitchFamily="34" charset="-120"/>
-              </a:rPr>
-              <a:t>‫האפליקציות מצביעות היום לנתיב ב-‪ECS‬. מעבר ל-‪S3‬ מחייב פיתוח בצד היישום, לא רק העברת דאטה.‬</a:t>
-            </a:r>
-            <a:endParaRPr lang="he-IL" sz="1100" dirty="0"/>
-          </a:p>
-        </p:txBody>
-      </p:sp>
-      <p:sp>
-        <p:nvSpPr>
-          <p:cNvPr id="21" name="Shape 19"/>
-          <p:cNvSpPr/>
-          <p:nvPr/>
-        </p:nvSpPr>
-        <p:spPr>
-          <a:xfrm>
-            <a:off x="1081735" y="2999232"/>
-            <a:ext cx="2734056" cy="9144"/>
+          <p:cNvPr id="25" name="Shape 23"/>
+          <p:cNvSpPr/>
+          <p:nvPr/>
+        </p:nvSpPr>
+        <p:spPr>
+          <a:xfrm>
+            <a:off x="1081735" y="2962656"/>
+            <a:ext cx="2679192" cy="9144"/>
           </a:xfrm>
           <a:prstGeom prst="rect">
             <a:avLst/>
@@ -10241,14 +10379,14 @@
       </p:sp>
       <p:sp>
         <p:nvSpPr>
-          <p:cNvPr id="22" name="Text 20"/>
-          <p:cNvSpPr/>
-          <p:nvPr/>
-        </p:nvSpPr>
-        <p:spPr>
-          <a:xfrm>
-            <a:off x="1081735" y="3063240"/>
-            <a:ext cx="2734056" cy="658368"/>
+          <p:cNvPr id="26" name="Text 24"/>
+          <p:cNvSpPr/>
+          <p:nvPr/>
+        </p:nvSpPr>
+        <p:spPr>
+          <a:xfrm>
+            <a:off x="1081735" y="3035808"/>
+            <a:ext cx="2679192" cy="658368"/>
           </a:xfrm>
           <a:prstGeom prst="rect">
             <a:avLst/>
@@ -10262,12 +10400,12 @@
           <a:p>
             <a:pPr rtl="1" algn="r" indent="0" marL="0">
               <a:lnSpc>
-                <a:spcPct val="116000"/>
-              </a:lnSpc>
-              <a:buNone/>
-            </a:pPr>
-            <a:r>
-              <a:rPr lang="he-IL" altLang="en-US" sz="1050" dirty="0">
+                <a:spcPct val="120000"/>
+              </a:lnSpc>
+              <a:buNone/>
+            </a:pPr>
+            <a:r>
+              <a:rPr lang="he-IL" altLang="en-US" sz="1150" dirty="0">
                 <a:solidFill>
                   <a:srgbClr val="91A0B7"/>
                 </a:solidFill>
@@ -10275,30 +10413,30 @@
                 <a:ea typeface="Calibri" pitchFamily="34" charset="-122"/>
                 <a:cs typeface="Calibri" pitchFamily="34" charset="-120"/>
               </a:rPr>
-              <a:t>‫מיטיגציה: אפיון מול צוותי הדימות ו-‪Verint‬, הערכת מאמץ פיתוח, ותקופת ביניים שבה שתי הכתובות פעילות במקביל.‬</a:t>
-            </a:r>
-            <a:endParaRPr lang="he-IL" sz="1050" dirty="0"/>
-          </a:p>
-        </p:txBody>
-      </p:sp>
-      <p:sp>
-        <p:nvSpPr>
-          <p:cNvPr id="23" name="Shape 21"/>
-          <p:cNvSpPr/>
-          <p:nvPr/>
-        </p:nvSpPr>
-        <p:spPr>
-          <a:xfrm>
-            <a:off x="8122615" y="4023360"/>
-            <a:ext cx="3246120" cy="1773936"/>
+              <a:t>‫מיטיגציה: אפיון מול צוותי הדימות ו-‪Verint‬, הערכת מאמץ פיתוח, ותקופת ביניים ששתי הכתובות פעילות בה.‬</a:t>
+            </a:r>
+            <a:endParaRPr lang="he-IL" sz="1150" dirty="0"/>
+          </a:p>
+        </p:txBody>
+      </p:sp>
+      <p:sp>
+        <p:nvSpPr>
+          <p:cNvPr id="27" name="Shape 25"/>
+          <p:cNvSpPr/>
+          <p:nvPr/>
+        </p:nvSpPr>
+        <p:spPr>
+          <a:xfrm>
+            <a:off x="8122615" y="3986784"/>
+            <a:ext cx="3246120" cy="1810512"/>
           </a:xfrm>
           <a:prstGeom prst="roundRect">
             <a:avLst>
-              <a:gd name="adj" fmla="val 2577"/>
+              <a:gd name="adj" fmla="val 2525"/>
             </a:avLst>
           </a:prstGeom>
           <a:solidFill>
-            <a:srgbClr val="182133"/>
+            <a:srgbClr val="141C2C"/>
           </a:solidFill>
           <a:ln w="12700">
             <a:solidFill>
@@ -10310,14 +10448,14 @@
       </p:sp>
       <p:sp>
         <p:nvSpPr>
-          <p:cNvPr id="24" name="Shape 22"/>
-          <p:cNvSpPr/>
-          <p:nvPr/>
-        </p:nvSpPr>
-        <p:spPr>
-          <a:xfrm>
-            <a:off x="10948111" y="4242816"/>
-            <a:ext cx="118872" cy="118872"/>
+          <p:cNvPr id="28" name="Shape 26"/>
+          <p:cNvSpPr/>
+          <p:nvPr/>
+        </p:nvSpPr>
+        <p:spPr>
+          <a:xfrm>
+            <a:off x="11318443" y="4133088"/>
+            <a:ext cx="50292" cy="1517904"/>
           </a:xfrm>
           <a:prstGeom prst="rect">
             <a:avLst/>
@@ -10335,14 +10473,14 @@
       </p:sp>
       <p:sp>
         <p:nvSpPr>
-          <p:cNvPr id="25" name="Text 23"/>
-          <p:cNvSpPr/>
-          <p:nvPr/>
-        </p:nvSpPr>
-        <p:spPr>
-          <a:xfrm>
-            <a:off x="8378647" y="4169664"/>
-            <a:ext cx="2478024" cy="256032"/>
+          <p:cNvPr id="29" name="Text 27"/>
+          <p:cNvSpPr/>
+          <p:nvPr/>
+        </p:nvSpPr>
+        <p:spPr>
+          <a:xfrm>
+            <a:off x="9421063" y="4114800"/>
+            <a:ext cx="1618488" cy="310896"/>
           </a:xfrm>
           <a:prstGeom prst="rect">
             <a:avLst/>
@@ -10361,7 +10499,7 @@
               <a:buNone/>
             </a:pPr>
             <a:r>
-              <a:rPr lang="he-IL" altLang="en-US" sz="1250" b="1" dirty="0">
+              <a:rPr lang="he-IL" altLang="en-US" sz="1400" b="1" dirty="0">
                 <a:solidFill>
                   <a:srgbClr val="FF9F43"/>
                 </a:solidFill>
@@ -10369,7 +10507,49 @@
                 <a:ea typeface="Calibri" pitchFamily="34" charset="-122"/>
                 <a:cs typeface="Calibri" pitchFamily="34" charset="-120"/>
               </a:rPr>
-              <a:t>‫מיליוני קבצים קטנים‬</a:t>
+              <a:t>‫מיליוני קבצים‬</a:t>
+            </a:r>
+            <a:endParaRPr lang="he-IL" sz="1400" dirty="0"/>
+          </a:p>
+        </p:txBody>
+      </p:sp>
+      <p:sp>
+        <p:nvSpPr>
+          <p:cNvPr id="30" name="Text 28"/>
+          <p:cNvSpPr/>
+          <p:nvPr/>
+        </p:nvSpPr>
+        <p:spPr>
+          <a:xfrm>
+            <a:off x="8378647" y="4480560"/>
+            <a:ext cx="2679192" cy="457200"/>
+          </a:xfrm>
+          <a:prstGeom prst="rect">
+            <a:avLst/>
+          </a:prstGeom>
+          <a:noFill/>
+          <a:ln/>
+        </p:spPr>
+        <p:txBody>
+          <a:bodyPr wrap="square" lIns="0" tIns="0" rIns="0" bIns="0" rtlCol="0" anchor="t"/>
+          <a:lstStyle/>
+          <a:p>
+            <a:pPr rtl="1" algn="r" indent="0" marL="0">
+              <a:lnSpc>
+                <a:spcPct val="120000"/>
+              </a:lnSpc>
+              <a:buNone/>
+            </a:pPr>
+            <a:r>
+              <a:rPr lang="he-IL" altLang="en-US" sz="1250" dirty="0">
+                <a:solidFill>
+                  <a:srgbClr val="F4F7FB"/>
+                </a:solidFill>
+                <a:latin typeface="Calibri" pitchFamily="34" charset="0"/>
+                <a:ea typeface="Calibri" pitchFamily="34" charset="-122"/>
+                <a:cs typeface="Calibri" pitchFamily="34" charset="-120"/>
+              </a:rPr>
+              <a:t>‫מיליוני קבצים קטנים. שמות ומבנה התיקיות ב-‪S3‬ שונים, ואין מיפוי אחד-לאחד.‬</a:t>
             </a:r>
             <a:endParaRPr lang="he-IL" sz="1250" dirty="0"/>
           </a:p>
@@ -10377,56 +10557,14 @@
       </p:sp>
       <p:sp>
         <p:nvSpPr>
-          <p:cNvPr id="26" name="Text 24"/>
-          <p:cNvSpPr/>
-          <p:nvPr/>
-        </p:nvSpPr>
-        <p:spPr>
-          <a:xfrm>
-            <a:off x="8378647" y="4462272"/>
-            <a:ext cx="2734056" cy="512064"/>
-          </a:xfrm>
-          <a:prstGeom prst="rect">
-            <a:avLst/>
-          </a:prstGeom>
-          <a:noFill/>
-          <a:ln/>
-        </p:spPr>
-        <p:txBody>
-          <a:bodyPr wrap="square" lIns="0" tIns="0" rIns="0" bIns="0" rtlCol="0" anchor="t"/>
-          <a:lstStyle/>
-          <a:p>
-            <a:pPr rtl="1" algn="r" indent="0" marL="0">
-              <a:lnSpc>
-                <a:spcPct val="116000"/>
-              </a:lnSpc>
-              <a:buNone/>
-            </a:pPr>
-            <a:r>
-              <a:rPr lang="he-IL" altLang="en-US" sz="1100" dirty="0">
-                <a:solidFill>
-                  <a:srgbClr val="F4F7FB"/>
-                </a:solidFill>
-                <a:latin typeface="Calibri" pitchFamily="34" charset="0"/>
-                <a:ea typeface="Calibri" pitchFamily="34" charset="-122"/>
-                <a:cs typeface="Calibri" pitchFamily="34" charset="-120"/>
-              </a:rPr>
-              <a:t>‫הקורפוס הוא מיליוני קבצים קטנים; שמות ומבנה התיקיות ב-‪S3‬ שונים, ואין מיפוי אחד-לאחד.‬</a:t>
-            </a:r>
-            <a:endParaRPr lang="he-IL" sz="1100" dirty="0"/>
-          </a:p>
-        </p:txBody>
-      </p:sp>
-      <p:sp>
-        <p:nvSpPr>
-          <p:cNvPr id="27" name="Shape 25"/>
-          <p:cNvSpPr/>
-          <p:nvPr/>
-        </p:nvSpPr>
-        <p:spPr>
-          <a:xfrm>
-            <a:off x="8378647" y="5010912"/>
-            <a:ext cx="2734056" cy="9144"/>
+          <p:cNvPr id="31" name="Shape 29"/>
+          <p:cNvSpPr/>
+          <p:nvPr/>
+        </p:nvSpPr>
+        <p:spPr>
+          <a:xfrm>
+            <a:off x="8378647" y="4974336"/>
+            <a:ext cx="2679192" cy="9144"/>
           </a:xfrm>
           <a:prstGeom prst="rect">
             <a:avLst/>
@@ -10444,14 +10582,14 @@
       </p:sp>
       <p:sp>
         <p:nvSpPr>
-          <p:cNvPr id="28" name="Text 26"/>
-          <p:cNvSpPr/>
-          <p:nvPr/>
-        </p:nvSpPr>
-        <p:spPr>
-          <a:xfrm>
-            <a:off x="8378647" y="5074920"/>
-            <a:ext cx="2734056" cy="658368"/>
+          <p:cNvPr id="32" name="Text 30"/>
+          <p:cNvSpPr/>
+          <p:nvPr/>
+        </p:nvSpPr>
+        <p:spPr>
+          <a:xfrm>
+            <a:off x="8378647" y="5047488"/>
+            <a:ext cx="2679192" cy="658368"/>
           </a:xfrm>
           <a:prstGeom prst="rect">
             <a:avLst/>
@@ -10465,12 +10603,12 @@
           <a:p>
             <a:pPr rtl="1" algn="r" indent="0" marL="0">
               <a:lnSpc>
-                <a:spcPct val="116000"/>
-              </a:lnSpc>
-              <a:buNone/>
-            </a:pPr>
-            <a:r>
-              <a:rPr lang="he-IL" altLang="en-US" sz="1050" dirty="0">
+                <a:spcPct val="120000"/>
+              </a:lnSpc>
+              <a:buNone/>
+            </a:pPr>
+            <a:r>
+              <a:rPr lang="he-IL" altLang="en-US" sz="1150" dirty="0">
                 <a:solidFill>
                   <a:srgbClr val="91A0B7"/>
                 </a:solidFill>
@@ -10480,28 +10618,28 @@
               </a:rPr>
               <a:t>‫מיטיגציה: מיפוי שמות ומבנה מוסכם מראש, ואימות של צוותי האפליקציה שכל מסמך נגיש בשמו החדש. נדרש זמן צוות ייעודי.‬</a:t>
             </a:r>
-            <a:endParaRPr lang="he-IL" sz="1050" dirty="0"/>
-          </a:p>
-        </p:txBody>
-      </p:sp>
-      <p:sp>
-        <p:nvSpPr>
-          <p:cNvPr id="29" name="Shape 27"/>
-          <p:cNvSpPr/>
-          <p:nvPr/>
-        </p:nvSpPr>
-        <p:spPr>
-          <a:xfrm>
-            <a:off x="4474159" y="4023360"/>
-            <a:ext cx="3246120" cy="1773936"/>
+            <a:endParaRPr lang="he-IL" sz="1150" dirty="0"/>
+          </a:p>
+        </p:txBody>
+      </p:sp>
+      <p:sp>
+        <p:nvSpPr>
+          <p:cNvPr id="33" name="Shape 31"/>
+          <p:cNvSpPr/>
+          <p:nvPr/>
+        </p:nvSpPr>
+        <p:spPr>
+          <a:xfrm>
+            <a:off x="4474159" y="3986784"/>
+            <a:ext cx="3246120" cy="1810512"/>
           </a:xfrm>
           <a:prstGeom prst="roundRect">
             <a:avLst>
-              <a:gd name="adj" fmla="val 2577"/>
+              <a:gd name="adj" fmla="val 2525"/>
             </a:avLst>
           </a:prstGeom>
           <a:solidFill>
-            <a:srgbClr val="182133"/>
+            <a:srgbClr val="141C2C"/>
           </a:solidFill>
           <a:ln w="12700">
             <a:solidFill>
@@ -10513,14 +10651,14 @@
       </p:sp>
       <p:sp>
         <p:nvSpPr>
-          <p:cNvPr id="30" name="Shape 28"/>
-          <p:cNvSpPr/>
-          <p:nvPr/>
-        </p:nvSpPr>
-        <p:spPr>
-          <a:xfrm>
-            <a:off x="7299655" y="4242816"/>
-            <a:ext cx="118872" cy="118872"/>
+          <p:cNvPr id="34" name="Shape 32"/>
+          <p:cNvSpPr/>
+          <p:nvPr/>
+        </p:nvSpPr>
+        <p:spPr>
+          <a:xfrm>
+            <a:off x="7669987" y="4133088"/>
+            <a:ext cx="50292" cy="1517904"/>
           </a:xfrm>
           <a:prstGeom prst="rect">
             <a:avLst/>
@@ -10538,14 +10676,14 @@
       </p:sp>
       <p:sp>
         <p:nvSpPr>
-          <p:cNvPr id="31" name="Text 29"/>
-          <p:cNvSpPr/>
-          <p:nvPr/>
-        </p:nvSpPr>
-        <p:spPr>
-          <a:xfrm>
-            <a:off x="4730191" y="4169664"/>
-            <a:ext cx="2478024" cy="256032"/>
+          <p:cNvPr id="35" name="Text 33"/>
+          <p:cNvSpPr/>
+          <p:nvPr/>
+        </p:nvSpPr>
+        <p:spPr>
+          <a:xfrm>
+            <a:off x="5772607" y="4114800"/>
+            <a:ext cx="1618488" cy="310896"/>
           </a:xfrm>
           <a:prstGeom prst="rect">
             <a:avLst/>
@@ -10564,7 +10702,7 @@
               <a:buNone/>
             </a:pPr>
             <a:r>
-              <a:rPr lang="he-IL" altLang="en-US" sz="1250" b="1" dirty="0">
+              <a:rPr lang="he-IL" altLang="en-US" sz="1400" b="1" dirty="0">
                 <a:solidFill>
                   <a:srgbClr val="FF9F43"/>
                 </a:solidFill>
@@ -10572,7 +10710,49 @@
                 <a:ea typeface="Calibri" pitchFamily="34" charset="-122"/>
                 <a:cs typeface="Calibri" pitchFamily="34" charset="-120"/>
               </a:rPr>
-              <a:t>‫ביצועים · זמני אחזור‬</a:t>
+              <a:t>‫ביצועים · לטנציה‬</a:t>
+            </a:r>
+            <a:endParaRPr lang="he-IL" sz="1400" dirty="0"/>
+          </a:p>
+        </p:txBody>
+      </p:sp>
+      <p:sp>
+        <p:nvSpPr>
+          <p:cNvPr id="36" name="Text 34"/>
+          <p:cNvSpPr/>
+          <p:nvPr/>
+        </p:nvSpPr>
+        <p:spPr>
+          <a:xfrm>
+            <a:off x="4730191" y="4480560"/>
+            <a:ext cx="2679192" cy="457200"/>
+          </a:xfrm>
+          <a:prstGeom prst="rect">
+            <a:avLst/>
+          </a:prstGeom>
+          <a:noFill/>
+          <a:ln/>
+        </p:spPr>
+        <p:txBody>
+          <a:bodyPr wrap="square" lIns="0" tIns="0" rIns="0" bIns="0" rtlCol="0" anchor="t"/>
+          <a:lstStyle/>
+          <a:p>
+            <a:pPr rtl="1" algn="r" indent="0" marL="0">
+              <a:lnSpc>
+                <a:spcPct val="120000"/>
+              </a:lnSpc>
+              <a:buNone/>
+            </a:pPr>
+            <a:r>
+              <a:rPr lang="he-IL" altLang="en-US" sz="1250" dirty="0">
+                <a:solidFill>
+                  <a:srgbClr val="F4F7FB"/>
+                </a:solidFill>
+                <a:latin typeface="Calibri" pitchFamily="34" charset="0"/>
+                <a:ea typeface="Calibri" pitchFamily="34" charset="-122"/>
+                <a:cs typeface="Calibri" pitchFamily="34" charset="-120"/>
+              </a:rPr>
+              <a:t>‫אחזור מהענן איטי מאחזור מ-‪ECS‬ מקומי, ועלול לפגוע בשירות למשתמש הקצה.‬</a:t>
             </a:r>
             <a:endParaRPr lang="he-IL" sz="1250" dirty="0"/>
           </a:p>
@@ -10580,56 +10760,14 @@
       </p:sp>
       <p:sp>
         <p:nvSpPr>
-          <p:cNvPr id="32" name="Text 30"/>
-          <p:cNvSpPr/>
-          <p:nvPr/>
-        </p:nvSpPr>
-        <p:spPr>
-          <a:xfrm>
-            <a:off x="4730191" y="4462272"/>
-            <a:ext cx="2734056" cy="512064"/>
-          </a:xfrm>
-          <a:prstGeom prst="rect">
-            <a:avLst/>
-          </a:prstGeom>
-          <a:noFill/>
-          <a:ln/>
-        </p:spPr>
-        <p:txBody>
-          <a:bodyPr wrap="square" lIns="0" tIns="0" rIns="0" bIns="0" rtlCol="0" anchor="t"/>
-          <a:lstStyle/>
-          <a:p>
-            <a:pPr rtl="1" algn="r" indent="0" marL="0">
-              <a:lnSpc>
-                <a:spcPct val="116000"/>
-              </a:lnSpc>
-              <a:buNone/>
-            </a:pPr>
-            <a:r>
-              <a:rPr lang="he-IL" altLang="en-US" sz="1100" dirty="0">
-                <a:solidFill>
-                  <a:srgbClr val="F4F7FB"/>
-                </a:solidFill>
-                <a:latin typeface="Calibri" pitchFamily="34" charset="0"/>
-                <a:ea typeface="Calibri" pitchFamily="34" charset="-122"/>
-                <a:cs typeface="Calibri" pitchFamily="34" charset="-120"/>
-              </a:rPr>
-              <a:t>‫אחזור מהענן איטי מאחזור מ-‪ECS‬ מקומי. לטנציה בשליפה עלולה לפגוע בשירות למשתמש הקצה.‬</a:t>
-            </a:r>
-            <a:endParaRPr lang="he-IL" sz="1100" dirty="0"/>
-          </a:p>
-        </p:txBody>
-      </p:sp>
-      <p:sp>
-        <p:nvSpPr>
-          <p:cNvPr id="33" name="Shape 31"/>
-          <p:cNvSpPr/>
-          <p:nvPr/>
-        </p:nvSpPr>
-        <p:spPr>
-          <a:xfrm>
-            <a:off x="4730191" y="5010912"/>
-            <a:ext cx="2734056" cy="9144"/>
+          <p:cNvPr id="37" name="Shape 35"/>
+          <p:cNvSpPr/>
+          <p:nvPr/>
+        </p:nvSpPr>
+        <p:spPr>
+          <a:xfrm>
+            <a:off x="4730191" y="4974336"/>
+            <a:ext cx="2679192" cy="9144"/>
           </a:xfrm>
           <a:prstGeom prst="rect">
             <a:avLst/>
@@ -10647,14 +10785,14 @@
       </p:sp>
       <p:sp>
         <p:nvSpPr>
-          <p:cNvPr id="34" name="Text 32"/>
-          <p:cNvSpPr/>
-          <p:nvPr/>
-        </p:nvSpPr>
-        <p:spPr>
-          <a:xfrm>
-            <a:off x="4730191" y="5074920"/>
-            <a:ext cx="2734056" cy="658368"/>
+          <p:cNvPr id="38" name="Text 36"/>
+          <p:cNvSpPr/>
+          <p:nvPr/>
+        </p:nvSpPr>
+        <p:spPr>
+          <a:xfrm>
+            <a:off x="4730191" y="5047488"/>
+            <a:ext cx="2679192" cy="658368"/>
           </a:xfrm>
           <a:prstGeom prst="rect">
             <a:avLst/>
@@ -10668,12 +10806,12 @@
           <a:p>
             <a:pPr rtl="1" algn="r" indent="0" marL="0">
               <a:lnSpc>
-                <a:spcPct val="116000"/>
-              </a:lnSpc>
-              <a:buNone/>
-            </a:pPr>
-            <a:r>
-              <a:rPr lang="he-IL" altLang="en-US" sz="1050" dirty="0">
+                <a:spcPct val="120000"/>
+              </a:lnSpc>
+              <a:buNone/>
+            </a:pPr>
+            <a:r>
+              <a:rPr lang="he-IL" altLang="en-US" sz="1150" dirty="0">
                 <a:solidFill>
                   <a:srgbClr val="91A0B7"/>
                 </a:solidFill>
@@ -10681,30 +10819,30 @@
                 <a:ea typeface="Calibri" pitchFamily="34" charset="-122"/>
                 <a:cs typeface="Calibri" pitchFamily="34" charset="-120"/>
               </a:rPr>
-              <a:t>‫מיטיגציה: מדידת זמני אחזור מול ה-‪SLA‬ הקיים לפני התחייבות, חיבור ‪Direct Connect‬ ולא אינטרנט, וקאשינג מקומי לפריטים חמים.‬</a:t>
-            </a:r>
-            <a:endParaRPr lang="he-IL" sz="1050" dirty="0"/>
-          </a:p>
-        </p:txBody>
-      </p:sp>
-      <p:sp>
-        <p:nvSpPr>
-          <p:cNvPr id="35" name="Shape 33"/>
-          <p:cNvSpPr/>
-          <p:nvPr/>
-        </p:nvSpPr>
-        <p:spPr>
-          <a:xfrm>
-            <a:off x="825703" y="4023360"/>
-            <a:ext cx="3246120" cy="1773936"/>
+              <a:t>‫מיטיגציה: מדידת זמני אחזור מול ה-‪SLA‬ הקיים לפני התחייבות, חיבור ‪Direct Connect‬ ולא אינטרנט, וקאשינג לפריטים חמים.‬</a:t>
+            </a:r>
+            <a:endParaRPr lang="he-IL" sz="1150" dirty="0"/>
+          </a:p>
+        </p:txBody>
+      </p:sp>
+      <p:sp>
+        <p:nvSpPr>
+          <p:cNvPr id="39" name="Shape 37"/>
+          <p:cNvSpPr/>
+          <p:nvPr/>
+        </p:nvSpPr>
+        <p:spPr>
+          <a:xfrm>
+            <a:off x="825703" y="3986784"/>
+            <a:ext cx="3246120" cy="1810512"/>
           </a:xfrm>
           <a:prstGeom prst="roundRect">
             <a:avLst>
-              <a:gd name="adj" fmla="val 2577"/>
+              <a:gd name="adj" fmla="val 2525"/>
             </a:avLst>
           </a:prstGeom>
           <a:solidFill>
-            <a:srgbClr val="182133"/>
+            <a:srgbClr val="141C2C"/>
           </a:solidFill>
           <a:ln w="12700">
             <a:solidFill>
@@ -10716,14 +10854,14 @@
       </p:sp>
       <p:sp>
         <p:nvSpPr>
-          <p:cNvPr id="36" name="Shape 34"/>
-          <p:cNvSpPr/>
-          <p:nvPr/>
-        </p:nvSpPr>
-        <p:spPr>
-          <a:xfrm>
-            <a:off x="3651199" y="4242816"/>
-            <a:ext cx="118872" cy="118872"/>
+          <p:cNvPr id="40" name="Shape 38"/>
+          <p:cNvSpPr/>
+          <p:nvPr/>
+        </p:nvSpPr>
+        <p:spPr>
+          <a:xfrm>
+            <a:off x="4021531" y="4133088"/>
+            <a:ext cx="50292" cy="1517904"/>
           </a:xfrm>
           <a:prstGeom prst="rect">
             <a:avLst/>
@@ -10741,14 +10879,14 @@
       </p:sp>
       <p:sp>
         <p:nvSpPr>
-          <p:cNvPr id="37" name="Text 35"/>
-          <p:cNvSpPr/>
-          <p:nvPr/>
-        </p:nvSpPr>
-        <p:spPr>
-          <a:xfrm>
-            <a:off x="1081735" y="4169664"/>
-            <a:ext cx="2478024" cy="256032"/>
+          <p:cNvPr id="41" name="Text 39"/>
+          <p:cNvSpPr/>
+          <p:nvPr/>
+        </p:nvSpPr>
+        <p:spPr>
+          <a:xfrm>
+            <a:off x="2124151" y="4114800"/>
+            <a:ext cx="1618488" cy="310896"/>
           </a:xfrm>
           <a:prstGeom prst="rect">
             <a:avLst/>
@@ -10767,7 +10905,7 @@
               <a:buNone/>
             </a:pPr>
             <a:r>
-              <a:rPr lang="he-IL" altLang="en-US" sz="1250" b="1" dirty="0">
+              <a:rPr lang="he-IL" altLang="en-US" sz="1400" b="1" dirty="0">
                 <a:solidFill>
                   <a:srgbClr val="FF9F43"/>
                 </a:solidFill>
@@ -10777,62 +10915,62 @@
               </a:rPr>
               <a:t>‫כלי ההעברה · ‪POC‬‬</a:t>
             </a:r>
+            <a:endParaRPr lang="he-IL" sz="1400" dirty="0"/>
+          </a:p>
+        </p:txBody>
+      </p:sp>
+      <p:sp>
+        <p:nvSpPr>
+          <p:cNvPr id="42" name="Text 40"/>
+          <p:cNvSpPr/>
+          <p:nvPr/>
+        </p:nvSpPr>
+        <p:spPr>
+          <a:xfrm>
+            <a:off x="1081735" y="4480560"/>
+            <a:ext cx="2679192" cy="457200"/>
+          </a:xfrm>
+          <a:prstGeom prst="rect">
+            <a:avLst/>
+          </a:prstGeom>
+          <a:noFill/>
+          <a:ln/>
+        </p:spPr>
+        <p:txBody>
+          <a:bodyPr wrap="square" lIns="0" tIns="0" rIns="0" bIns="0" rtlCol="0" anchor="t"/>
+          <a:lstStyle/>
+          <a:p>
+            <a:pPr rtl="1" algn="r" indent="0" marL="0">
+              <a:lnSpc>
+                <a:spcPct val="120000"/>
+              </a:lnSpc>
+              <a:buNone/>
+            </a:pPr>
+            <a:r>
+              <a:rPr lang="he-IL" altLang="en-US" sz="1250" dirty="0">
+                <a:solidFill>
+                  <a:srgbClr val="F4F7FB"/>
+                </a:solidFill>
+                <a:latin typeface="Calibri" pitchFamily="34" charset="0"/>
+                <a:ea typeface="Calibri" pitchFamily="34" charset="-122"/>
+                <a:cs typeface="Calibri" pitchFamily="34" charset="-120"/>
+              </a:rPr>
+              <a:t>‫אין כלי העתקה מוכח בסדר גודל כזה; קבצים עלולים להיכשל בלי שהדבר יתגלה.‬</a:t>
+            </a:r>
             <a:endParaRPr lang="he-IL" sz="1250" dirty="0"/>
           </a:p>
         </p:txBody>
       </p:sp>
       <p:sp>
         <p:nvSpPr>
-          <p:cNvPr id="38" name="Text 36"/>
-          <p:cNvSpPr/>
-          <p:nvPr/>
-        </p:nvSpPr>
-        <p:spPr>
-          <a:xfrm>
-            <a:off x="1081735" y="4462272"/>
-            <a:ext cx="2734056" cy="512064"/>
-          </a:xfrm>
-          <a:prstGeom prst="rect">
-            <a:avLst/>
-          </a:prstGeom>
-          <a:noFill/>
-          <a:ln/>
-        </p:spPr>
-        <p:txBody>
-          <a:bodyPr wrap="square" lIns="0" tIns="0" rIns="0" bIns="0" rtlCol="0" anchor="t"/>
-          <a:lstStyle/>
-          <a:p>
-            <a:pPr rtl="1" algn="r" indent="0" marL="0">
-              <a:lnSpc>
-                <a:spcPct val="116000"/>
-              </a:lnSpc>
-              <a:buNone/>
-            </a:pPr>
-            <a:r>
-              <a:rPr lang="he-IL" altLang="en-US" sz="1100" dirty="0">
-                <a:solidFill>
-                  <a:srgbClr val="F4F7FB"/>
-                </a:solidFill>
-                <a:latin typeface="Calibri" pitchFamily="34" charset="0"/>
-                <a:ea typeface="Calibri" pitchFamily="34" charset="-122"/>
-                <a:cs typeface="Calibri" pitchFamily="34" charset="-120"/>
-              </a:rPr>
-              <a:t>‫אין כלי העתקה מוכח בסדר גודל כזה; קבצים עלולים להיכשל בהעברה בלי שהדבר יתגלה.‬</a:t>
-            </a:r>
-            <a:endParaRPr lang="he-IL" sz="1100" dirty="0"/>
-          </a:p>
-        </p:txBody>
-      </p:sp>
-      <p:sp>
-        <p:nvSpPr>
-          <p:cNvPr id="39" name="Shape 37"/>
-          <p:cNvSpPr/>
-          <p:nvPr/>
-        </p:nvSpPr>
-        <p:spPr>
-          <a:xfrm>
-            <a:off x="1081735" y="5010912"/>
-            <a:ext cx="2734056" cy="9144"/>
+          <p:cNvPr id="43" name="Shape 41"/>
+          <p:cNvSpPr/>
+          <p:nvPr/>
+        </p:nvSpPr>
+        <p:spPr>
+          <a:xfrm>
+            <a:off x="1081735" y="4974336"/>
+            <a:ext cx="2679192" cy="9144"/>
           </a:xfrm>
           <a:prstGeom prst="rect">
             <a:avLst/>
@@ -10850,14 +10988,14 @@
       </p:sp>
       <p:sp>
         <p:nvSpPr>
-          <p:cNvPr id="40" name="Text 38"/>
-          <p:cNvSpPr/>
-          <p:nvPr/>
-        </p:nvSpPr>
-        <p:spPr>
-          <a:xfrm>
-            <a:off x="1081735" y="5074920"/>
-            <a:ext cx="2734056" cy="658368"/>
+          <p:cNvPr id="44" name="Text 42"/>
+          <p:cNvSpPr/>
+          <p:nvPr/>
+        </p:nvSpPr>
+        <p:spPr>
+          <a:xfrm>
+            <a:off x="1081735" y="5047488"/>
+            <a:ext cx="2679192" cy="658368"/>
           </a:xfrm>
           <a:prstGeom prst="rect">
             <a:avLst/>
@@ -10871,12 +11009,12 @@
           <a:p>
             <a:pPr rtl="1" algn="r" indent="0" marL="0">
               <a:lnSpc>
-                <a:spcPct val="116000"/>
-              </a:lnSpc>
-              <a:buNone/>
-            </a:pPr>
-            <a:r>
-              <a:rPr lang="he-IL" altLang="en-US" sz="1050" dirty="0">
+                <a:spcPct val="120000"/>
+              </a:lnSpc>
+              <a:buNone/>
+            </a:pPr>
+            <a:r>
+              <a:rPr lang="he-IL" altLang="en-US" sz="1150" dirty="0">
                 <a:solidFill>
                   <a:srgbClr val="91A0B7"/>
                 </a:solidFill>
@@ -10884,15 +11022,15 @@
                 <a:ea typeface="Calibri" pitchFamily="34" charset="-122"/>
                 <a:cs typeface="Calibri" pitchFamily="34" charset="-120"/>
               </a:rPr>
-              <a:t>‫מיטיגציה: ‪POC‬ קצר על ‪1–2 TB‬ עם ‪AWS DataSync‬: ולידציה מובנית, דוח חריגים לכל ריצה, ומחיקה מ-‪ECS‬ רק לאחר אימות מלא.‬</a:t>
-            </a:r>
-            <a:endParaRPr lang="he-IL" sz="1050" dirty="0"/>
-          </a:p>
-        </p:txBody>
-      </p:sp>
-      <p:sp>
-        <p:nvSpPr>
-          <p:cNvPr id="41" name="Shape 39"/>
+              <a:t>‫מיטיגציה: ‪POC‬ קצר על ‪1–2 TB‬ עם ‪AWS DataSync‬: ולידציה מובנית, דוח חריגים לכל ריצה, ומחיקה מ-‪ECS‬ רק לאחר אימות.‬</a:t>
+            </a:r>
+            <a:endParaRPr lang="he-IL" sz="1150" dirty="0"/>
+          </a:p>
+        </p:txBody>
+      </p:sp>
+      <p:sp>
+        <p:nvSpPr>
+          <p:cNvPr id="45" name="Shape 43"/>
           <p:cNvSpPr/>
           <p:nvPr/>
         </p:nvSpPr>
@@ -10917,7 +11055,7 @@
       </p:sp>
       <p:sp>
         <p:nvSpPr>
-          <p:cNvPr id="42" name="Shape 40"/>
+          <p:cNvPr id="46" name="Shape 44"/>
           <p:cNvSpPr/>
           <p:nvPr/>
         </p:nvSpPr>
@@ -10942,7 +11080,7 @@
       </p:sp>
       <p:sp>
         <p:nvSpPr>
-          <p:cNvPr id="43" name="Text 41"/>
+          <p:cNvPr id="47" name="Text 45"/>
           <p:cNvSpPr/>
           <p:nvPr/>
         </p:nvSpPr>
@@ -10976,7 +11114,7 @@
                 <a:ea typeface="Calibri" pitchFamily="34" charset="-122"/>
                 <a:cs typeface="Calibri" pitchFamily="34" charset="-120"/>
               </a:rPr>
-              <a:t>‫שני הסיכונים באדום חוסמים התחלה: בלי אישור הלשכה המשפטית ובלי אישור ‪DPO‬ ורגולטור אין העתקה ראשונה. ארבעת הכתומים נסגרים ב-‪POC‬ ובאפיון מול צוותי האפליקציה.‬</a:t>
+              <a:t>‫שני הסיכונים המסומנים "חוסם התחלה" אינם ניתנים לעקיפה: בלי אישור הלשכה המשפטית ובלי אישור ‪DPO‬ ורגולטור אין העתקה ראשונה. ארבעת הנותרים נסגרים ב-‪POC‬ ובאפיון מול צוותי האפליקציה.‬</a:t>
             </a:r>
             <a:endParaRPr lang="he-IL" sz="1150" dirty="0"/>
           </a:p>

</xml_diff>